<commit_message>
feat(course): raise research judgment across 16 lessons within homework budget
</commit_message>
<xml_diff>
--- a/lessons/lesson-15/slides.pptx
+++ b/lessons/lesson-15/slides.pptx
@@ -412,7 +412,7 @@
           </a:p>
           <a:p xmlns:a="http://schemas.openxmlformats.org/drawingml/2006/main">
             <a:r>
-              <a:t>讲义位置：本课讲义；见逐页母稿映射表</a:t>
+              <a:t>讲述与校准：</a:t>
             </a:r>
           </a:p>
           <a:p xmlns:a="http://schemas.openxmlformats.org/drawingml/2006/main">
@@ -422,27 +422,17 @@
           </a:p>
           <a:p xmlns:a="http://schemas.openxmlformats.org/drawingml/2006/main">
             <a:r>
-              <a:t>屏显核对：</a:t>
-            </a:r>
-          </a:p>
-          <a:p xmlns:a="http://schemas.openxmlformats.org/drawingml/2006/main">
-            <a:r>
-              <a:t>第15讲 同行评审、论证门预检与修改工作坊</a:t>
-            </a:r>
-          </a:p>
-          <a:p xmlns:a="http://schemas.openxmlformats.org/drawingml/2006/main">
-            <a:r>
               <a:t/>
             </a:r>
           </a:p>
           <a:p xmlns:a="http://schemas.openxmlformats.org/drawingml/2006/main">
             <a:r>
-              <a:t>教师讲述：</a:t>
-            </a:r>
-          </a:p>
-          <a:p xmlns:a="http://schemas.openxmlformats.org/drawingml/2006/main">
-            <a:r>
-              <a:t>学生打开第 14 课 `report.md` 初版。本课不新增正式提交。</a:t>
+              <a:t>学生动作：</a:t>
+            </a:r>
+          </a:p>
+          <a:p xmlns:a="http://schemas.openxmlformats.org/drawingml/2006/main">
+            <a:r>
+              <a:t>依据本页方法检查本人项目；按需参考。</a:t>
             </a:r>
           </a:p>
           <a:p xmlns:a="http://schemas.openxmlformats.org/drawingml/2006/main">
@@ -452,7 +442,7 @@
           </a:p>
           <a:p xmlns:a="http://schemas.openxmlformats.org/drawingml/2006/main">
             <a:r>
-              <a:t>学生动作：</a:t>
+              <a:t>课堂安排：按 teaching-plan.md 专用课堂时段安排；换场计入对应时段。</a:t>
             </a:r>
           </a:p>
           <a:p xmlns:a="http://schemas.openxmlformats.org/drawingml/2006/main">
@@ -462,52 +452,12 @@
           </a:p>
           <a:p xmlns:a="http://schemas.openxmlformats.org/drawingml/2006/main">
             <a:r>
-              <a:t/>
-            </a:r>
-          </a:p>
-          <a:p xmlns:a="http://schemas.openxmlformats.org/drawingml/2006/main">
-            <a:r>
-              <a:t>来源与边界：</a:t>
-            </a:r>
-          </a:p>
-          <a:p xmlns:a="http://schemas.openxmlformats.org/drawingml/2006/main">
-            <a:r>
-              <a:t>讲义导读；assignments.md 第 15 课。</a:t>
-            </a:r>
-          </a:p>
-          <a:p xmlns:a="http://schemas.openxmlformats.org/drawingml/2006/main">
-            <a:r>
-              <a:t/>
-            </a:r>
-          </a:p>
-          <a:p xmlns:a="http://schemas.openxmlformats.org/drawingml/2006/main">
-            <a:r>
               <a:t>[Sources]</a:t>
             </a:r>
           </a:p>
           <a:p xmlns:a="http://schemas.openxmlformats.org/drawingml/2006/main">
             <a:r>
-              <a:t/>
-            </a:r>
-          </a:p>
-          <a:p xmlns:a="http://schemas.openxmlformats.org/drawingml/2006/main">
-            <a:r>
-              <a:t>- 本课 handout.md 与 slides.md</a:t>
-            </a:r>
-          </a:p>
-          <a:p xmlns:a="http://schemas.openxmlformats.org/drawingml/2006/main">
-            <a:r>
-              <a:t/>
-            </a:r>
-          </a:p>
-          <a:p xmlns:a="http://schemas.openxmlformats.org/drawingml/2006/main">
-            <a:r>
-              <a:t>- ../../course/reading-card-case.md</a:t>
-            </a:r>
-          </a:p>
-          <a:p xmlns:a="http://schemas.openxmlformats.org/drawingml/2006/main">
-            <a:r>
-              <a:t/>
+              <a:t>本课 handout.md、judgment-task.md；../../course/judgment-path.md。</a:t>
             </a:r>
           </a:p>
           <a:p xmlns:a="http://schemas.openxmlformats.org/drawingml/2006/main">
@@ -582,7 +532,7 @@
           <a:lstStyle xmlns:a="http://schemas.openxmlformats.org/drawingml/2006/main"/>
           <a:p xmlns:a="http://schemas.openxmlformats.org/drawingml/2006/main">
             <a:r>
-              <a:t>页面：P10 现在修改最可能卡门的一项</a:t>
+              <a:t>页面：P10 本人项目：决定、核验与回写</a:t>
             </a:r>
           </a:p>
           <a:p xmlns:a="http://schemas.openxmlformats.org/drawingml/2006/main">
@@ -592,7 +542,12 @@
           </a:p>
           <a:p xmlns:a="http://schemas.openxmlformats.org/drawingml/2006/main">
             <a:r>
-              <a:t>讲义位置：本课讲义；见逐页母稿映射表</a:t>
+              <a:t>讲述与校准：</a:t>
+            </a:r>
+          </a:p>
+          <a:p xmlns:a="http://schemas.openxmlformats.org/drawingml/2006/main">
+            <a:r>
+              <a:t>A 同时涉及单位事实和效度，应优先实际修订；B 为次级表达问题；C 忽略了确定性回放，可用方法与版本证据澄清。保留异议需要定位事实，不能以“时间不够”反驳实质错误。 按本课专用90分钟流程进行，不套用普通课时间。</a:t>
             </a:r>
           </a:p>
           <a:p xmlns:a="http://schemas.openxmlformats.org/drawingml/2006/main">
@@ -602,12 +557,12 @@
           </a:p>
           <a:p xmlns:a="http://schemas.openxmlformats.org/drawingml/2006/main">
             <a:r>
-              <a:t>屏显核对：</a:t>
-            </a:r>
-          </a:p>
-          <a:p xmlns:a="http://schemas.openxmlformats.org/drawingml/2006/main">
-            <a:r>
-              <a:t>课程虚构稿件的实际文本修改示范</a:t>
+              <a:t>学生动作：</a:t>
+            </a:r>
+          </a:p>
+          <a:p xmlns:a="http://schemas.openxmlformats.org/drawingml/2006/main">
+            <a:r>
+              <a:t>保留两轮真实互评和现场修改。作者对意见接受、澄清、补证、保留异议或暂缓，至少完成一项影响论证的实际修订。</a:t>
             </a:r>
           </a:p>
           <a:p xmlns:a="http://schemas.openxmlformats.org/drawingml/2006/main">
@@ -617,7 +572,7 @@
           </a:p>
           <a:p xmlns:a="http://schemas.openxmlformats.org/drawingml/2006/main">
             <a:r>
-              <a:t>− 阅读卡机制已证实，状态 stable。</a:t>
+              <a:t>课堂安排：按 teaching-plan.md 专用课堂时段安排；换场计入对应时段。</a:t>
             </a:r>
           </a:p>
           <a:p xmlns:a="http://schemas.openxmlformats.org/drawingml/2006/main">
@@ -627,107 +582,12 @@
           </a:p>
           <a:p xmlns:a="http://schemas.openxmlformats.org/drawingml/2006/main">
             <a:r>
-              <a:t>+ 本教学构造包中阅读卡组总遗漏率较低，方向与 Q1 一致，H1 机制未决。</a:t>
-            </a:r>
-          </a:p>
-          <a:p xmlns:a="http://schemas.openxmlformats.org/drawingml/2006/main">
-            <a:r>
-              <a:t/>
-            </a:r>
-          </a:p>
-          <a:p xmlns:a="http://schemas.openxmlformats.org/drawingml/2006/main">
-            <a:r>
-              <a:t>+ H1/A2 尚未区分，A1 质量代价未评价，A3 范围受限；工件：review；机制判断：仍不能判断。</a:t>
-            </a:r>
-          </a:p>
-          <a:p xmlns:a="http://schemas.openxmlformats.org/drawingml/2006/main">
-            <a:r>
-              <a:t/>
-            </a:r>
-          </a:p>
-          <a:p xmlns:a="http://schemas.openxmlformats.org/drawingml/2006/main">
-            <a:r>
-              <a:t>优先：致命 → 重要 → 表达。改实际文件，保存 diff，更新影响工件。</a:t>
-            </a:r>
-          </a:p>
-          <a:p xmlns:a="http://schemas.openxmlformats.org/drawingml/2006/main">
-            <a:r>
-              <a:t/>
-            </a:r>
-          </a:p>
-          <a:p xmlns:a="http://schemas.openxmlformats.org/drawingml/2006/main">
-            <a:r>
-              <a:t>教师讲述：</a:t>
-            </a:r>
-          </a:p>
-          <a:p xmlns:a="http://schemas.openxmlformats.org/drawingml/2006/main">
-            <a:r>
-              <a:t>实践停留页。普通技术失败进入修复与复盘，不自动视为学术不端。</a:t>
-            </a:r>
-          </a:p>
-          <a:p xmlns:a="http://schemas.openxmlformats.org/drawingml/2006/main">
-            <a:r>
-              <a:t/>
-            </a:r>
-          </a:p>
-          <a:p xmlns:a="http://schemas.openxmlformats.org/drawingml/2006/main">
-            <a:r>
-              <a:t>学生动作：</a:t>
-            </a:r>
-          </a:p>
-          <a:p xmlns:a="http://schemas.openxmlformats.org/drawingml/2006/main">
-            <a:r>
-              <a:t/>
-            </a:r>
-          </a:p>
-          <a:p xmlns:a="http://schemas.openxmlformats.org/drawingml/2006/main">
-            <a:r>
-              <a:t/>
-            </a:r>
-          </a:p>
-          <a:p xmlns:a="http://schemas.openxmlformats.org/drawingml/2006/main">
-            <a:r>
-              <a:t>来源与边界：</a:t>
-            </a:r>
-          </a:p>
-          <a:p xmlns:a="http://schemas.openxmlformats.org/drawingml/2006/main">
-            <a:r>
-              <a:t>讲义 §四—五；assessment.md 学术规范。</a:t>
-            </a:r>
-          </a:p>
-          <a:p xmlns:a="http://schemas.openxmlformats.org/drawingml/2006/main">
-            <a:r>
-              <a:t/>
-            </a:r>
-          </a:p>
-          <a:p xmlns:a="http://schemas.openxmlformats.org/drawingml/2006/main">
-            <a:r>
               <a:t>[Sources]</a:t>
             </a:r>
           </a:p>
           <a:p xmlns:a="http://schemas.openxmlformats.org/drawingml/2006/main">
             <a:r>
-              <a:t/>
-            </a:r>
-          </a:p>
-          <a:p xmlns:a="http://schemas.openxmlformats.org/drawingml/2006/main">
-            <a:r>
-              <a:t>- 本课 handout.md 与 slides.md</a:t>
-            </a:r>
-          </a:p>
-          <a:p xmlns:a="http://schemas.openxmlformats.org/drawingml/2006/main">
-            <a:r>
-              <a:t/>
-            </a:r>
-          </a:p>
-          <a:p xmlns:a="http://schemas.openxmlformats.org/drawingml/2006/main">
-            <a:r>
-              <a:t>- ../../course/reading-card-case.md</a:t>
-            </a:r>
-          </a:p>
-          <a:p xmlns:a="http://schemas.openxmlformats.org/drawingml/2006/main">
-            <a:r>
-              <a:t/>
+              <a:t>本课 handout.md、judgment-task.md；../../course/judgment-path.md。教学构造仅用于方法判断；本人结果以实际记录为准。</a:t>
             </a:r>
           </a:p>
           <a:p xmlns:a="http://schemas.openxmlformats.org/drawingml/2006/main">
@@ -812,7 +672,12 @@
           </a:p>
           <a:p xmlns:a="http://schemas.openxmlformats.org/drawingml/2006/main">
             <a:r>
-              <a:t>讲义位置：handout.md §七、贯穿案例：从第 14 课初稿到同行评审</a:t>
+              <a:t>讲述与校准：</a:t>
+            </a:r>
+          </a:p>
+          <a:p xmlns:a="http://schemas.openxmlformats.org/drawingml/2006/main">
+            <a:r>
+              <a:t>不要把“机制已证明”简单改成“支持待验证”。证据没有回答机制时，状态应为不能判断；工件成熟度另行检查。修改动作需落到文件并形成diff。</a:t>
             </a:r>
           </a:p>
           <a:p xmlns:a="http://schemas.openxmlformats.org/drawingml/2006/main">
@@ -822,27 +687,12 @@
           </a:p>
           <a:p xmlns:a="http://schemas.openxmlformats.org/drawingml/2006/main">
             <a:r>
-              <a:t>屏显核对：</a:t>
-            </a:r>
-          </a:p>
-          <a:p xmlns:a="http://schemas.openxmlformats.org/drawingml/2006/main">
-            <a:r>
-              <a:t>Q1：在构造包中方向一致。</a:t>
-            </a:r>
-          </a:p>
-          <a:p xmlns:a="http://schemas.openxmlformats.org/drawingml/2006/main">
-            <a:r>
-              <a:t>H1/A2：仍不能区分。</a:t>
-            </a:r>
-          </a:p>
-          <a:p xmlns:a="http://schemas.openxmlformats.org/drawingml/2006/main">
-            <a:r>
-              <a:t>其他质量：尚未测量。</a:t>
-            </a:r>
-          </a:p>
-          <a:p xmlns:a="http://schemas.openxmlformats.org/drawingml/2006/main">
-            <a:r>
-              <a:t>范围：保留T03负例，撤回“所有文本”。</a:t>
+              <a:t>学生动作：</a:t>
+            </a:r>
+          </a:p>
+          <a:p xmlns:a="http://schemas.openxmlformats.org/drawingml/2006/main">
+            <a:r>
+              <a:t>核对一条作者回应是否已经改变正文与追踪记录。</a:t>
             </a:r>
           </a:p>
           <a:p xmlns:a="http://schemas.openxmlformats.org/drawingml/2006/main">
@@ -852,7 +702,7 @@
           </a:p>
           <a:p xmlns:a="http://schemas.openxmlformats.org/drawingml/2006/main">
             <a:r>
-              <a:t>修改正文，再更新追踪状态。</a:t>
+              <a:t>课堂安排：按 teaching-plan.md 专用课堂时段安排；换场计入对应时段。</a:t>
             </a:r>
           </a:p>
           <a:p xmlns:a="http://schemas.openxmlformats.org/drawingml/2006/main">
@@ -862,12 +712,12 @@
           </a:p>
           <a:p xmlns:a="http://schemas.openxmlformats.org/drawingml/2006/main">
             <a:r>
-              <a:t>教师讲述：</a:t>
-            </a:r>
-          </a:p>
-          <a:p xmlns:a="http://schemas.openxmlformats.org/drawingml/2006/main">
-            <a:r>
-              <a:t>不要把“机制已证明”简单改成“支持待验证”。证据没有回答机制时，状态应为不能判断；工件成熟度另行检查。修改动作需落到文件并形成diff。</a:t>
+              <a:t>[Sources]</a:t>
+            </a:r>
+          </a:p>
+          <a:p xmlns:a="http://schemas.openxmlformats.org/drawingml/2006/main">
+            <a:r>
+              <a:t>./handout.md；课堂示例与构造数据见 ../../course/reading-card-case.md</a:t>
             </a:r>
           </a:p>
           <a:p xmlns:a="http://schemas.openxmlformats.org/drawingml/2006/main">
@@ -877,62 +727,7 @@
           </a:p>
           <a:p xmlns:a="http://schemas.openxmlformats.org/drawingml/2006/main">
             <a:r>
-              <a:t>学生动作：</a:t>
-            </a:r>
-          </a:p>
-          <a:p xmlns:a="http://schemas.openxmlformats.org/drawingml/2006/main">
-            <a:r>
-              <a:t>核对一条作者回应是否已经改变正文与追踪记录。</a:t>
-            </a:r>
-          </a:p>
-          <a:p xmlns:a="http://schemas.openxmlformats.org/drawingml/2006/main">
-            <a:r>
-              <a:t/>
-            </a:r>
-          </a:p>
-          <a:p xmlns:a="http://schemas.openxmlformats.org/drawingml/2006/main">
-            <a:r>
-              <a:t>来源与边界：</a:t>
-            </a:r>
-          </a:p>
-          <a:p xmlns:a="http://schemas.openxmlformats.org/drawingml/2006/main">
-            <a:r>
-              <a:t>./handout.md；课堂示例与构造数据见 ../../course/reading-card-case.md</a:t>
-            </a:r>
-          </a:p>
-          <a:p xmlns:a="http://schemas.openxmlformats.org/drawingml/2006/main">
-            <a:r>
-              <a:t/>
-            </a:r>
-          </a:p>
-          <a:p xmlns:a="http://schemas.openxmlformats.org/drawingml/2006/main">
-            <a:r>
-              <a:t>[Sources]</a:t>
-            </a:r>
-          </a:p>
-          <a:p xmlns:a="http://schemas.openxmlformats.org/drawingml/2006/main">
-            <a:r>
-              <a:t/>
-            </a:r>
-          </a:p>
-          <a:p xmlns:a="http://schemas.openxmlformats.org/drawingml/2006/main">
-            <a:r>
-              <a:t>- 本课 handout.md 与 slides.md</a:t>
-            </a:r>
-          </a:p>
-          <a:p xmlns:a="http://schemas.openxmlformats.org/drawingml/2006/main">
-            <a:r>
-              <a:t/>
-            </a:r>
-          </a:p>
-          <a:p xmlns:a="http://schemas.openxmlformats.org/drawingml/2006/main">
-            <a:r>
-              <a:t>- ../../course/reading-card-case.md</a:t>
-            </a:r>
-          </a:p>
-          <a:p xmlns:a="http://schemas.openxmlformats.org/drawingml/2006/main">
-            <a:r>
-              <a:t/>
+              <a:t>本课 handout.md、judgment-task.md；../../course/judgment-path.md。</a:t>
             </a:r>
           </a:p>
           <a:p xmlns:a="http://schemas.openxmlformats.org/drawingml/2006/main">
@@ -1017,7 +812,7 @@
           </a:p>
           <a:p xmlns:a="http://schemas.openxmlformats.org/drawingml/2006/main">
             <a:r>
-              <a:t>讲义位置：本课讲义；见逐页母稿映射表</a:t>
+              <a:t>讲述与校准：</a:t>
             </a:r>
           </a:p>
           <a:p xmlns:a="http://schemas.openxmlformats.org/drawingml/2006/main">
@@ -1027,22 +822,17 @@
           </a:p>
           <a:p xmlns:a="http://schemas.openxmlformats.org/drawingml/2006/main">
             <a:r>
-              <a:t>屏显核对：</a:t>
-            </a:r>
-          </a:p>
-          <a:p xmlns:a="http://schemas.openxmlformats.org/drawingml/2006/main">
-            <a:r>
-              <a:t>从当前稿件选一项：第二项高优先级修改／证据定位／结论降级与边界／AI 与伦理披露。</a:t>
-            </a:r>
-          </a:p>
-          <a:p xmlns:a="http://schemas.openxmlformats.org/drawingml/2006/main">
-            <a:r>
               <a:t/>
             </a:r>
           </a:p>
           <a:p xmlns:a="http://schemas.openxmlformats.org/drawingml/2006/main">
             <a:r>
-              <a:t>保存到相应项目文件。</a:t>
+              <a:t>学生动作：</a:t>
+            </a:r>
+          </a:p>
+          <a:p xmlns:a="http://schemas.openxmlformats.org/drawingml/2006/main">
+            <a:r>
+              <a:t>依据本页方法检查本人项目；按需参考。</a:t>
             </a:r>
           </a:p>
           <a:p xmlns:a="http://schemas.openxmlformats.org/drawingml/2006/main">
@@ -1052,7 +842,7 @@
           </a:p>
           <a:p xmlns:a="http://schemas.openxmlformats.org/drawingml/2006/main">
             <a:r>
-              <a:t>完成样例（课程构造）：未能补做对照 → 暂缓机制结论 → 记录缺口和复核点。</a:t>
+              <a:t>课堂安排：按 teaching-plan.md 专用课堂时段安排；换场计入对应时段。</a:t>
             </a:r>
           </a:p>
           <a:p xmlns:a="http://schemas.openxmlformats.org/drawingml/2006/main">
@@ -1062,87 +852,12 @@
           </a:p>
           <a:p xmlns:a="http://schemas.openxmlformats.org/drawingml/2006/main">
             <a:r>
-              <a:t>完成标志：文件已保存，剩余风险可定位。</a:t>
-            </a:r>
-          </a:p>
-          <a:p xmlns:a="http://schemas.openxmlformats.org/drawingml/2006/main">
-            <a:r>
-              <a:t/>
-            </a:r>
-          </a:p>
-          <a:p xmlns:a="http://schemas.openxmlformats.org/drawingml/2006/main">
-            <a:r>
-              <a:t>教师讲述：</a:t>
-            </a:r>
-          </a:p>
-          <a:p xmlns:a="http://schemas.openxmlformats.org/drawingml/2006/main">
-            <a:r>
-              <a:t>实践停留页。结束时检查文件已保存。</a:t>
-            </a:r>
-          </a:p>
-          <a:p xmlns:a="http://schemas.openxmlformats.org/drawingml/2006/main">
-            <a:r>
-              <a:t/>
-            </a:r>
-          </a:p>
-          <a:p xmlns:a="http://schemas.openxmlformats.org/drawingml/2006/main">
-            <a:r>
-              <a:t>学生动作：</a:t>
-            </a:r>
-          </a:p>
-          <a:p xmlns:a="http://schemas.openxmlformats.org/drawingml/2006/main">
-            <a:r>
-              <a:t/>
-            </a:r>
-          </a:p>
-          <a:p xmlns:a="http://schemas.openxmlformats.org/drawingml/2006/main">
-            <a:r>
-              <a:t/>
-            </a:r>
-          </a:p>
-          <a:p xmlns:a="http://schemas.openxmlformats.org/drawingml/2006/main">
-            <a:r>
-              <a:t>来源与边界：</a:t>
-            </a:r>
-          </a:p>
-          <a:p xmlns:a="http://schemas.openxmlformats.org/drawingml/2006/main">
-            <a:r>
-              <a:t>讲义 §五—六。</a:t>
-            </a:r>
-          </a:p>
-          <a:p xmlns:a="http://schemas.openxmlformats.org/drawingml/2006/main">
-            <a:r>
-              <a:t/>
-            </a:r>
-          </a:p>
-          <a:p xmlns:a="http://schemas.openxmlformats.org/drawingml/2006/main">
-            <a:r>
               <a:t>[Sources]</a:t>
             </a:r>
           </a:p>
           <a:p xmlns:a="http://schemas.openxmlformats.org/drawingml/2006/main">
             <a:r>
-              <a:t/>
-            </a:r>
-          </a:p>
-          <a:p xmlns:a="http://schemas.openxmlformats.org/drawingml/2006/main">
-            <a:r>
-              <a:t>- 本课 handout.md 与 slides.md</a:t>
-            </a:r>
-          </a:p>
-          <a:p xmlns:a="http://schemas.openxmlformats.org/drawingml/2006/main">
-            <a:r>
-              <a:t/>
-            </a:r>
-          </a:p>
-          <a:p xmlns:a="http://schemas.openxmlformats.org/drawingml/2006/main">
-            <a:r>
-              <a:t>- ../../course/reading-card-case.md</a:t>
-            </a:r>
-          </a:p>
-          <a:p xmlns:a="http://schemas.openxmlformats.org/drawingml/2006/main">
-            <a:r>
-              <a:t/>
+              <a:t>本课 handout.md、judgment-task.md；../../course/judgment-path.md。</a:t>
             </a:r>
           </a:p>
           <a:p xmlns:a="http://schemas.openxmlformats.org/drawingml/2006/main">
@@ -1227,7 +942,7 @@
           </a:p>
           <a:p xmlns:a="http://schemas.openxmlformats.org/drawingml/2006/main">
             <a:r>
-              <a:t>讲义位置：本课讲义；见逐页母稿映射表</a:t>
+              <a:t>讲述与校准：</a:t>
             </a:r>
           </a:p>
           <a:p xmlns:a="http://schemas.openxmlformats.org/drawingml/2006/main">
@@ -1237,22 +952,17 @@
           </a:p>
           <a:p xmlns:a="http://schemas.openxmlformats.org/drawingml/2006/main">
             <a:r>
-              <a:t>屏显核对：</a:t>
-            </a:r>
-          </a:p>
-          <a:p xmlns:a="http://schemas.openxmlformats.org/drawingml/2006/main">
-            <a:r>
-              <a:t>只标：已满足／部分满足／未覆盖。</a:t>
-            </a:r>
-          </a:p>
-          <a:p xmlns:a="http://schemas.openxmlformats.org/drawingml/2006/main">
-            <a:r>
               <a:t/>
             </a:r>
           </a:p>
           <a:p xmlns:a="http://schemas.openxmlformats.org/drawingml/2006/main">
             <a:r>
-              <a:t>关键结论可追溯；stable 符合证据条件；工作流含运行、权限、评价与失败；伦理、许可、贡献与 AI 完整；工件状态与门检一致。</a:t>
+              <a:t>学生动作：</a:t>
+            </a:r>
+          </a:p>
+          <a:p xmlns:a="http://schemas.openxmlformats.org/drawingml/2006/main">
+            <a:r>
+              <a:t>依据本页方法检查本人项目；按需参考。</a:t>
             </a:r>
           </a:p>
           <a:p xmlns:a="http://schemas.openxmlformats.org/drawingml/2006/main">
@@ -1262,7 +972,7 @@
           </a:p>
           <a:p xmlns:a="http://schemas.openxmlformats.org/drawingml/2006/main">
             <a:r>
-              <a:t>把剩余缺口写入 revision-plan.md。</a:t>
+              <a:t>课堂安排：按 teaching-plan.md 专用课堂时段安排；换场计入对应时段。</a:t>
             </a:r>
           </a:p>
           <a:p xmlns:a="http://schemas.openxmlformats.org/drawingml/2006/main">
@@ -1272,77 +982,12 @@
           </a:p>
           <a:p xmlns:a="http://schemas.openxmlformats.org/drawingml/2006/main">
             <a:r>
-              <a:t>教师讲述：</a:t>
-            </a:r>
-          </a:p>
-          <a:p xmlns:a="http://schemas.openxmlformats.org/drawingml/2006/main">
-            <a:r>
-              <a:t>本课完成主要预检，不要求在课堂假装全部通过。</a:t>
-            </a:r>
-          </a:p>
-          <a:p xmlns:a="http://schemas.openxmlformats.org/drawingml/2006/main">
-            <a:r>
-              <a:t/>
-            </a:r>
-          </a:p>
-          <a:p xmlns:a="http://schemas.openxmlformats.org/drawingml/2006/main">
-            <a:r>
-              <a:t>学生动作：</a:t>
-            </a:r>
-          </a:p>
-          <a:p xmlns:a="http://schemas.openxmlformats.org/drawingml/2006/main">
-            <a:r>
-              <a:t/>
-            </a:r>
-          </a:p>
-          <a:p xmlns:a="http://schemas.openxmlformats.org/drawingml/2006/main">
-            <a:r>
-              <a:t/>
-            </a:r>
-          </a:p>
-          <a:p xmlns:a="http://schemas.openxmlformats.org/drawingml/2006/main">
-            <a:r>
-              <a:t>来源与边界：</a:t>
-            </a:r>
-          </a:p>
-          <a:p xmlns:a="http://schemas.openxmlformats.org/drawingml/2006/main">
-            <a:r>
-              <a:t>assignments.md Checkpoint 4；讲义 §六。</a:t>
-            </a:r>
-          </a:p>
-          <a:p xmlns:a="http://schemas.openxmlformats.org/drawingml/2006/main">
-            <a:r>
-              <a:t/>
-            </a:r>
-          </a:p>
-          <a:p xmlns:a="http://schemas.openxmlformats.org/drawingml/2006/main">
-            <a:r>
               <a:t>[Sources]</a:t>
             </a:r>
           </a:p>
           <a:p xmlns:a="http://schemas.openxmlformats.org/drawingml/2006/main">
             <a:r>
-              <a:t/>
-            </a:r>
-          </a:p>
-          <a:p xmlns:a="http://schemas.openxmlformats.org/drawingml/2006/main">
-            <a:r>
-              <a:t>- 本课 handout.md 与 slides.md</a:t>
-            </a:r>
-          </a:p>
-          <a:p xmlns:a="http://schemas.openxmlformats.org/drawingml/2006/main">
-            <a:r>
-              <a:t/>
-            </a:r>
-          </a:p>
-          <a:p xmlns:a="http://schemas.openxmlformats.org/drawingml/2006/main">
-            <a:r>
-              <a:t>- ../../course/reading-card-case.md</a:t>
-            </a:r>
-          </a:p>
-          <a:p xmlns:a="http://schemas.openxmlformats.org/drawingml/2006/main">
-            <a:r>
-              <a:t/>
+              <a:t>本课 handout.md、judgment-task.md；../../course/judgment-path.md。</a:t>
             </a:r>
           </a:p>
           <a:p xmlns:a="http://schemas.openxmlformats.org/drawingml/2006/main">
@@ -1427,7 +1072,7 @@
           </a:p>
           <a:p xmlns:a="http://schemas.openxmlformats.org/drawingml/2006/main">
             <a:r>
-              <a:t>讲义位置：本课讲义；见逐页母稿映射表</a:t>
+              <a:t>讲述与校准：</a:t>
             </a:r>
           </a:p>
           <a:p xmlns:a="http://schemas.openxmlformats.org/drawingml/2006/main">
@@ -1437,22 +1082,17 @@
           </a:p>
           <a:p xmlns:a="http://schemas.openxmlformats.org/drawingml/2006/main">
             <a:r>
-              <a:t>屏显核对：</a:t>
-            </a:r>
-          </a:p>
-          <a:p xmlns:a="http://schemas.openxmlformats.org/drawingml/2006/main">
-            <a:r>
-              <a:t>真实意见 → 处理决定 → 实际修改 → 剩余边界</a:t>
-            </a:r>
-          </a:p>
-          <a:p xmlns:a="http://schemas.openxmlformats.org/drawingml/2006/main">
-            <a:r>
               <a:t/>
             </a:r>
           </a:p>
           <a:p xmlns:a="http://schemas.openxmlformats.org/drawingml/2006/main">
             <a:r>
-              <a:t>反馈不替代作者判断；理由回到证据和约束。</a:t>
+              <a:t>学生动作：</a:t>
+            </a:r>
+          </a:p>
+          <a:p xmlns:a="http://schemas.openxmlformats.org/drawingml/2006/main">
+            <a:r>
+              <a:t>依据本页方法检查本人项目；按需参考。</a:t>
             </a:r>
           </a:p>
           <a:p xmlns:a="http://schemas.openxmlformats.org/drawingml/2006/main">
@@ -1462,7 +1102,7 @@
           </a:p>
           <a:p xmlns:a="http://schemas.openxmlformats.org/drawingml/2006/main">
             <a:r>
-              <a:t>完成标志是修改证据，不只是修改计划。</a:t>
+              <a:t>课堂安排：按 teaching-plan.md 专用课堂时段安排；换场计入对应时段。</a:t>
             </a:r>
           </a:p>
           <a:p xmlns:a="http://schemas.openxmlformats.org/drawingml/2006/main">
@@ -1472,77 +1112,12 @@
           </a:p>
           <a:p xmlns:a="http://schemas.openxmlformats.org/drawingml/2006/main">
             <a:r>
-              <a:t>教师讲述：</a:t>
-            </a:r>
-          </a:p>
-          <a:p xmlns:a="http://schemas.openxmlformats.org/drawingml/2006/main">
-            <a:r>
-              <a:t>退出动作：学生指出已改的一处和仍待处理的一处。</a:t>
-            </a:r>
-          </a:p>
-          <a:p xmlns:a="http://schemas.openxmlformats.org/drawingml/2006/main">
-            <a:r>
-              <a:t/>
-            </a:r>
-          </a:p>
-          <a:p xmlns:a="http://schemas.openxmlformats.org/drawingml/2006/main">
-            <a:r>
-              <a:t>学生动作：</a:t>
-            </a:r>
-          </a:p>
-          <a:p xmlns:a="http://schemas.openxmlformats.org/drawingml/2006/main">
-            <a:r>
-              <a:t/>
-            </a:r>
-          </a:p>
-          <a:p xmlns:a="http://schemas.openxmlformats.org/drawingml/2006/main">
-            <a:r>
-              <a:t/>
-            </a:r>
-          </a:p>
-          <a:p xmlns:a="http://schemas.openxmlformats.org/drawingml/2006/main">
-            <a:r>
-              <a:t>来源与边界：</a:t>
-            </a:r>
-          </a:p>
-          <a:p xmlns:a="http://schemas.openxmlformats.org/drawingml/2006/main">
-            <a:r>
-              <a:t>讲义总结；Booth et al.；assignments.md。</a:t>
-            </a:r>
-          </a:p>
-          <a:p xmlns:a="http://schemas.openxmlformats.org/drawingml/2006/main">
-            <a:r>
-              <a:t/>
-            </a:r>
-          </a:p>
-          <a:p xmlns:a="http://schemas.openxmlformats.org/drawingml/2006/main">
-            <a:r>
               <a:t>[Sources]</a:t>
             </a:r>
           </a:p>
           <a:p xmlns:a="http://schemas.openxmlformats.org/drawingml/2006/main">
             <a:r>
-              <a:t/>
-            </a:r>
-          </a:p>
-          <a:p xmlns:a="http://schemas.openxmlformats.org/drawingml/2006/main">
-            <a:r>
-              <a:t>- 本课 handout.md 与 slides.md</a:t>
-            </a:r>
-          </a:p>
-          <a:p xmlns:a="http://schemas.openxmlformats.org/drawingml/2006/main">
-            <a:r>
-              <a:t/>
-            </a:r>
-          </a:p>
-          <a:p xmlns:a="http://schemas.openxmlformats.org/drawingml/2006/main">
-            <a:r>
-              <a:t>- ../../course/reading-card-case.md</a:t>
-            </a:r>
-          </a:p>
-          <a:p xmlns:a="http://schemas.openxmlformats.org/drawingml/2006/main">
-            <a:r>
-              <a:t/>
+              <a:t>本课 handout.md、judgment-task.md；../../course/judgment-path.md。</a:t>
             </a:r>
           </a:p>
           <a:p xmlns:a="http://schemas.openxmlformats.org/drawingml/2006/main">
@@ -1617,7 +1192,7 @@
           <a:lstStyle xmlns:a="http://schemas.openxmlformats.org/drawingml/2006/main"/>
           <a:p xmlns:a="http://schemas.openxmlformats.org/drawingml/2006/main">
             <a:r>
-              <a:t>页面：P15 带齐展示与抽查材料</a:t>
+              <a:t>页面：P15 保留本课决定，准备下一课输入</a:t>
             </a:r>
           </a:p>
           <a:p xmlns:a="http://schemas.openxmlformats.org/drawingml/2006/main">
@@ -1627,7 +1202,12 @@
           </a:p>
           <a:p xmlns:a="http://schemas.openxmlformats.org/drawingml/2006/main">
             <a:r>
-              <a:t>讲义位置：本课讲义；见逐页母稿映射表</a:t>
+              <a:t>讲述与校准：</a:t>
+            </a:r>
+          </a:p>
+          <a:p xmlns:a="http://schemas.openxmlformats.org/drawingml/2006/main">
+            <a:r>
+              <a:t>按优先级修订既有初稿；从现有图表挑展示材料并检查可打开。 每课课外最多60分钟；详见讲义。</a:t>
             </a:r>
           </a:p>
           <a:p xmlns:a="http://schemas.openxmlformats.org/drawingml/2006/main">
@@ -1637,12 +1217,12 @@
           </a:p>
           <a:p xmlns:a="http://schemas.openxmlformats.org/drawingml/2006/main">
             <a:r>
-              <a:t>屏显核对：</a:t>
-            </a:r>
-          </a:p>
-          <a:p xmlns:a="http://schemas.openxmlformats.org/drawingml/2006/main">
-            <a:r>
-              <a:t>全员闪电报告：研究问题、关键结果、结论边界。</a:t>
+              <a:t>学生动作：</a:t>
+            </a:r>
+          </a:p>
+          <a:p xmlns:a="http://schemas.openxmlformats.org/drawingml/2006/main">
+            <a:r>
+              <a:t>定位实际工件与下一项动作；按既定预算收口。</a:t>
             </a:r>
           </a:p>
           <a:p xmlns:a="http://schemas.openxmlformats.org/drawingml/2006/main">
@@ -1652,7 +1232,7 @@
           </a:p>
           <a:p xmlns:a="http://schemas.openxmlformats.org/drawingml/2006/main">
             <a:r>
-              <a:t>分组证据／工作流演示：证据定位、真实作用、失败与人工判断。</a:t>
+              <a:t>课堂安排：按 teaching-plan.md 专用课堂时段安排；换场计入对应时段。</a:t>
             </a:r>
           </a:p>
           <a:p xmlns:a="http://schemas.openxmlformats.org/drawingml/2006/main">
@@ -1662,97 +1242,12 @@
           </a:p>
           <a:p xmlns:a="http://schemas.openxmlformats.org/drawingml/2006/main">
             <a:r>
-              <a:t>教师抽查：实验 ID、引用或工作流 trace。</a:t>
-            </a:r>
-          </a:p>
-          <a:p xmlns:a="http://schemas.openxmlformats.org/drawingml/2006/main">
-            <a:r>
-              <a:t/>
-            </a:r>
-          </a:p>
-          <a:p xmlns:a="http://schemas.openxmlformats.org/drawingml/2006/main">
-            <a:r>
-              <a:t>第 16 课使用现有项目材料，不新增独立汇报文档。</a:t>
-            </a:r>
-          </a:p>
-          <a:p xmlns:a="http://schemas.openxmlformats.org/drawingml/2006/main">
-            <a:r>
-              <a:t/>
-            </a:r>
-          </a:p>
-          <a:p xmlns:a="http://schemas.openxmlformats.org/drawingml/2006/main">
-            <a:r>
-              <a:t>教师讲述：</a:t>
-            </a:r>
-          </a:p>
-          <a:p xmlns:a="http://schemas.openxmlformats.org/drawingml/2006/main">
-            <a:r>
-              <a:t>确认每人材料位置；不再安排新的独立汇报文档。</a:t>
-            </a:r>
-          </a:p>
-          <a:p xmlns:a="http://schemas.openxmlformats.org/drawingml/2006/main">
-            <a:r>
-              <a:t/>
-            </a:r>
-          </a:p>
-          <a:p xmlns:a="http://schemas.openxmlformats.org/drawingml/2006/main">
-            <a:r>
-              <a:t>学生动作：</a:t>
-            </a:r>
-          </a:p>
-          <a:p xmlns:a="http://schemas.openxmlformats.org/drawingml/2006/main">
-            <a:r>
-              <a:t/>
-            </a:r>
-          </a:p>
-          <a:p xmlns:a="http://schemas.openxmlformats.org/drawingml/2006/main">
-            <a:r>
-              <a:t/>
-            </a:r>
-          </a:p>
-          <a:p xmlns:a="http://schemas.openxmlformats.org/drawingml/2006/main">
-            <a:r>
-              <a:t>来源与边界：</a:t>
-            </a:r>
-          </a:p>
-          <a:p xmlns:a="http://schemas.openxmlformats.org/drawingml/2006/main">
-            <a:r>
-              <a:t>第 16 课讲义；assignments.md。</a:t>
-            </a:r>
-          </a:p>
-          <a:p xmlns:a="http://schemas.openxmlformats.org/drawingml/2006/main">
-            <a:r>
-              <a:t/>
-            </a:r>
-          </a:p>
-          <a:p xmlns:a="http://schemas.openxmlformats.org/drawingml/2006/main">
-            <a:r>
               <a:t>[Sources]</a:t>
             </a:r>
           </a:p>
           <a:p xmlns:a="http://schemas.openxmlformats.org/drawingml/2006/main">
             <a:r>
-              <a:t/>
-            </a:r>
-          </a:p>
-          <a:p xmlns:a="http://schemas.openxmlformats.org/drawingml/2006/main">
-            <a:r>
-              <a:t>- 本课 handout.md 与 slides.md</a:t>
-            </a:r>
-          </a:p>
-          <a:p xmlns:a="http://schemas.openxmlformats.org/drawingml/2006/main">
-            <a:r>
-              <a:t/>
-            </a:r>
-          </a:p>
-          <a:p xmlns:a="http://schemas.openxmlformats.org/drawingml/2006/main">
-            <a:r>
-              <a:t>- ../../course/reading-card-case.md</a:t>
-            </a:r>
-          </a:p>
-          <a:p xmlns:a="http://schemas.openxmlformats.org/drawingml/2006/main">
-            <a:r>
-              <a:t/>
+              <a:t>本课 handout.md、judgment-task.md；../../course/judgment-path.md。教学构造仅用于方法判断；本人结果以实际记录为准。</a:t>
             </a:r>
           </a:p>
           <a:p xmlns:a="http://schemas.openxmlformats.org/drawingml/2006/main">
@@ -1837,7 +1332,7 @@
           </a:p>
           <a:p xmlns:a="http://schemas.openxmlformats.org/drawingml/2006/main">
             <a:r>
-              <a:t>讲义位置：本课讲义；见逐页母稿映射表</a:t>
+              <a:t>讲述与校准：</a:t>
             </a:r>
           </a:p>
           <a:p xmlns:a="http://schemas.openxmlformats.org/drawingml/2006/main">
@@ -1847,22 +1342,17 @@
           </a:p>
           <a:p xmlns:a="http://schemas.openxmlformats.org/drawingml/2006/main">
             <a:r>
-              <a:t>屏显核对：</a:t>
-            </a:r>
-          </a:p>
-          <a:p xmlns:a="http://schemas.openxmlformats.org/drawingml/2006/main">
-            <a:r>
-              <a:t>课程构造的评审表达示例</a:t>
-            </a:r>
-          </a:p>
-          <a:p xmlns:a="http://schemas.openxmlformats.org/drawingml/2006/main">
-            <a:r>
               <a:t/>
             </a:r>
           </a:p>
           <a:p xmlns:a="http://schemas.openxmlformats.org/drawingml/2006/main">
             <a:r>
-              <a:t>− 论证不严谨。</a:t>
+              <a:t>学生动作：</a:t>
+            </a:r>
+          </a:p>
+          <a:p xmlns:a="http://schemas.openxmlformats.org/drawingml/2006/main">
+            <a:r>
+              <a:t>依据本页方法检查本人项目；按需参考。</a:t>
             </a:r>
           </a:p>
           <a:p xmlns:a="http://schemas.openxmlformats.org/drawingml/2006/main">
@@ -1872,7 +1362,7 @@
           </a:p>
           <a:p xmlns:a="http://schemas.openxmlformats.org/drawingml/2006/main">
             <a:r>
-              <a:t>+ report.md 结果段：主张“机制已证实”，但没有区分 H1/A2，也没有测量其他质量。建议降级结论并补边界。</a:t>
+              <a:t>课堂安排：按 teaching-plan.md 专用课堂时段安排；换场计入对应时段。</a:t>
             </a:r>
           </a:p>
           <a:p xmlns:a="http://schemas.openxmlformats.org/drawingml/2006/main">
@@ -1882,142 +1372,12 @@
           </a:p>
           <a:p xmlns:a="http://schemas.openxmlformats.org/drawingml/2006/main">
             <a:r>
-              <a:t>指向工作，不评价作者人格或选题时髦度；作者保留判断责任。</a:t>
-            </a:r>
-          </a:p>
-          <a:p xmlns:a="http://schemas.openxmlformats.org/drawingml/2006/main">
-            <a:r>
-              <a:t/>
-            </a:r>
-          </a:p>
-          <a:p xmlns:a="http://schemas.openxmlformats.org/drawingml/2006/main">
-            <a:r>
-              <a:t>教师讲述：</a:t>
-            </a:r>
-          </a:p>
-          <a:p xmlns:a="http://schemas.openxmlformats.org/drawingml/2006/main">
-            <a:r>
-              <a:t>把“论证不严谨”改写为可定位句子。</a:t>
-            </a:r>
-          </a:p>
-          <a:p xmlns:a="http://schemas.openxmlformats.org/drawingml/2006/main">
-            <a:r>
-              <a:t/>
-            </a:r>
-          </a:p>
-          <a:p xmlns:a="http://schemas.openxmlformats.org/drawingml/2006/main">
-            <a:r>
-              <a:t>学生动作：</a:t>
-            </a:r>
-          </a:p>
-          <a:p xmlns:a="http://schemas.openxmlformats.org/drawingml/2006/main">
-            <a:r>
-              <a:t/>
-            </a:r>
-          </a:p>
-          <a:p xmlns:a="http://schemas.openxmlformats.org/drawingml/2006/main">
-            <a:r>
-              <a:t/>
-            </a:r>
-          </a:p>
-          <a:p xmlns:a="http://schemas.openxmlformats.org/drawingml/2006/main">
-            <a:r>
-              <a:t>本课板书、诊断与串词：</a:t>
-            </a:r>
-          </a:p>
-          <a:p xmlns:a="http://schemas.openxmlformats.org/drawingml/2006/main">
-            <a:r>
-              <a:t>本节替换同类口头提示，不增加既有时段。开场诊断嵌入现有开场/回顾，后续再沿原实践时段操作。</a:t>
-            </a:r>
-          </a:p>
-          <a:p xmlns:a="http://schemas.openxmlformats.org/drawingml/2006/main">
-            <a:r>
-              <a:t/>
-            </a:r>
-          </a:p>
-          <a:p xmlns:a="http://schemas.openxmlformats.org/drawingml/2006/main">
-            <a:r>
-              <a:t>- **板书主线**：意见定位 → 严重度 → 回应理由 → 实际diff → 未决项。</a:t>
-            </a:r>
-          </a:p>
-          <a:p xmlns:a="http://schemas.openxmlformats.org/drawingml/2006/main">
-            <a:r>
-              <a:t>- **诊断问题**：写了修改计划，是否就算处理完意见？</a:t>
-            </a:r>
-          </a:p>
-          <a:p xmlns:a="http://schemas.openxmlformats.org/drawingml/2006/main">
-            <a:r>
-              <a:t>- **预期回答**：要看正文或工件的实际修改；未完成需标缺口。</a:t>
-            </a:r>
-          </a:p>
-          <a:p xmlns:a="http://schemas.openxmlformats.org/drawingml/2006/main">
-            <a:r>
-              <a:t>- **常见误答后的追问**：如所有意见都写接受，核对依据，允许合理拒绝或暂缓。</a:t>
-            </a:r>
-          </a:p>
-          <a:p xmlns:a="http://schemas.openxmlformats.org/drawingml/2006/main">
-            <a:r>
-              <a:t>- **过渡串词**：“第16课会抽查这些修改后的真实记录，而非只看汇报表述。”</a:t>
-            </a:r>
-          </a:p>
-          <a:p xmlns:a="http://schemas.openxmlformats.org/drawingml/2006/main">
-            <a:r>
-              <a:t>- **当堂最小产出**：真实互评、作者回应、一项已落盘修改与剩余清单。</a:t>
-            </a:r>
-          </a:p>
-          <a:p xmlns:a="http://schemas.openxmlformats.org/drawingml/2006/main">
-            <a:r>
-              <a:t>- **退出记录**：写“已完成的动作、本人项目仍缺的证据/工件、下次补齐位置”。使用教师包时标明课堂方法练习，不能据此宣称本人研究门通过；正式提交课次仍为第 6、9、13、16 课。</a:t>
-            </a:r>
-          </a:p>
-          <a:p xmlns:a="http://schemas.openxmlformats.org/drawingml/2006/main">
-            <a:r>
-              <a:t/>
-            </a:r>
-          </a:p>
-          <a:p xmlns:a="http://schemas.openxmlformats.org/drawingml/2006/main">
-            <a:r>
-              <a:t>来源与边界：</a:t>
-            </a:r>
-          </a:p>
-          <a:p xmlns:a="http://schemas.openxmlformats.org/drawingml/2006/main">
-            <a:r>
-              <a:t>Smith 1990；Stanford Scientific Writing Unit 8；讲义 §四。</a:t>
-            </a:r>
-          </a:p>
-          <a:p xmlns:a="http://schemas.openxmlformats.org/drawingml/2006/main">
-            <a:r>
-              <a:t/>
-            </a:r>
-          </a:p>
-          <a:p xmlns:a="http://schemas.openxmlformats.org/drawingml/2006/main">
-            <a:r>
               <a:t>[Sources]</a:t>
             </a:r>
           </a:p>
           <a:p xmlns:a="http://schemas.openxmlformats.org/drawingml/2006/main">
             <a:r>
-              <a:t/>
-            </a:r>
-          </a:p>
-          <a:p xmlns:a="http://schemas.openxmlformats.org/drawingml/2006/main">
-            <a:r>
-              <a:t>- 本课 handout.md 与 slides.md</a:t>
-            </a:r>
-          </a:p>
-          <a:p xmlns:a="http://schemas.openxmlformats.org/drawingml/2006/main">
-            <a:r>
-              <a:t/>
-            </a:r>
-          </a:p>
-          <a:p xmlns:a="http://schemas.openxmlformats.org/drawingml/2006/main">
-            <a:r>
-              <a:t>- ../../course/reading-card-case.md</a:t>
-            </a:r>
-          </a:p>
-          <a:p xmlns:a="http://schemas.openxmlformats.org/drawingml/2006/main">
-            <a:r>
-              <a:t/>
+              <a:t>本课 handout.md、judgment-task.md；../../course/judgment-path.md。</a:t>
             </a:r>
           </a:p>
           <a:p xmlns:a="http://schemas.openxmlformats.org/drawingml/2006/main">
@@ -2102,7 +1462,7 @@
           </a:p>
           <a:p xmlns:a="http://schemas.openxmlformats.org/drawingml/2006/main">
             <a:r>
-              <a:t>讲义位置：本课讲义；见逐页母稿映射表</a:t>
+              <a:t>讲述与校准：</a:t>
             </a:r>
           </a:p>
           <a:p xmlns:a="http://schemas.openxmlformats.org/drawingml/2006/main">
@@ -2112,22 +1472,17 @@
           </a:p>
           <a:p xmlns:a="http://schemas.openxmlformats.org/drawingml/2006/main">
             <a:r>
-              <a:t>屏显核对：</a:t>
-            </a:r>
-          </a:p>
-          <a:p xmlns:a="http://schemas.openxmlformats.org/drawingml/2006/main">
-            <a:r>
-              <a:t>peer-review.md：具体意见 → 处理决定与理由</a:t>
-            </a:r>
-          </a:p>
-          <a:p xmlns:a="http://schemas.openxmlformats.org/drawingml/2006/main">
-            <a:r>
               <a:t/>
             </a:r>
           </a:p>
           <a:p xmlns:a="http://schemas.openxmlformats.org/drawingml/2006/main">
             <a:r>
-              <a:t>实际文件 diff：至少一项落实修改</a:t>
+              <a:t>学生动作：</a:t>
+            </a:r>
+          </a:p>
+          <a:p xmlns:a="http://schemas.openxmlformats.org/drawingml/2006/main">
+            <a:r>
+              <a:t>依据本页方法检查本人项目；按需参考。</a:t>
             </a:r>
           </a:p>
           <a:p xmlns:a="http://schemas.openxmlformats.org/drawingml/2006/main">
@@ -2137,7 +1492,7 @@
           </a:p>
           <a:p xmlns:a="http://schemas.openxmlformats.org/drawingml/2006/main">
             <a:r>
-              <a:t>revision-plan.md：剩余预检缺口</a:t>
+              <a:t>课堂安排：按 teaching-plan.md 专用课堂时段安排；换场计入对应时段。</a:t>
             </a:r>
           </a:p>
           <a:p xmlns:a="http://schemas.openxmlformats.org/drawingml/2006/main">
@@ -2147,97 +1502,12 @@
           </a:p>
           <a:p xmlns:a="http://schemas.openxmlformats.org/drawingml/2006/main">
             <a:r>
-              <a:t>这些工件直接进入第 16 课；真实意见不足时处理全部，不虚构反馈。</a:t>
-            </a:r>
-          </a:p>
-          <a:p xmlns:a="http://schemas.openxmlformats.org/drawingml/2006/main">
-            <a:r>
-              <a:t/>
-            </a:r>
-          </a:p>
-          <a:p xmlns:a="http://schemas.openxmlformats.org/drawingml/2006/main">
-            <a:r>
-              <a:t>课程虚构工件示例：评审指出结果段结论越界；作者采纳并将 `stable` 改为“支持（待验证）”；修改计划保留替代解释对照缺口。</a:t>
-            </a:r>
-          </a:p>
-          <a:p xmlns:a="http://schemas.openxmlformats.org/drawingml/2006/main">
-            <a:r>
-              <a:t/>
-            </a:r>
-          </a:p>
-          <a:p xmlns:a="http://schemas.openxmlformats.org/drawingml/2006/main">
-            <a:r>
-              <a:t>教师讲述：</a:t>
-            </a:r>
-          </a:p>
-          <a:p xmlns:a="http://schemas.openxmlformats.org/drawingml/2006/main">
-            <a:r>
-              <a:t>若真实反馈少于两条，处理全部并记录缺口，不虚构意见。</a:t>
-            </a:r>
-          </a:p>
-          <a:p xmlns:a="http://schemas.openxmlformats.org/drawingml/2006/main">
-            <a:r>
-              <a:t/>
-            </a:r>
-          </a:p>
-          <a:p xmlns:a="http://schemas.openxmlformats.org/drawingml/2006/main">
-            <a:r>
-              <a:t>学生动作：</a:t>
-            </a:r>
-          </a:p>
-          <a:p xmlns:a="http://schemas.openxmlformats.org/drawingml/2006/main">
-            <a:r>
-              <a:t/>
-            </a:r>
-          </a:p>
-          <a:p xmlns:a="http://schemas.openxmlformats.org/drawingml/2006/main">
-            <a:r>
-              <a:t/>
-            </a:r>
-          </a:p>
-          <a:p xmlns:a="http://schemas.openxmlformats.org/drawingml/2006/main">
-            <a:r>
-              <a:t>来源与边界：</a:t>
-            </a:r>
-          </a:p>
-          <a:p xmlns:a="http://schemas.openxmlformats.org/drawingml/2006/main">
-            <a:r>
-              <a:t>讲义导读、§五—六。</a:t>
-            </a:r>
-          </a:p>
-          <a:p xmlns:a="http://schemas.openxmlformats.org/drawingml/2006/main">
-            <a:r>
-              <a:t/>
-            </a:r>
-          </a:p>
-          <a:p xmlns:a="http://schemas.openxmlformats.org/drawingml/2006/main">
-            <a:r>
               <a:t>[Sources]</a:t>
             </a:r>
           </a:p>
           <a:p xmlns:a="http://schemas.openxmlformats.org/drawingml/2006/main">
             <a:r>
-              <a:t/>
-            </a:r>
-          </a:p>
-          <a:p xmlns:a="http://schemas.openxmlformats.org/drawingml/2006/main">
-            <a:r>
-              <a:t>- 本课 handout.md 与 slides.md</a:t>
-            </a:r>
-          </a:p>
-          <a:p xmlns:a="http://schemas.openxmlformats.org/drawingml/2006/main">
-            <a:r>
-              <a:t/>
-            </a:r>
-          </a:p>
-          <a:p xmlns:a="http://schemas.openxmlformats.org/drawingml/2006/main">
-            <a:r>
-              <a:t>- ../../course/reading-card-case.md</a:t>
-            </a:r>
-          </a:p>
-          <a:p xmlns:a="http://schemas.openxmlformats.org/drawingml/2006/main">
-            <a:r>
-              <a:t/>
+              <a:t>本课 handout.md、judgment-task.md；../../course/judgment-path.md。</a:t>
             </a:r>
           </a:p>
           <a:p xmlns:a="http://schemas.openxmlformats.org/drawingml/2006/main">
@@ -2312,7 +1582,7 @@
           <a:lstStyle xmlns:a="http://schemas.openxmlformats.org/drawingml/2006/main"/>
           <a:p xmlns:a="http://schemas.openxmlformats.org/drawingml/2006/main">
             <a:r>
-              <a:t>页面：P04 给三处错误排优先级</a:t>
+              <a:t>页面：P04 哪条评审应先处理</a:t>
             </a:r>
           </a:p>
           <a:p xmlns:a="http://schemas.openxmlformats.org/drawingml/2006/main">
@@ -2322,7 +1592,12 @@
           </a:p>
           <a:p xmlns:a="http://schemas.openxmlformats.org/drawingml/2006/main">
             <a:r>
-              <a:t>讲义位置：handout.md §七、贯穿案例：从第 14 课初稿到同行评审</a:t>
+              <a:t>讲述与校准：</a:t>
+            </a:r>
+          </a:p>
+          <a:p xmlns:a="http://schemas.openxmlformats.org/drawingml/2006/main">
+            <a:r>
+              <a:t>先独立作答，再同伴比较；以下依据只在校准时揭示。</a:t>
             </a:r>
           </a:p>
           <a:p xmlns:a="http://schemas.openxmlformats.org/drawingml/2006/main">
@@ -2332,22 +1607,7 @@
           </a:p>
           <a:p xmlns:a="http://schemas.openxmlformats.org/drawingml/2006/main">
             <a:r>
-              <a:t>屏显核对：</a:t>
-            </a:r>
-          </a:p>
-          <a:p xmlns:a="http://schemas.openxmlformats.org/drawingml/2006/main">
-            <a:r>
-              <a:t>D1：“证明机制，对所有文本有效，stable。”</a:t>
-            </a:r>
-          </a:p>
-          <a:p xmlns:a="http://schemas.openxmlformats.org/drawingml/2006/main">
-            <a:r>
-              <a:t>D2：只给百分比，没有分母和原始记录位置。</a:t>
-            </a:r>
-          </a:p>
-          <a:p xmlns:a="http://schemas.openxmlformats.org/drawingml/2006/main">
-            <a:r>
-              <a:t>图1：“组一/组二”，指标和范围不明。</a:t>
+              <a:t>A 同时涉及单位事实和效度，应优先实际修订；B 为次级表达问题；C 忽略了确定性回放，可用方法与版本证据澄清。保留异议需要定位事实，不能以“时间不够”反驳实质错误。</a:t>
             </a:r>
           </a:p>
           <a:p xmlns:a="http://schemas.openxmlformats.org/drawingml/2006/main">
@@ -2357,7 +1617,12 @@
           </a:p>
           <a:p xmlns:a="http://schemas.openxmlformats.org/drawingml/2006/main">
             <a:r>
-              <a:t>先处理结论越界，再补追踪与图表说明。</a:t>
+              <a:t>学生动作：</a:t>
+            </a:r>
+          </a:p>
+          <a:p xmlns:a="http://schemas.openxmlformats.org/drawingml/2006/main">
+            <a:r>
+              <a:t>先独立写决定和证据，后同伴比较；校准后再回写。</a:t>
             </a:r>
           </a:p>
           <a:p xmlns:a="http://schemas.openxmlformats.org/drawingml/2006/main">
@@ -2367,12 +1632,7 @@
           </a:p>
           <a:p xmlns:a="http://schemas.openxmlformats.org/drawingml/2006/main">
             <a:r>
-              <a:t>教师讲述：</a:t>
-            </a:r>
-          </a:p>
-          <a:p xmlns:a="http://schemas.openxmlformats.org/drawingml/2006/main">
-            <a:r>
-              <a:t>打开calibration-pack完整含错版本。三条意见须分别指出位置、问题、影响和修订动作。标准答案只作教师校准；本课主体仍是学生真实互评。</a:t>
+              <a:t>课堂安排：按 teaching-plan.md 专用课堂时段安排；换场计入对应时段。</a:t>
             </a:r>
           </a:p>
           <a:p xmlns:a="http://schemas.openxmlformats.org/drawingml/2006/main">
@@ -2382,12 +1642,12 @@
           </a:p>
           <a:p xmlns:a="http://schemas.openxmlformats.org/drawingml/2006/main">
             <a:r>
-              <a:t>学生动作：</a:t>
-            </a:r>
-          </a:p>
-          <a:p xmlns:a="http://schemas.openxmlformats.org/drawingml/2006/main">
-            <a:r>
-              <a:t>各写一条可执行意见，与教师参考意见比较优先级。</a:t>
+              <a:t>[Sources]</a:t>
+            </a:r>
+          </a:p>
+          <a:p xmlns:a="http://schemas.openxmlformats.org/drawingml/2006/main">
+            <a:r>
+              <a:t>./handout.md；课堂示例与构造数据见 ../../course/reading-card-case.md</a:t>
             </a:r>
           </a:p>
           <a:p xmlns:a="http://schemas.openxmlformats.org/drawingml/2006/main">
@@ -2397,47 +1657,7 @@
           </a:p>
           <a:p xmlns:a="http://schemas.openxmlformats.org/drawingml/2006/main">
             <a:r>
-              <a:t>来源与边界：</a:t>
-            </a:r>
-          </a:p>
-          <a:p xmlns:a="http://schemas.openxmlformats.org/drawingml/2006/main">
-            <a:r>
-              <a:t>./handout.md；课堂示例与构造数据见 ../../course/reading-card-case.md</a:t>
-            </a:r>
-          </a:p>
-          <a:p xmlns:a="http://schemas.openxmlformats.org/drawingml/2006/main">
-            <a:r>
-              <a:t/>
-            </a:r>
-          </a:p>
-          <a:p xmlns:a="http://schemas.openxmlformats.org/drawingml/2006/main">
-            <a:r>
-              <a:t>[Sources]</a:t>
-            </a:r>
-          </a:p>
-          <a:p xmlns:a="http://schemas.openxmlformats.org/drawingml/2006/main">
-            <a:r>
-              <a:t/>
-            </a:r>
-          </a:p>
-          <a:p xmlns:a="http://schemas.openxmlformats.org/drawingml/2006/main">
-            <a:r>
-              <a:t>- 本课 handout.md 与 slides.md</a:t>
-            </a:r>
-          </a:p>
-          <a:p xmlns:a="http://schemas.openxmlformats.org/drawingml/2006/main">
-            <a:r>
-              <a:t/>
-            </a:r>
-          </a:p>
-          <a:p xmlns:a="http://schemas.openxmlformats.org/drawingml/2006/main">
-            <a:r>
-              <a:t>- ../../course/reading-card-case.md</a:t>
-            </a:r>
-          </a:p>
-          <a:p xmlns:a="http://schemas.openxmlformats.org/drawingml/2006/main">
-            <a:r>
-              <a:t/>
+              <a:t>本课 handout.md、judgment-task.md；../../course/judgment-path.md。教学构造仅用于方法判断；本人结果以实际记录为准。</a:t>
             </a:r>
           </a:p>
           <a:p xmlns:a="http://schemas.openxmlformats.org/drawingml/2006/main">
@@ -2522,7 +1742,7 @@
           </a:p>
           <a:p xmlns:a="http://schemas.openxmlformats.org/drawingml/2006/main">
             <a:r>
-              <a:t>讲义位置：本课讲义；见逐页母稿映射表</a:t>
+              <a:t>讲述与校准：</a:t>
             </a:r>
           </a:p>
           <a:p xmlns:a="http://schemas.openxmlformats.org/drawingml/2006/main">
@@ -2532,22 +1752,17 @@
           </a:p>
           <a:p xmlns:a="http://schemas.openxmlformats.org/drawingml/2006/main">
             <a:r>
-              <a:t>屏显核对：</a:t>
-            </a:r>
-          </a:p>
-          <a:p xmlns:a="http://schemas.openxmlformats.org/drawingml/2006/main">
-            <a:r>
-              <a:t>论证链：主张能反查证据与上游判断吗？</a:t>
-            </a:r>
-          </a:p>
-          <a:p xmlns:a="http://schemas.openxmlformats.org/drawingml/2006/main">
-            <a:r>
               <a:t/>
             </a:r>
           </a:p>
           <a:p xmlns:a="http://schemas.openxmlformats.org/drawingml/2006/main">
             <a:r>
-              <a:t>证据充分：强度匹配吗，失败保留吗？</a:t>
+              <a:t>学生动作：</a:t>
+            </a:r>
+          </a:p>
+          <a:p xmlns:a="http://schemas.openxmlformats.org/drawingml/2006/main">
+            <a:r>
+              <a:t>依据本页方法检查本人项目；按需参考。</a:t>
             </a:r>
           </a:p>
           <a:p xmlns:a="http://schemas.openxmlformats.org/drawingml/2006/main">
@@ -2557,7 +1772,7 @@
           </a:p>
           <a:p xmlns:a="http://schemas.openxmlformats.org/drawingml/2006/main">
             <a:r>
-              <a:t>局限：替代解释与边界具体吗？</a:t>
+              <a:t>课堂安排：按 teaching-plan.md 专用课堂时段安排；换场计入对应时段。</a:t>
             </a:r>
           </a:p>
           <a:p xmlns:a="http://schemas.openxmlformats.org/drawingml/2006/main">
@@ -2567,107 +1782,12 @@
           </a:p>
           <a:p xmlns:a="http://schemas.openxmlformats.org/drawingml/2006/main">
             <a:r>
-              <a:t>可复现：表图能定位运行记录吗？</a:t>
-            </a:r>
-          </a:p>
-          <a:p xmlns:a="http://schemas.openxmlformats.org/drawingml/2006/main">
-            <a:r>
-              <a:t/>
-            </a:r>
-          </a:p>
-          <a:p xmlns:a="http://schemas.openxmlformats.org/drawingml/2006/main">
-            <a:r>
-              <a:t>伦理：数据、权限、贡献与 AI 披露透明吗？</a:t>
-            </a:r>
-          </a:p>
-          <a:p xmlns:a="http://schemas.openxmlformats.org/drawingml/2006/main">
-            <a:r>
-              <a:t/>
-            </a:r>
-          </a:p>
-          <a:p xmlns:a="http://schemas.openxmlformats.org/drawingml/2006/main">
-            <a:r>
-              <a:t>rubric 用于诊断，不打总分。</a:t>
-            </a:r>
-          </a:p>
-          <a:p xmlns:a="http://schemas.openxmlformats.org/drawingml/2006/main">
-            <a:r>
-              <a:t/>
-            </a:r>
-          </a:p>
-          <a:p xmlns:a="http://schemas.openxmlformats.org/drawingml/2006/main">
-            <a:r>
-              <a:t>教师讲述：</a:t>
-            </a:r>
-          </a:p>
-          <a:p xmlns:a="http://schemas.openxmlformats.org/drawingml/2006/main">
-            <a:r>
-              <a:t>rubric 是诊断工具，不打总分。</a:t>
-            </a:r>
-          </a:p>
-          <a:p xmlns:a="http://schemas.openxmlformats.org/drawingml/2006/main">
-            <a:r>
-              <a:t/>
-            </a:r>
-          </a:p>
-          <a:p xmlns:a="http://schemas.openxmlformats.org/drawingml/2006/main">
-            <a:r>
-              <a:t>学生动作：</a:t>
-            </a:r>
-          </a:p>
-          <a:p xmlns:a="http://schemas.openxmlformats.org/drawingml/2006/main">
-            <a:r>
-              <a:t/>
-            </a:r>
-          </a:p>
-          <a:p xmlns:a="http://schemas.openxmlformats.org/drawingml/2006/main">
-            <a:r>
-              <a:t/>
-            </a:r>
-          </a:p>
-          <a:p xmlns:a="http://schemas.openxmlformats.org/drawingml/2006/main">
-            <a:r>
-              <a:t>来源与边界：</a:t>
-            </a:r>
-          </a:p>
-          <a:p xmlns:a="http://schemas.openxmlformats.org/drawingml/2006/main">
-            <a:r>
-              <a:t>讲义 §二；assignments.md Checkpoint 4。</a:t>
-            </a:r>
-          </a:p>
-          <a:p xmlns:a="http://schemas.openxmlformats.org/drawingml/2006/main">
-            <a:r>
-              <a:t/>
-            </a:r>
-          </a:p>
-          <a:p xmlns:a="http://schemas.openxmlformats.org/drawingml/2006/main">
-            <a:r>
               <a:t>[Sources]</a:t>
             </a:r>
           </a:p>
           <a:p xmlns:a="http://schemas.openxmlformats.org/drawingml/2006/main">
             <a:r>
-              <a:t/>
-            </a:r>
-          </a:p>
-          <a:p xmlns:a="http://schemas.openxmlformats.org/drawingml/2006/main">
-            <a:r>
-              <a:t>- 本课 handout.md 与 slides.md</a:t>
-            </a:r>
-          </a:p>
-          <a:p xmlns:a="http://schemas.openxmlformats.org/drawingml/2006/main">
-            <a:r>
-              <a:t/>
-            </a:r>
-          </a:p>
-          <a:p xmlns:a="http://schemas.openxmlformats.org/drawingml/2006/main">
-            <a:r>
-              <a:t>- ../../course/reading-card-case.md</a:t>
-            </a:r>
-          </a:p>
-          <a:p xmlns:a="http://schemas.openxmlformats.org/drawingml/2006/main">
-            <a:r>
-              <a:t/>
+              <a:t>本课 handout.md、judgment-task.md；../../course/judgment-path.md。</a:t>
             </a:r>
           </a:p>
           <a:p xmlns:a="http://schemas.openxmlformats.org/drawingml/2006/main">
@@ -2752,7 +1872,7 @@
           </a:p>
           <a:p xmlns:a="http://schemas.openxmlformats.org/drawingml/2006/main">
             <a:r>
-              <a:t>讲义位置：本课讲义；见逐页母稿映射表</a:t>
+              <a:t>讲述与校准：</a:t>
             </a:r>
           </a:p>
           <a:p xmlns:a="http://schemas.openxmlformats.org/drawingml/2006/main">
@@ -2762,32 +1882,17 @@
           </a:p>
           <a:p xmlns:a="http://schemas.openxmlformats.org/drawingml/2006/main">
             <a:r>
-              <a:t>屏显核对：</a:t>
-            </a:r>
-          </a:p>
-          <a:p xmlns:a="http://schemas.openxmlformats.org/drawingml/2006/main">
-            <a:r>
-              <a:t>留下三条能执行的反馈：</a:t>
-            </a:r>
-          </a:p>
-          <a:p xmlns:a="http://schemas.openxmlformats.org/drawingml/2006/main">
-            <a:r>
               <a:t/>
             </a:r>
           </a:p>
           <a:p xmlns:a="http://schemas.openxmlformats.org/drawingml/2006/main">
             <a:r>
-              <a:t>最强处：证据在哪里？</a:t>
-            </a:r>
-          </a:p>
-          <a:p xmlns:a="http://schemas.openxmlformats.org/drawingml/2006/main">
-            <a:r>
-              <a:t>最大风险：会卡住哪条门条件？</a:t>
-            </a:r>
-          </a:p>
-          <a:p xmlns:a="http://schemas.openxmlformats.org/drawingml/2006/main">
-            <a:r>
-              <a:t>可执行建议：最小改动是什么？</a:t>
+              <a:t>学生动作：</a:t>
+            </a:r>
+          </a:p>
+          <a:p xmlns:a="http://schemas.openxmlformats.org/drawingml/2006/main">
+            <a:r>
+              <a:t>依据本页方法检查本人项目；按需参考。</a:t>
             </a:r>
           </a:p>
           <a:p xmlns:a="http://schemas.openxmlformats.org/drawingml/2006/main">
@@ -2797,12 +1902,7 @@
           </a:p>
           <a:p xmlns:a="http://schemas.openxmlformats.org/drawingml/2006/main">
             <a:r>
-              <a:t>指向具体段落、表、证据项或运行记录。</a:t>
-            </a:r>
-          </a:p>
-          <a:p xmlns:a="http://schemas.openxmlformats.org/drawingml/2006/main">
-            <a:r>
-              <a:t>本例核对点：Q1 包内一致；H1/A2 未决；质量与范围仍有缺口。</a:t>
+              <a:t>课堂安排：按 teaching-plan.md 专用课堂时段安排；换场计入对应时段。</a:t>
             </a:r>
           </a:p>
           <a:p xmlns:a="http://schemas.openxmlformats.org/drawingml/2006/main">
@@ -2812,77 +1912,12 @@
           </a:p>
           <a:p xmlns:a="http://schemas.openxmlformats.org/drawingml/2006/main">
             <a:r>
-              <a:t>教师讲述：</a:t>
-            </a:r>
-          </a:p>
-          <a:p xmlns:a="http://schemas.openxmlformats.org/drawingml/2006/main">
-            <a:r>
-              <a:t>禁止“挺好”“不严谨”“建议多做实验”这类无位置反馈。</a:t>
-            </a:r>
-          </a:p>
-          <a:p xmlns:a="http://schemas.openxmlformats.org/drawingml/2006/main">
-            <a:r>
-              <a:t/>
-            </a:r>
-          </a:p>
-          <a:p xmlns:a="http://schemas.openxmlformats.org/drawingml/2006/main">
-            <a:r>
-              <a:t>学生动作：</a:t>
-            </a:r>
-          </a:p>
-          <a:p xmlns:a="http://schemas.openxmlformats.org/drawingml/2006/main">
-            <a:r>
-              <a:t/>
-            </a:r>
-          </a:p>
-          <a:p xmlns:a="http://schemas.openxmlformats.org/drawingml/2006/main">
-            <a:r>
-              <a:t/>
-            </a:r>
-          </a:p>
-          <a:p xmlns:a="http://schemas.openxmlformats.org/drawingml/2006/main">
-            <a:r>
-              <a:t>来源与边界：</a:t>
-            </a:r>
-          </a:p>
-          <a:p xmlns:a="http://schemas.openxmlformats.org/drawingml/2006/main">
-            <a:r>
-              <a:t>讲义 §三—四。</a:t>
-            </a:r>
-          </a:p>
-          <a:p xmlns:a="http://schemas.openxmlformats.org/drawingml/2006/main">
-            <a:r>
-              <a:t/>
-            </a:r>
-          </a:p>
-          <a:p xmlns:a="http://schemas.openxmlformats.org/drawingml/2006/main">
-            <a:r>
               <a:t>[Sources]</a:t>
             </a:r>
           </a:p>
           <a:p xmlns:a="http://schemas.openxmlformats.org/drawingml/2006/main">
             <a:r>
-              <a:t/>
-            </a:r>
-          </a:p>
-          <a:p xmlns:a="http://schemas.openxmlformats.org/drawingml/2006/main">
-            <a:r>
-              <a:t>- 本课 handout.md 与 slides.md</a:t>
-            </a:r>
-          </a:p>
-          <a:p xmlns:a="http://schemas.openxmlformats.org/drawingml/2006/main">
-            <a:r>
-              <a:t/>
-            </a:r>
-          </a:p>
-          <a:p xmlns:a="http://schemas.openxmlformats.org/drawingml/2006/main">
-            <a:r>
-              <a:t>- ../../course/reading-card-case.md</a:t>
-            </a:r>
-          </a:p>
-          <a:p xmlns:a="http://schemas.openxmlformats.org/drawingml/2006/main">
-            <a:r>
-              <a:t/>
+              <a:t>本课 handout.md、judgment-task.md；../../course/judgment-path.md。</a:t>
             </a:r>
           </a:p>
           <a:p xmlns:a="http://schemas.openxmlformats.org/drawingml/2006/main">
@@ -2967,7 +2002,7 @@
           </a:p>
           <a:p xmlns:a="http://schemas.openxmlformats.org/drawingml/2006/main">
             <a:r>
-              <a:t>讲义位置：本课讲义；见逐页母稿映射表</a:t>
+              <a:t>讲述与校准：</a:t>
             </a:r>
           </a:p>
           <a:p xmlns:a="http://schemas.openxmlformats.org/drawingml/2006/main">
@@ -2977,22 +2012,17 @@
           </a:p>
           <a:p xmlns:a="http://schemas.openxmlformats.org/drawingml/2006/main">
             <a:r>
-              <a:t>屏显核对：</a:t>
-            </a:r>
-          </a:p>
-          <a:p xmlns:a="http://schemas.openxmlformats.org/drawingml/2006/main">
-            <a:r>
-              <a:t>输入：固定同伴 A 的真实初稿；第二轮换同伴 B 或三人组轮转。</a:t>
-            </a:r>
-          </a:p>
-          <a:p xmlns:a="http://schemas.openxmlformats.org/drawingml/2006/main">
-            <a:r>
               <a:t/>
             </a:r>
           </a:p>
           <a:p xmlns:a="http://schemas.openxmlformats.org/drawingml/2006/main">
             <a:r>
-              <a:t>保存：peer-review.md。</a:t>
+              <a:t>学生动作：</a:t>
+            </a:r>
+          </a:p>
+          <a:p xmlns:a="http://schemas.openxmlformats.org/drawingml/2006/main">
+            <a:r>
+              <a:t>依据本页方法检查本人项目；按需参考。</a:t>
             </a:r>
           </a:p>
           <a:p xmlns:a="http://schemas.openxmlformats.org/drawingml/2006/main">
@@ -3002,7 +2032,7 @@
           </a:p>
           <a:p xmlns:a="http://schemas.openxmlformats.org/drawingml/2006/main">
             <a:r>
-              <a:t>完成样例（课程构造）：位置=结果段；观察=把待验证写成 stable；风险=证据强度越界；建议=降级并补替代解释。</a:t>
+              <a:t>课堂安排：按 teaching-plan.md 专用课堂时段安排；换场计入对应时段。</a:t>
             </a:r>
           </a:p>
           <a:p xmlns:a="http://schemas.openxmlformats.org/drawingml/2006/main">
@@ -3012,87 +2042,12 @@
           </a:p>
           <a:p xmlns:a="http://schemas.openxmlformats.org/drawingml/2006/main">
             <a:r>
-              <a:t>记录版本、位置、观察、风险与建议；只记录，不当场辩论。</a:t>
-            </a:r>
-          </a:p>
-          <a:p xmlns:a="http://schemas.openxmlformats.org/drawingml/2006/main">
-            <a:r>
-              <a:t/>
-            </a:r>
-          </a:p>
-          <a:p xmlns:a="http://schemas.openxmlformats.org/drawingml/2006/main">
-            <a:r>
-              <a:t>教师讲述：</a:t>
-            </a:r>
-          </a:p>
-          <a:p xmlns:a="http://schemas.openxmlformats.org/drawingml/2006/main">
-            <a:r>
-              <a:t>实践停留页。每轮结束时提醒交换角色；教师只纠正泛化反馈。</a:t>
-            </a:r>
-          </a:p>
-          <a:p xmlns:a="http://schemas.openxmlformats.org/drawingml/2006/main">
-            <a:r>
-              <a:t/>
-            </a:r>
-          </a:p>
-          <a:p xmlns:a="http://schemas.openxmlformats.org/drawingml/2006/main">
-            <a:r>
-              <a:t>学生动作：</a:t>
-            </a:r>
-          </a:p>
-          <a:p xmlns:a="http://schemas.openxmlformats.org/drawingml/2006/main">
-            <a:r>
-              <a:t/>
-            </a:r>
-          </a:p>
-          <a:p xmlns:a="http://schemas.openxmlformats.org/drawingml/2006/main">
-            <a:r>
-              <a:t/>
-            </a:r>
-          </a:p>
-          <a:p xmlns:a="http://schemas.openxmlformats.org/drawingml/2006/main">
-            <a:r>
-              <a:t>来源与边界：</a:t>
-            </a:r>
-          </a:p>
-          <a:p xmlns:a="http://schemas.openxmlformats.org/drawingml/2006/main">
-            <a:r>
-              <a:t>讲义 §三、练习 3；分组沿用第 8 课。</a:t>
-            </a:r>
-          </a:p>
-          <a:p xmlns:a="http://schemas.openxmlformats.org/drawingml/2006/main">
-            <a:r>
-              <a:t/>
-            </a:r>
-          </a:p>
-          <a:p xmlns:a="http://schemas.openxmlformats.org/drawingml/2006/main">
-            <a:r>
               <a:t>[Sources]</a:t>
             </a:r>
           </a:p>
           <a:p xmlns:a="http://schemas.openxmlformats.org/drawingml/2006/main">
             <a:r>
-              <a:t/>
-            </a:r>
-          </a:p>
-          <a:p xmlns:a="http://schemas.openxmlformats.org/drawingml/2006/main">
-            <a:r>
-              <a:t>- 本课 handout.md 与 slides.md</a:t>
-            </a:r>
-          </a:p>
-          <a:p xmlns:a="http://schemas.openxmlformats.org/drawingml/2006/main">
-            <a:r>
-              <a:t/>
-            </a:r>
-          </a:p>
-          <a:p xmlns:a="http://schemas.openxmlformats.org/drawingml/2006/main">
-            <a:r>
-              <a:t>- ../../course/reading-card-case.md</a:t>
-            </a:r>
-          </a:p>
-          <a:p xmlns:a="http://schemas.openxmlformats.org/drawingml/2006/main">
-            <a:r>
-              <a:t/>
+              <a:t>本课 handout.md、judgment-task.md；../../course/judgment-path.md。</a:t>
             </a:r>
           </a:p>
           <a:p xmlns:a="http://schemas.openxmlformats.org/drawingml/2006/main">
@@ -3177,7 +2132,7 @@
           </a:p>
           <a:p xmlns:a="http://schemas.openxmlformats.org/drawingml/2006/main">
             <a:r>
-              <a:t>讲义位置：本课讲义；见逐页母稿映射表</a:t>
+              <a:t>讲述与校准：</a:t>
             </a:r>
           </a:p>
           <a:p xmlns:a="http://schemas.openxmlformats.org/drawingml/2006/main">
@@ -3187,22 +2142,17 @@
           </a:p>
           <a:p xmlns:a="http://schemas.openxmlformats.org/drawingml/2006/main">
             <a:r>
-              <a:t>屏显核对：</a:t>
-            </a:r>
-          </a:p>
-          <a:p xmlns:a="http://schemas.openxmlformats.org/drawingml/2006/main">
-            <a:r>
-              <a:t>采纳：缺陷成立，直接修改。</a:t>
-            </a:r>
-          </a:p>
-          <a:p xmlns:a="http://schemas.openxmlformats.org/drawingml/2006/main">
-            <a:r>
               <a:t/>
             </a:r>
           </a:p>
           <a:p xmlns:a="http://schemas.openxmlformats.org/drawingml/2006/main">
             <a:r>
-              <a:t>澄清：已有内容被误读。</a:t>
+              <a:t>学生动作：</a:t>
+            </a:r>
+          </a:p>
+          <a:p xmlns:a="http://schemas.openxmlformats.org/drawingml/2006/main">
+            <a:r>
+              <a:t>依据本页方法检查本人项目；按需参考。</a:t>
             </a:r>
           </a:p>
           <a:p xmlns:a="http://schemas.openxmlformats.org/drawingml/2006/main">
@@ -3212,7 +2162,7 @@
           </a:p>
           <a:p xmlns:a="http://schemas.openxmlformats.org/drawingml/2006/main">
             <a:r>
-              <a:t>补证：需要新增证据或实验。</a:t>
+              <a:t>课堂安排：按 teaching-plan.md 专用课堂时段安排；换场计入对应时段。</a:t>
             </a:r>
           </a:p>
           <a:p xmlns:a="http://schemas.openxmlformats.org/drawingml/2006/main">
@@ -3222,107 +2172,12 @@
           </a:p>
           <a:p xmlns:a="http://schemas.openxmlformats.org/drawingml/2006/main">
             <a:r>
-              <a:t>保留异议：意见与证据或约束冲突。</a:t>
-            </a:r>
-          </a:p>
-          <a:p xmlns:a="http://schemas.openxmlformats.org/drawingml/2006/main">
-            <a:r>
-              <a:t/>
-            </a:r>
-          </a:p>
-          <a:p xmlns:a="http://schemas.openxmlformats.org/drawingml/2006/main">
-            <a:r>
-              <a:t>暂缓：当前条件不足，写阻塞、风险与复核点。</a:t>
-            </a:r>
-          </a:p>
-          <a:p xmlns:a="http://schemas.openxmlformats.org/drawingml/2006/main">
-            <a:r>
-              <a:t/>
-            </a:r>
-          </a:p>
-          <a:p xmlns:a="http://schemas.openxmlformats.org/drawingml/2006/main">
-            <a:r>
-              <a:t>不要求五类齐全，也不要求机械拒绝。</a:t>
-            </a:r>
-          </a:p>
-          <a:p xmlns:a="http://schemas.openxmlformats.org/drawingml/2006/main">
-            <a:r>
-              <a:t/>
-            </a:r>
-          </a:p>
-          <a:p xmlns:a="http://schemas.openxmlformats.org/drawingml/2006/main">
-            <a:r>
-              <a:t>教师讲述：</a:t>
-            </a:r>
-          </a:p>
-          <a:p xmlns:a="http://schemas.openxmlformats.org/drawingml/2006/main">
-            <a:r>
-              <a:t>暂缓不等于搁置：写明阻塞、风险和下次复核点。</a:t>
-            </a:r>
-          </a:p>
-          <a:p xmlns:a="http://schemas.openxmlformats.org/drawingml/2006/main">
-            <a:r>
-              <a:t/>
-            </a:r>
-          </a:p>
-          <a:p xmlns:a="http://schemas.openxmlformats.org/drawingml/2006/main">
-            <a:r>
-              <a:t>学生动作：</a:t>
-            </a:r>
-          </a:p>
-          <a:p xmlns:a="http://schemas.openxmlformats.org/drawingml/2006/main">
-            <a:r>
-              <a:t/>
-            </a:r>
-          </a:p>
-          <a:p xmlns:a="http://schemas.openxmlformats.org/drawingml/2006/main">
-            <a:r>
-              <a:t/>
-            </a:r>
-          </a:p>
-          <a:p xmlns:a="http://schemas.openxmlformats.org/drawingml/2006/main">
-            <a:r>
-              <a:t>来源与边界：</a:t>
-            </a:r>
-          </a:p>
-          <a:p xmlns:a="http://schemas.openxmlformats.org/drawingml/2006/main">
-            <a:r>
-              <a:t>讲义 §五；Booth et al. Ch. 9, 11。</a:t>
-            </a:r>
-          </a:p>
-          <a:p xmlns:a="http://schemas.openxmlformats.org/drawingml/2006/main">
-            <a:r>
-              <a:t/>
-            </a:r>
-          </a:p>
-          <a:p xmlns:a="http://schemas.openxmlformats.org/drawingml/2006/main">
-            <a:r>
               <a:t>[Sources]</a:t>
             </a:r>
           </a:p>
           <a:p xmlns:a="http://schemas.openxmlformats.org/drawingml/2006/main">
             <a:r>
-              <a:t/>
-            </a:r>
-          </a:p>
-          <a:p xmlns:a="http://schemas.openxmlformats.org/drawingml/2006/main">
-            <a:r>
-              <a:t>- 本课 handout.md 与 slides.md</a:t>
-            </a:r>
-          </a:p>
-          <a:p xmlns:a="http://schemas.openxmlformats.org/drawingml/2006/main">
-            <a:r>
-              <a:t/>
-            </a:r>
-          </a:p>
-          <a:p xmlns:a="http://schemas.openxmlformats.org/drawingml/2006/main">
-            <a:r>
-              <a:t>- ../../course/reading-card-case.md</a:t>
-            </a:r>
-          </a:p>
-          <a:p xmlns:a="http://schemas.openxmlformats.org/drawingml/2006/main">
-            <a:r>
-              <a:t/>
+              <a:t>本课 handout.md、judgment-task.md；../../course/judgment-path.md。</a:t>
             </a:r>
           </a:p>
           <a:p xmlns:a="http://schemas.openxmlformats.org/drawingml/2006/main">
@@ -3407,7 +2262,7 @@
           </a:p>
           <a:p xmlns:a="http://schemas.openxmlformats.org/drawingml/2006/main">
             <a:r>
-              <a:t>讲义位置：本课讲义；见逐页母稿映射表</a:t>
+              <a:t>讲述与校准：</a:t>
             </a:r>
           </a:p>
           <a:p xmlns:a="http://schemas.openxmlformats.org/drawingml/2006/main">
@@ -3417,22 +2272,17 @@
           </a:p>
           <a:p xmlns:a="http://schemas.openxmlformats.org/drawingml/2006/main">
             <a:r>
-              <a:t>屏显核对：</a:t>
-            </a:r>
-          </a:p>
-          <a:p xmlns:a="http://schemas.openxmlformats.org/drawingml/2006/main">
-            <a:r>
-              <a:t>课程虚构回应样例</a:t>
-            </a:r>
-          </a:p>
-          <a:p xmlns:a="http://schemas.openxmlformats.org/drawingml/2006/main">
-            <a:r>
               <a:t/>
             </a:r>
           </a:p>
           <a:p xmlns:a="http://schemas.openxmlformats.org/drawingml/2006/main">
             <a:r>
-              <a:t>动作：采纳；理由：当前证据不能排除替代解释。</a:t>
+              <a:t>学生动作：</a:t>
+            </a:r>
+          </a:p>
+          <a:p xmlns:a="http://schemas.openxmlformats.org/drawingml/2006/main">
+            <a:r>
+              <a:t>依据本页方法检查本人项目；按需参考。</a:t>
             </a:r>
           </a:p>
           <a:p xmlns:a="http://schemas.openxmlformats.org/drawingml/2006/main">
@@ -3442,7 +2292,7 @@
           </a:p>
           <a:p xmlns:a="http://schemas.openxmlformats.org/drawingml/2006/main">
             <a:r>
-              <a:t>边界：同一批 3 份构造源文本；依据：评价报告 §2。</a:t>
+              <a:t>课堂安排：按 teaching-plan.md 专用课堂时段安排；换场计入对应时段。</a:t>
             </a:r>
           </a:p>
           <a:p xmlns:a="http://schemas.openxmlformats.org/drawingml/2006/main">
@@ -3452,97 +2302,12 @@
           </a:p>
           <a:p xmlns:a="http://schemas.openxmlformats.org/drawingml/2006/main">
             <a:r>
-              <a:t>主张方向：Q1 包内一致、H1/A2 未决；工件：review；影响工件：report.md、结论追踪记录。</a:t>
-            </a:r>
-          </a:p>
-          <a:p xmlns:a="http://schemas.openxmlformats.org/drawingml/2006/main">
-            <a:r>
-              <a:t/>
-            </a:r>
-          </a:p>
-          <a:p xmlns:a="http://schemas.openxmlformats.org/drawingml/2006/main">
-            <a:r>
-              <a:t>回应写入 peer-review.md；优先级写入 revision-plan.md。</a:t>
-            </a:r>
-          </a:p>
-          <a:p xmlns:a="http://schemas.openxmlformats.org/drawingml/2006/main">
-            <a:r>
-              <a:t/>
-            </a:r>
-          </a:p>
-          <a:p xmlns:a="http://schemas.openxmlformats.org/drawingml/2006/main">
-            <a:r>
-              <a:t>教师讲述：</a:t>
-            </a:r>
-          </a:p>
-          <a:p xmlns:a="http://schemas.openxmlformats.org/drawingml/2006/main">
-            <a:r>
-              <a:t>实践停留页。作者处理收到的真实意见；不凑类别。</a:t>
-            </a:r>
-          </a:p>
-          <a:p xmlns:a="http://schemas.openxmlformats.org/drawingml/2006/main">
-            <a:r>
-              <a:t/>
-            </a:r>
-          </a:p>
-          <a:p xmlns:a="http://schemas.openxmlformats.org/drawingml/2006/main">
-            <a:r>
-              <a:t>学生动作：</a:t>
-            </a:r>
-          </a:p>
-          <a:p xmlns:a="http://schemas.openxmlformats.org/drawingml/2006/main">
-            <a:r>
-              <a:t/>
-            </a:r>
-          </a:p>
-          <a:p xmlns:a="http://schemas.openxmlformats.org/drawingml/2006/main">
-            <a:r>
-              <a:t/>
-            </a:r>
-          </a:p>
-          <a:p xmlns:a="http://schemas.openxmlformats.org/drawingml/2006/main">
-            <a:r>
-              <a:t>来源与边界：</a:t>
-            </a:r>
-          </a:p>
-          <a:p xmlns:a="http://schemas.openxmlformats.org/drawingml/2006/main">
-            <a:r>
-              <a:t>讲义 §五；模板文件。</a:t>
-            </a:r>
-          </a:p>
-          <a:p xmlns:a="http://schemas.openxmlformats.org/drawingml/2006/main">
-            <a:r>
-              <a:t/>
-            </a:r>
-          </a:p>
-          <a:p xmlns:a="http://schemas.openxmlformats.org/drawingml/2006/main">
-            <a:r>
               <a:t>[Sources]</a:t>
             </a:r>
           </a:p>
           <a:p xmlns:a="http://schemas.openxmlformats.org/drawingml/2006/main">
             <a:r>
-              <a:t/>
-            </a:r>
-          </a:p>
-          <a:p xmlns:a="http://schemas.openxmlformats.org/drawingml/2006/main">
-            <a:r>
-              <a:t>- 本课 handout.md 与 slides.md</a:t>
-            </a:r>
-          </a:p>
-          <a:p xmlns:a="http://schemas.openxmlformats.org/drawingml/2006/main">
-            <a:r>
-              <a:t/>
-            </a:r>
-          </a:p>
-          <a:p xmlns:a="http://schemas.openxmlformats.org/drawingml/2006/main">
-            <a:r>
-              <a:t>- ../../course/reading-card-case.md</a:t>
-            </a:r>
-          </a:p>
-          <a:p xmlns:a="http://schemas.openxmlformats.org/drawingml/2006/main">
-            <a:r>
-              <a:t/>
+              <a:t>本课 handout.md、judgment-task.md；../../course/judgment-path.md。</a:t>
             </a:r>
           </a:p>
           <a:p xmlns:a="http://schemas.openxmlformats.org/drawingml/2006/main">
@@ -5479,35 +4244,55 @@
       </p:grpSpPr>
       <p:sp>
         <p:nvSpPr>
-          <p:cNvPr id="4" name="Text Placeholder 3">
-            <a:extLst xmlns:a="http://schemas.openxmlformats.org/drawingml/2006/main">
-              <a:ext uri="{FF2B5EF4-FFF2-40B4-BE49-F238E27FC236}">
-                <a16:creationId xmlns:a16="http://schemas.microsoft.com/office/drawing/2014/main" id="{4D941B40-7A0A-534E-3563-CA11753C8E3F}"/>
-              </a:ext>
-            </a:extLst>
-          </p:cNvPr>
-          <p:cNvSpPr>
-            <a:spLocks xmlns:a="http://schemas.openxmlformats.org/drawingml/2006/main" noGrp="1"/>
-          </p:cNvSpPr>
-          <p:nvPr>
-            <p:ph type="body" idx="14"/>
-          </p:nvPr>
-        </p:nvSpPr>
-        <p:spPr>
-          <a:xfrm xmlns:a="http://schemas.openxmlformats.org/drawingml/2006/main">
-            <a:off x="1028700" y="57150"/>
-            <a:ext cx="10668000" cy="571500"/>
-          </a:xfrm>
-        </p:spPr>
-        <p:txBody>
-          <a:bodyPr xmlns:a="http://schemas.openxmlformats.org/drawingml/2006/main" lIns="0" tIns="0" rIns="0" bIns="0" anchor="ctr"/>
-          <a:lstStyle xmlns:a="http://schemas.openxmlformats.org/drawingml/2006/main"/>
+          <p:cNvPr id="7" name="judgment-title">
+            <a:extLst xmlns:a="http://schemas.openxmlformats.org/drawingml/2006/main">
+              <a:ext uri="{FF2B5EF4-FFF2-40B4-BE49-F238E27FC236}">
+                <a16:creationId xmlns:a16="http://schemas.microsoft.com/office/drawing/2014/main" id="{38D8EBAA-C889-4DC1-A1A1-D806DA4F3F2A}"/>
+              </a:ext>
+            </a:extLst>
+          </p:cNvPr>
+          <p:cNvSpPr>
+            <a:spLocks xmlns:a="http://schemas.openxmlformats.org/drawingml/2006/main" noGrp="1"/>
+          </p:cNvSpPr>
+          <p:nvPr/>
+        </p:nvSpPr>
+        <p:spPr>
+          <a:xfrm xmlns:a="http://schemas.openxmlformats.org/drawingml/2006/main">
+            <a:off x="1028700" y="76200"/>
+            <a:ext cx="10687050" cy="514350"/>
+          </a:xfrm>
+          <a:prstGeom xmlns:a="http://schemas.openxmlformats.org/drawingml/2006/main" prst="rect">
+            <a:avLst/>
+          </a:prstGeom>
+          <a:noFill xmlns:a="http://schemas.openxmlformats.org/drawingml/2006/main"/>
+          <a:ln xmlns:a="http://schemas.openxmlformats.org/drawingml/2006/main" w="0">
+            <a:noFill/>
+          </a:ln>
+        </p:spPr>
+        <p:txBody>
+          <a:bodyPr xmlns:a="http://schemas.openxmlformats.org/drawingml/2006/main" lIns="0" tIns="0" rIns="0" bIns="0" anchor="t"/>
+          <a:lstStyle xmlns:a="http://schemas.openxmlformats.org/drawingml/2006/main">
+            <a:defPPr algn="l">
+              <a:defRPr sz="3000" b="1">
+                <a:solidFill>
+                  <a:srgbClr val="FFFFFF"/>
+                </a:solidFill>
+                <a:latin typeface="微软雅黑"/>
+                <a:ea typeface="微软雅黑"/>
+                <a:cs typeface="微软雅黑"/>
+              </a:defRPr>
+            </a:defPPr>
+          </a:lstStyle>
           <a:p xmlns:a="http://schemas.openxmlformats.org/drawingml/2006/main">
             <a:pPr algn="l">
-              <a:lnSpc>
-                <a:spcPct val="118000"/>
-              </a:lnSpc>
-              <a:buNone/>
+              <a:defRPr sz="3000" b="1">
+                <a:solidFill>
+                  <a:srgbClr val="FFFFFF"/>
+                </a:solidFill>
+                <a:latin typeface="微软雅黑"/>
+                <a:ea typeface="微软雅黑"/>
+                <a:cs typeface="微软雅黑"/>
+              </a:defRPr>
             </a:pPr>
             <a:r>
               <a:rPr sz="3000" b="1">
@@ -5518,385 +4303,337 @@
                 <a:ea typeface="微软雅黑"/>
                 <a:cs typeface="微软雅黑"/>
               </a:rPr>
-              <a:t>现在修改最可能卡门的一项</a:t>
-            </a:r>
-            <a:endParaRPr/>
-          </a:p>
-        </p:txBody>
-      </p:sp>
-      <p:sp>
-        <p:nvSpPr>
-          <p:cNvPr id="5" name="Slide Number Placeholder 4">
-            <a:extLst xmlns:a="http://schemas.openxmlformats.org/drawingml/2006/main">
-              <a:ext uri="{FF2B5EF4-FFF2-40B4-BE49-F238E27FC236}">
-                <a16:creationId xmlns:a16="http://schemas.microsoft.com/office/drawing/2014/main" id="{EBA5909F-738E-F60C-BE8C-B3F1D94548E5}"/>
-              </a:ext>
-            </a:extLst>
-          </p:cNvPr>
-          <p:cNvSpPr>
-            <a:spLocks xmlns:a="http://schemas.openxmlformats.org/drawingml/2006/main" noGrp="1"/>
-          </p:cNvSpPr>
-          <p:nvPr>
-            <p:ph type="sldNum" idx="10"/>
-          </p:nvPr>
-        </p:nvSpPr>
-        <p:spPr/>
-        <p:txBody>
-          <a:bodyPr xmlns:a="http://schemas.openxmlformats.org/drawingml/2006/main"/>
-          <a:lstStyle xmlns:a="http://schemas.openxmlformats.org/drawingml/2006/main"/>
-          <a:p xmlns:a="http://schemas.openxmlformats.org/drawingml/2006/main">
-            <a:fld id="{DB7BEEEC-A170-5376-2B6E-CB54687B0CB1}" type="slidenum">
+              <a:t>本人项目：决定、核验与回写</a:t>
+            </a:r>
+          </a:p>
+        </p:txBody>
+      </p:sp>
+      <p:sp>
+        <p:nvSpPr>
+          <p:cNvPr id="2" name="judgment-body-0">
+            <a:extLst xmlns:a="http://schemas.openxmlformats.org/drawingml/2006/main">
+              <a:ext uri="{FF2B5EF4-FFF2-40B4-BE49-F238E27FC236}">
+                <a16:creationId xmlns:a16="http://schemas.microsoft.com/office/drawing/2014/main" id="{5F7D3881-668A-487A-AB4A-A677B3BB492A}"/>
+              </a:ext>
+            </a:extLst>
+          </p:cNvPr>
+          <p:cNvSpPr>
+            <a:spLocks xmlns:a="http://schemas.openxmlformats.org/drawingml/2006/main" noGrp="1"/>
+          </p:cNvSpPr>
+          <p:nvPr/>
+        </p:nvSpPr>
+        <p:spPr>
+          <a:xfrm xmlns:a="http://schemas.openxmlformats.org/drawingml/2006/main">
+            <a:off x="666750" y="1066800"/>
+            <a:ext cx="10858500" cy="1476375"/>
+          </a:xfrm>
+          <a:prstGeom xmlns:a="http://schemas.openxmlformats.org/drawingml/2006/main" prst="rect">
+            <a:avLst/>
+          </a:prstGeom>
+          <a:noFill xmlns:a="http://schemas.openxmlformats.org/drawingml/2006/main"/>
+          <a:ln xmlns:a="http://schemas.openxmlformats.org/drawingml/2006/main" w="0">
+            <a:noFill/>
+          </a:ln>
+        </p:spPr>
+        <p:txBody>
+          <a:bodyPr xmlns:a="http://schemas.openxmlformats.org/drawingml/2006/main" lIns="0" tIns="0" rIns="0" bIns="0" anchor="t"/>
+          <a:lstStyle xmlns:a="http://schemas.openxmlformats.org/drawingml/2006/main">
+            <a:defPPr algn="l">
+              <a:defRPr sz="2400" b="0">
+                <a:solidFill>
+                  <a:srgbClr val="263746"/>
+                </a:solidFill>
+                <a:latin typeface="微软雅黑"/>
+                <a:ea typeface="微软雅黑"/>
+                <a:cs typeface="微软雅黑"/>
+              </a:defRPr>
+            </a:defPPr>
+          </a:lstStyle>
+          <a:p xmlns:a="http://schemas.openxmlformats.org/drawingml/2006/main">
+            <a:pPr algn="l">
+              <a:defRPr sz="2400" b="0">
+                <a:solidFill>
+                  <a:srgbClr val="263746"/>
+                </a:solidFill>
+                <a:latin typeface="微软雅黑"/>
+                <a:ea typeface="微软雅黑"/>
+                <a:cs typeface="微软雅黑"/>
+              </a:defRPr>
+            </a:pPr>
+            <a:r>
+              <a:rPr sz="2400" b="0">
+                <a:solidFill>
+                  <a:srgbClr val="263746"/>
+                </a:solidFill>
+                <a:latin typeface="微软雅黑"/>
+                <a:ea typeface="微软雅黑"/>
+                <a:cs typeface="微软雅黑"/>
+              </a:rPr>
+              <a:t>保留两轮真实互评和现场修改。作者对意见接受、澄清、补证、保留异议或暂缓，至少完成一项影响论证的实际修订。</a:t>
+            </a:r>
+          </a:p>
+        </p:txBody>
+      </p:sp>
+      <p:sp>
+        <p:nvSpPr>
+          <p:cNvPr id="3" name="judgment-body-1">
+            <a:extLst xmlns:a="http://schemas.openxmlformats.org/drawingml/2006/main">
+              <a:ext uri="{FF2B5EF4-FFF2-40B4-BE49-F238E27FC236}">
+                <a16:creationId xmlns:a16="http://schemas.microsoft.com/office/drawing/2014/main" id="{911509BA-F02E-416E-B23B-10AA36468D45}"/>
+              </a:ext>
+            </a:extLst>
+          </p:cNvPr>
+          <p:cNvSpPr>
+            <a:spLocks xmlns:a="http://schemas.openxmlformats.org/drawingml/2006/main" noGrp="1"/>
+          </p:cNvSpPr>
+          <p:nvPr/>
+        </p:nvSpPr>
+        <p:spPr>
+          <a:xfrm xmlns:a="http://schemas.openxmlformats.org/drawingml/2006/main">
+            <a:off x="666750" y="2724150"/>
+            <a:ext cx="10858500" cy="1524000"/>
+          </a:xfrm>
+          <a:prstGeom xmlns:a="http://schemas.openxmlformats.org/drawingml/2006/main" prst="rect">
+            <a:avLst/>
+          </a:prstGeom>
+          <a:noFill xmlns:a="http://schemas.openxmlformats.org/drawingml/2006/main"/>
+          <a:ln xmlns:a="http://schemas.openxmlformats.org/drawingml/2006/main" w="0">
+            <a:noFill/>
+          </a:ln>
+        </p:spPr>
+        <p:txBody>
+          <a:bodyPr xmlns:a="http://schemas.openxmlformats.org/drawingml/2006/main" lIns="0" tIns="0" rIns="0" bIns="0" anchor="t"/>
+          <a:lstStyle xmlns:a="http://schemas.openxmlformats.org/drawingml/2006/main">
+            <a:defPPr algn="l">
+              <a:defRPr sz="2400" b="0">
+                <a:solidFill>
+                  <a:srgbClr val="263746"/>
+                </a:solidFill>
+                <a:latin typeface="微软雅黑"/>
+                <a:ea typeface="微软雅黑"/>
+                <a:cs typeface="微软雅黑"/>
+              </a:defRPr>
+            </a:defPPr>
+          </a:lstStyle>
+          <a:p xmlns:a="http://schemas.openxmlformats.org/drawingml/2006/main">
+            <a:pPr algn="l">
+              <a:defRPr sz="2400" b="0">
+                <a:solidFill>
+                  <a:srgbClr val="263746"/>
+                </a:solidFill>
+                <a:latin typeface="微软雅黑"/>
+                <a:ea typeface="微软雅黑"/>
+                <a:cs typeface="微软雅黑"/>
+              </a:defRPr>
+            </a:pPr>
+            <a:r>
+              <a:rPr sz="2400" b="0">
+                <a:solidFill>
+                  <a:srgbClr val="263746"/>
+                </a:solidFill>
+                <a:latin typeface="微软雅黑"/>
+                <a:ea typeface="微软雅黑"/>
+                <a:cs typeface="微软雅黑"/>
+              </a:rPr>
+              <a:t>检查正文与表格、追踪记录、状态同时更新；真实意见逐条回应，处理类别不凑数；剩余缺口在 L16 抽查中可解释。</a:t>
+            </a:r>
+          </a:p>
+        </p:txBody>
+      </p:sp>
+      <p:sp>
+        <p:nvSpPr>
+          <p:cNvPr id="4" name="judgment-body-2">
+            <a:extLst xmlns:a="http://schemas.openxmlformats.org/drawingml/2006/main">
+              <a:ext uri="{FF2B5EF4-FFF2-40B4-BE49-F238E27FC236}">
+                <a16:creationId xmlns:a16="http://schemas.microsoft.com/office/drawing/2014/main" id="{9854EBBC-AEF7-4876-A9BF-E79E3B2B494F}"/>
+              </a:ext>
+            </a:extLst>
+          </p:cNvPr>
+          <p:cNvSpPr>
+            <a:spLocks xmlns:a="http://schemas.openxmlformats.org/drawingml/2006/main" noGrp="1"/>
+          </p:cNvSpPr>
+          <p:nvPr/>
+        </p:nvSpPr>
+        <p:spPr>
+          <a:xfrm xmlns:a="http://schemas.openxmlformats.org/drawingml/2006/main">
+            <a:off x="666750" y="4457700"/>
+            <a:ext cx="10858500" cy="1466850"/>
+          </a:xfrm>
+          <a:prstGeom xmlns:a="http://schemas.openxmlformats.org/drawingml/2006/main" prst="rect">
+            <a:avLst/>
+          </a:prstGeom>
+          <a:noFill xmlns:a="http://schemas.openxmlformats.org/drawingml/2006/main"/>
+          <a:ln xmlns:a="http://schemas.openxmlformats.org/drawingml/2006/main" w="0">
+            <a:noFill/>
+          </a:ln>
+        </p:spPr>
+        <p:txBody>
+          <a:bodyPr xmlns:a="http://schemas.openxmlformats.org/drawingml/2006/main" lIns="0" tIns="0" rIns="0" bIns="0" anchor="t"/>
+          <a:lstStyle xmlns:a="http://schemas.openxmlformats.org/drawingml/2006/main">
+            <a:defPPr algn="l">
+              <a:defRPr sz="2200" b="0">
+                <a:solidFill>
+                  <a:srgbClr val="1F4D78"/>
+                </a:solidFill>
+                <a:latin typeface="微软雅黑"/>
+                <a:ea typeface="微软雅黑"/>
+                <a:cs typeface="微软雅黑"/>
+              </a:defRPr>
+            </a:defPPr>
+          </a:lstStyle>
+          <a:p xmlns:a="http://schemas.openxmlformats.org/drawingml/2006/main">
+            <a:pPr algn="l">
+              <a:defRPr sz="2200" b="0">
+                <a:solidFill>
+                  <a:srgbClr val="1F4D78"/>
+                </a:solidFill>
+                <a:latin typeface="微软雅黑"/>
+                <a:ea typeface="微软雅黑"/>
+                <a:cs typeface="微软雅黑"/>
+              </a:defRPr>
+            </a:pPr>
+            <a:r>
+              <a:rPr sz="2200" b="0">
+                <a:solidFill>
+                  <a:srgbClr val="1F4D78"/>
+                </a:solidFill>
+                <a:latin typeface="微软雅黑"/>
+                <a:ea typeface="微软雅黑"/>
+                <a:cs typeface="微软雅黑"/>
+              </a:rPr>
+              <a:t>保存：真实评审意见、处理理由、实际 diff 与论证门预检</a:t>
+            </a:r>
+          </a:p>
+        </p:txBody>
+      </p:sp>
+      <p:sp>
+        <p:nvSpPr>
+          <p:cNvPr id="5" name="judgment-source">
+            <a:extLst xmlns:a="http://schemas.openxmlformats.org/drawingml/2006/main">
+              <a:ext uri="{FF2B5EF4-FFF2-40B4-BE49-F238E27FC236}">
+                <a16:creationId xmlns:a16="http://schemas.microsoft.com/office/drawing/2014/main" id="{255FBC3D-A212-4073-B2FF-6A3152AF5C41}"/>
+              </a:ext>
+            </a:extLst>
+          </p:cNvPr>
+          <p:cNvSpPr>
+            <a:spLocks xmlns:a="http://schemas.openxmlformats.org/drawingml/2006/main" noGrp="1"/>
+          </p:cNvSpPr>
+          <p:nvPr/>
+        </p:nvSpPr>
+        <p:spPr>
+          <a:xfrm xmlns:a="http://schemas.openxmlformats.org/drawingml/2006/main">
+            <a:off x="666750" y="6276975"/>
+            <a:ext cx="10572750" cy="209550"/>
+          </a:xfrm>
+          <a:prstGeom xmlns:a="http://schemas.openxmlformats.org/drawingml/2006/main" prst="rect">
+            <a:avLst/>
+          </a:prstGeom>
+          <a:noFill xmlns:a="http://schemas.openxmlformats.org/drawingml/2006/main"/>
+          <a:ln xmlns:a="http://schemas.openxmlformats.org/drawingml/2006/main" w="0">
+            <a:noFill/>
+          </a:ln>
+        </p:spPr>
+        <p:txBody>
+          <a:bodyPr xmlns:a="http://schemas.openxmlformats.org/drawingml/2006/main" lIns="0" tIns="0" rIns="0" bIns="0" anchor="t"/>
+          <a:lstStyle xmlns:a="http://schemas.openxmlformats.org/drawingml/2006/main">
+            <a:defPPr algn="l">
+              <a:defRPr sz="1100" b="0">
+                <a:solidFill>
+                  <a:srgbClr val="667684"/>
+                </a:solidFill>
+                <a:latin typeface="微软雅黑"/>
+                <a:ea typeface="微软雅黑"/>
+                <a:cs typeface="微软雅黑"/>
+              </a:defRPr>
+            </a:defPPr>
+          </a:lstStyle>
+          <a:p xmlns:a="http://schemas.openxmlformats.org/drawingml/2006/main">
+            <a:pPr algn="l">
+              <a:defRPr sz="1100" b="0">
+                <a:solidFill>
+                  <a:srgbClr val="667684"/>
+                </a:solidFill>
+                <a:latin typeface="微软雅黑"/>
+                <a:ea typeface="微软雅黑"/>
+                <a:cs typeface="微软雅黑"/>
+              </a:defRPr>
+            </a:pPr>
+            <a:r>
+              <a:rPr sz="1100" b="0">
+                <a:solidFill>
+                  <a:srgbClr val="667684"/>
+                </a:solidFill>
+                <a:latin typeface="微软雅黑"/>
+                <a:ea typeface="微软雅黑"/>
+                <a:cs typeface="微软雅黑"/>
+              </a:rPr>
+              <a:t>来源：本课判断任务与讲义；构造材料及真实来源按材料包标识</a:t>
+            </a:r>
+          </a:p>
+        </p:txBody>
+      </p:sp>
+      <p:sp>
+        <p:nvSpPr>
+          <p:cNvPr id="6" name="judgment-page">
+            <a:extLst xmlns:a="http://schemas.openxmlformats.org/drawingml/2006/main">
+              <a:ext uri="{FF2B5EF4-FFF2-40B4-BE49-F238E27FC236}">
+                <a16:creationId xmlns:a16="http://schemas.microsoft.com/office/drawing/2014/main" id="{07EBA216-9E69-4B77-8487-26732FC06FB8}"/>
+              </a:ext>
+            </a:extLst>
+          </p:cNvPr>
+          <p:cNvSpPr>
+            <a:spLocks xmlns:a="http://schemas.openxmlformats.org/drawingml/2006/main" noGrp="1"/>
+          </p:cNvSpPr>
+          <p:nvPr/>
+        </p:nvSpPr>
+        <p:spPr>
+          <a:xfrm xmlns:a="http://schemas.openxmlformats.org/drawingml/2006/main">
+            <a:off x="11715750" y="6562725"/>
+            <a:ext cx="238125" cy="171450"/>
+          </a:xfrm>
+          <a:prstGeom xmlns:a="http://schemas.openxmlformats.org/drawingml/2006/main" prst="rect">
+            <a:avLst/>
+          </a:prstGeom>
+          <a:noFill xmlns:a="http://schemas.openxmlformats.org/drawingml/2006/main"/>
+          <a:ln xmlns:a="http://schemas.openxmlformats.org/drawingml/2006/main" w="0">
+            <a:noFill/>
+          </a:ln>
+        </p:spPr>
+        <p:txBody>
+          <a:bodyPr xmlns:a="http://schemas.openxmlformats.org/drawingml/2006/main" lIns="0" tIns="0" rIns="0" bIns="0" anchor="t"/>
+          <a:lstStyle xmlns:a="http://schemas.openxmlformats.org/drawingml/2006/main">
+            <a:defPPr algn="l">
+              <a:defRPr sz="900" b="0">
+                <a:solidFill>
+                  <a:srgbClr val="A5A5A5"/>
+                </a:solidFill>
+                <a:latin typeface="微软雅黑"/>
+                <a:ea typeface="微软雅黑"/>
+                <a:cs typeface="微软雅黑"/>
+              </a:defRPr>
+            </a:defPPr>
+          </a:lstStyle>
+          <a:p xmlns:a="http://schemas.openxmlformats.org/drawingml/2006/main">
+            <a:pPr algn="l">
+              <a:defRPr sz="900" b="0">
+                <a:solidFill>
+                  <a:srgbClr val="A5A5A5"/>
+                </a:solidFill>
+                <a:latin typeface="微软雅黑"/>
+                <a:ea typeface="微软雅黑"/>
+                <a:cs typeface="微软雅黑"/>
+              </a:defRPr>
+            </a:pPr>
+            <a:r>
+              <a:rPr sz="900" b="0">
+                <a:solidFill>
+                  <a:srgbClr val="A5A5A5"/>
+                </a:solidFill>
+                <a:latin typeface="微软雅黑"/>
+                <a:ea typeface="微软雅黑"/>
+                <a:cs typeface="微软雅黑"/>
+              </a:rPr>
               <a:t>10</a:t>
-            </a:fld>
-            <a:endParaRPr/>
-          </a:p>
-        </p:txBody>
-      </p:sp>
-      <p:sp>
-        <p:nvSpPr>
-          <p:cNvPr id="6" name="content-216">
-            <a:extLst xmlns:a="http://schemas.openxmlformats.org/drawingml/2006/main">
-              <a:ext uri="{FF2B5EF4-FFF2-40B4-BE49-F238E27FC236}">
-                <a16:creationId xmlns:a16="http://schemas.microsoft.com/office/drawing/2014/main" id="{1DADE4D9-19F5-4549-92C4-F385C156DA95}"/>
-              </a:ext>
-            </a:extLst>
-          </p:cNvPr>
-          <p:cNvSpPr>
-            <a:spLocks xmlns:a="http://schemas.openxmlformats.org/drawingml/2006/main" noGrp="1"/>
-          </p:cNvSpPr>
-          <p:nvPr/>
-        </p:nvSpPr>
-        <p:spPr>
-          <a:xfrm xmlns:a="http://schemas.openxmlformats.org/drawingml/2006/main">
-            <a:off x="609600" y="1009650"/>
-            <a:ext cx="10972800" cy="342900"/>
-          </a:xfrm>
-          <a:prstGeom xmlns:a="http://schemas.openxmlformats.org/drawingml/2006/main" prst="rect">
-            <a:avLst/>
-          </a:prstGeom>
-          <a:noFill xmlns:a="http://schemas.openxmlformats.org/drawingml/2006/main"/>
-          <a:ln xmlns:a="http://schemas.openxmlformats.org/drawingml/2006/main" w="0">
-            <a:noFill/>
-          </a:ln>
-        </p:spPr>
-        <p:txBody>
-          <a:bodyPr xmlns:a="http://schemas.openxmlformats.org/drawingml/2006/main" lIns="0" tIns="0" rIns="0" bIns="0" anchor="t"/>
-          <a:lstStyle xmlns:a="http://schemas.openxmlformats.org/drawingml/2006/main"/>
-          <a:p xmlns:a="http://schemas.openxmlformats.org/drawingml/2006/main">
-            <a:pPr algn="l">
-              <a:lnSpc>
-                <a:spcPct val="118000"/>
-              </a:lnSpc>
-              <a:buNone/>
-              <a:defRPr sz="1800" b="0">
-                <a:solidFill>
-                  <a:srgbClr val="A96510"/>
-                </a:solidFill>
-                <a:latin typeface="微软雅黑"/>
-                <a:ea typeface="微软雅黑"/>
-                <a:cs typeface="微软雅黑"/>
-              </a:defRPr>
-            </a:pPr>
-            <a:r>
-              <a:rPr sz="1800" b="0">
-                <a:solidFill>
-                  <a:srgbClr val="A96510"/>
-                </a:solidFill>
-                <a:latin typeface="微软雅黑"/>
-                <a:ea typeface="微软雅黑"/>
-                <a:cs typeface="微软雅黑"/>
-              </a:rPr>
-              <a:t>课程虚构稿件的实际文本修改示范</a:t>
-            </a:r>
-          </a:p>
-        </p:txBody>
-      </p:sp>
-      <p:sp>
-        <p:nvSpPr>
-          <p:cNvPr id="7" name="content-217">
-            <a:extLst xmlns:a="http://schemas.openxmlformats.org/drawingml/2006/main">
-              <a:ext uri="{FF2B5EF4-FFF2-40B4-BE49-F238E27FC236}">
-                <a16:creationId xmlns:a16="http://schemas.microsoft.com/office/drawing/2014/main" id="{4E2E4DA3-B993-464E-B5C6-24AC426F0266}"/>
-              </a:ext>
-            </a:extLst>
-          </p:cNvPr>
-          <p:cNvSpPr>
-            <a:spLocks xmlns:a="http://schemas.openxmlformats.org/drawingml/2006/main" noGrp="1"/>
-          </p:cNvSpPr>
-          <p:nvPr/>
-        </p:nvSpPr>
-        <p:spPr>
-          <a:xfrm xmlns:a="http://schemas.openxmlformats.org/drawingml/2006/main">
-            <a:off x="609600" y="1771650"/>
-            <a:ext cx="10972800" cy="619125"/>
-          </a:xfrm>
-          <a:prstGeom xmlns:a="http://schemas.openxmlformats.org/drawingml/2006/main" prst="rect">
-            <a:avLst/>
-          </a:prstGeom>
-          <a:noFill xmlns:a="http://schemas.openxmlformats.org/drawingml/2006/main"/>
-          <a:ln xmlns:a="http://schemas.openxmlformats.org/drawingml/2006/main" w="0">
-            <a:noFill/>
-          </a:ln>
-        </p:spPr>
-        <p:txBody>
-          <a:bodyPr xmlns:a="http://schemas.openxmlformats.org/drawingml/2006/main" lIns="0" tIns="0" rIns="0" bIns="0" anchor="t"/>
-          <a:lstStyle xmlns:a="http://schemas.openxmlformats.org/drawingml/2006/main"/>
-          <a:p xmlns:a="http://schemas.openxmlformats.org/drawingml/2006/main">
-            <a:pPr algn="l">
-              <a:lnSpc>
-                <a:spcPct val="118000"/>
-              </a:lnSpc>
-              <a:buNone/>
-              <a:defRPr sz="2600" b="0">
-                <a:solidFill>
-                  <a:srgbClr val="C8161E"/>
-                </a:solidFill>
-                <a:latin typeface="微软雅黑"/>
-                <a:ea typeface="微软雅黑"/>
-                <a:cs typeface="微软雅黑"/>
-              </a:defRPr>
-            </a:pPr>
-            <a:r>
-              <a:rPr sz="2600" b="0">
-                <a:solidFill>
-                  <a:srgbClr val="C8161E"/>
-                </a:solidFill>
-                <a:latin typeface="微软雅黑"/>
-                <a:ea typeface="微软雅黑"/>
-                <a:cs typeface="微软雅黑"/>
-              </a:rPr>
-              <a:t>− 阅读卡机制已证实，状态 stable。</a:t>
-            </a:r>
-          </a:p>
-        </p:txBody>
-      </p:sp>
-      <p:sp>
-        <p:nvSpPr>
-          <p:cNvPr id="8" name="content-218">
-            <a:extLst xmlns:a="http://schemas.openxmlformats.org/drawingml/2006/main">
-              <a:ext uri="{FF2B5EF4-FFF2-40B4-BE49-F238E27FC236}">
-                <a16:creationId xmlns:a16="http://schemas.microsoft.com/office/drawing/2014/main" id="{5B0EAEB4-CC8D-4FEC-A4CD-A179646D1671}"/>
-              </a:ext>
-            </a:extLst>
-          </p:cNvPr>
-          <p:cNvSpPr>
-            <a:spLocks xmlns:a="http://schemas.openxmlformats.org/drawingml/2006/main" noGrp="1"/>
-          </p:cNvSpPr>
-          <p:nvPr/>
-        </p:nvSpPr>
-        <p:spPr>
-          <a:xfrm xmlns:a="http://schemas.openxmlformats.org/drawingml/2006/main">
-            <a:off x="609600" y="2695575"/>
-            <a:ext cx="10972800" cy="1190625"/>
-          </a:xfrm>
-          <a:prstGeom xmlns:a="http://schemas.openxmlformats.org/drawingml/2006/main" prst="rect">
-            <a:avLst/>
-          </a:prstGeom>
-          <a:noFill xmlns:a="http://schemas.openxmlformats.org/drawingml/2006/main"/>
-          <a:ln xmlns:a="http://schemas.openxmlformats.org/drawingml/2006/main" w="0">
-            <a:noFill/>
-          </a:ln>
-        </p:spPr>
-        <p:txBody>
-          <a:bodyPr xmlns:a="http://schemas.openxmlformats.org/drawingml/2006/main" lIns="0" tIns="0" rIns="0" bIns="0" anchor="t"/>
-          <a:lstStyle xmlns:a="http://schemas.openxmlformats.org/drawingml/2006/main"/>
-          <a:p xmlns:a="http://schemas.openxmlformats.org/drawingml/2006/main">
-            <a:pPr algn="l">
-              <a:lnSpc>
-                <a:spcPct val="118000"/>
-              </a:lnSpc>
-              <a:buNone/>
-              <a:defRPr sz="2600" b="0">
-                <a:solidFill>
-                  <a:srgbClr val="1F4D78"/>
-                </a:solidFill>
-                <a:latin typeface="微软雅黑"/>
-                <a:ea typeface="微软雅黑"/>
-                <a:cs typeface="微软雅黑"/>
-              </a:defRPr>
-            </a:pPr>
-            <a:r>
-              <a:rPr sz="2600" b="0">
-                <a:solidFill>
-                  <a:srgbClr val="1F4D78"/>
-                </a:solidFill>
-                <a:latin typeface="微软雅黑"/>
-                <a:ea typeface="微软雅黑"/>
-                <a:cs typeface="微软雅黑"/>
-              </a:rPr>
-              <a:t>+ 本构造包中总遗漏率较低，方向与 Q1 一致。</a:t>
-            </a:r>
-          </a:p>
-          <a:p xmlns:a="http://schemas.openxmlformats.org/drawingml/2006/main">
-            <a:pPr algn="l">
-              <a:lnSpc>
-                <a:spcPct val="118000"/>
-              </a:lnSpc>
-              <a:buNone/>
-              <a:defRPr sz="2600" b="0">
-                <a:solidFill>
-                  <a:srgbClr val="1F4D78"/>
-                </a:solidFill>
-                <a:latin typeface="微软雅黑"/>
-                <a:ea typeface="微软雅黑"/>
-                <a:cs typeface="微软雅黑"/>
-              </a:defRPr>
-            </a:pPr>
-            <a:r>
-              <a:rPr sz="2600" b="0">
-                <a:solidFill>
-                  <a:srgbClr val="1F4D78"/>
-                </a:solidFill>
-                <a:latin typeface="微软雅黑"/>
-                <a:ea typeface="微软雅黑"/>
-                <a:cs typeface="微软雅黑"/>
-              </a:rPr>
-              <a:t>   H1/A2 未区分，其他质量未测，范围受限。</a:t>
-            </a:r>
-          </a:p>
-        </p:txBody>
-      </p:sp>
-      <p:sp>
-        <p:nvSpPr>
-          <p:cNvPr id="9" name="content-219">
-            <a:extLst xmlns:a="http://schemas.openxmlformats.org/drawingml/2006/main">
-              <a:ext uri="{FF2B5EF4-FFF2-40B4-BE49-F238E27FC236}">
-                <a16:creationId xmlns:a16="http://schemas.microsoft.com/office/drawing/2014/main" id="{77BF3809-82DB-4222-AB06-0F9149DA6109}"/>
-              </a:ext>
-            </a:extLst>
-          </p:cNvPr>
-          <p:cNvSpPr>
-            <a:spLocks xmlns:a="http://schemas.openxmlformats.org/drawingml/2006/main" noGrp="1"/>
-          </p:cNvSpPr>
-          <p:nvPr/>
-        </p:nvSpPr>
-        <p:spPr>
-          <a:xfrm xmlns:a="http://schemas.openxmlformats.org/drawingml/2006/main">
-            <a:off x="609600" y="4295775"/>
-            <a:ext cx="10972800" cy="523875"/>
-          </a:xfrm>
-          <a:prstGeom xmlns:a="http://schemas.openxmlformats.org/drawingml/2006/main" prst="rect">
-            <a:avLst/>
-          </a:prstGeom>
-          <a:noFill xmlns:a="http://schemas.openxmlformats.org/drawingml/2006/main"/>
-          <a:ln xmlns:a="http://schemas.openxmlformats.org/drawingml/2006/main" w="0">
-            <a:noFill/>
-          </a:ln>
-        </p:spPr>
-        <p:txBody>
-          <a:bodyPr xmlns:a="http://schemas.openxmlformats.org/drawingml/2006/main" lIns="0" tIns="0" rIns="0" bIns="0" anchor="t"/>
-          <a:lstStyle xmlns:a="http://schemas.openxmlformats.org/drawingml/2006/main"/>
-          <a:p xmlns:a="http://schemas.openxmlformats.org/drawingml/2006/main">
-            <a:pPr algn="l">
-              <a:lnSpc>
-                <a:spcPct val="118000"/>
-              </a:lnSpc>
-              <a:buNone/>
-              <a:defRPr sz="2300" b="0">
-                <a:solidFill>
-                  <a:srgbClr val="27333D"/>
-                </a:solidFill>
-                <a:latin typeface="微软雅黑"/>
-                <a:ea typeface="微软雅黑"/>
-                <a:cs typeface="微软雅黑"/>
-              </a:defRPr>
-            </a:pPr>
-            <a:r>
-              <a:rPr sz="2300" b="0">
-                <a:solidFill>
-                  <a:srgbClr val="27333D"/>
-                </a:solidFill>
-                <a:latin typeface="微软雅黑"/>
-                <a:ea typeface="微软雅黑"/>
-                <a:cs typeface="微软雅黑"/>
-              </a:rPr>
-              <a:t>工件：review；机制判断：仍不能判断。</a:t>
-            </a:r>
-          </a:p>
-        </p:txBody>
-      </p:sp>
-      <p:sp>
-        <p:nvSpPr>
-          <p:cNvPr id="10" name="content-220">
-            <a:extLst xmlns:a="http://schemas.openxmlformats.org/drawingml/2006/main">
-              <a:ext uri="{FF2B5EF4-FFF2-40B4-BE49-F238E27FC236}">
-                <a16:creationId xmlns:a16="http://schemas.microsoft.com/office/drawing/2014/main" id="{59D1C168-A00B-4D96-AE66-F0276BD9518A}"/>
-              </a:ext>
-            </a:extLst>
-          </p:cNvPr>
-          <p:cNvSpPr>
-            <a:spLocks xmlns:a="http://schemas.openxmlformats.org/drawingml/2006/main" noGrp="1"/>
-          </p:cNvSpPr>
-          <p:nvPr/>
-        </p:nvSpPr>
-        <p:spPr>
-          <a:xfrm xmlns:a="http://schemas.openxmlformats.org/drawingml/2006/main">
-            <a:off x="609600" y="5191125"/>
-            <a:ext cx="10972800" cy="866775"/>
-          </a:xfrm>
-          <a:prstGeom xmlns:a="http://schemas.openxmlformats.org/drawingml/2006/main" prst="rect">
-            <a:avLst/>
-          </a:prstGeom>
-          <a:noFill xmlns:a="http://schemas.openxmlformats.org/drawingml/2006/main"/>
-          <a:ln xmlns:a="http://schemas.openxmlformats.org/drawingml/2006/main" w="0">
-            <a:noFill/>
-          </a:ln>
-        </p:spPr>
-        <p:txBody>
-          <a:bodyPr xmlns:a="http://schemas.openxmlformats.org/drawingml/2006/main" lIns="0" tIns="0" rIns="0" bIns="0" anchor="t"/>
-          <a:lstStyle xmlns:a="http://schemas.openxmlformats.org/drawingml/2006/main"/>
-          <a:p xmlns:a="http://schemas.openxmlformats.org/drawingml/2006/main">
-            <a:pPr algn="l">
-              <a:lnSpc>
-                <a:spcPct val="118000"/>
-              </a:lnSpc>
-              <a:buNone/>
-              <a:defRPr sz="2200" b="0">
-                <a:solidFill>
-                  <a:srgbClr val="27333D"/>
-                </a:solidFill>
-                <a:latin typeface="微软雅黑"/>
-                <a:ea typeface="微软雅黑"/>
-                <a:cs typeface="微软雅黑"/>
-              </a:defRPr>
-            </a:pPr>
-            <a:r>
-              <a:rPr sz="2200" b="0">
-                <a:solidFill>
-                  <a:srgbClr val="27333D"/>
-                </a:solidFill>
-                <a:latin typeface="微软雅黑"/>
-                <a:ea typeface="微软雅黑"/>
-                <a:cs typeface="微软雅黑"/>
-              </a:rPr>
-              <a:t>优先处理致命问题，再处理重要问题与表达。</a:t>
-            </a:r>
-          </a:p>
-          <a:p xmlns:a="http://schemas.openxmlformats.org/drawingml/2006/main">
-            <a:pPr algn="l">
-              <a:lnSpc>
-                <a:spcPct val="118000"/>
-              </a:lnSpc>
-              <a:buNone/>
-              <a:defRPr sz="2200" b="0">
-                <a:solidFill>
-                  <a:srgbClr val="27333D"/>
-                </a:solidFill>
-                <a:latin typeface="微软雅黑"/>
-                <a:ea typeface="微软雅黑"/>
-                <a:cs typeface="微软雅黑"/>
-              </a:defRPr>
-            </a:pPr>
-            <a:r>
-              <a:rPr sz="2200" b="0">
-                <a:solidFill>
-                  <a:srgbClr val="27333D"/>
-                </a:solidFill>
-                <a:latin typeface="微软雅黑"/>
-                <a:ea typeface="微软雅黑"/>
-                <a:cs typeface="微软雅黑"/>
-              </a:rPr>
-              <a:t>改实际文件，保存 diff，更新影响工件。</a:t>
             </a:r>
           </a:p>
         </p:txBody>
@@ -9259,35 +7996,55 @@
       </p:grpSpPr>
       <p:sp>
         <p:nvSpPr>
-          <p:cNvPr id="4" name="Text Placeholder 3">
-            <a:extLst xmlns:a="http://schemas.openxmlformats.org/drawingml/2006/main">
-              <a:ext uri="{FF2B5EF4-FFF2-40B4-BE49-F238E27FC236}">
-                <a16:creationId xmlns:a16="http://schemas.microsoft.com/office/drawing/2014/main" id="{4D941B40-7A0A-534E-3563-CA11753C8E3F}"/>
-              </a:ext>
-            </a:extLst>
-          </p:cNvPr>
-          <p:cNvSpPr>
-            <a:spLocks xmlns:a="http://schemas.openxmlformats.org/drawingml/2006/main" noGrp="1"/>
-          </p:cNvSpPr>
-          <p:nvPr>
-            <p:ph type="body" idx="14"/>
-          </p:nvPr>
-        </p:nvSpPr>
-        <p:spPr>
-          <a:xfrm xmlns:a="http://schemas.openxmlformats.org/drawingml/2006/main">
-            <a:off x="1028700" y="57150"/>
-            <a:ext cx="10668000" cy="571500"/>
-          </a:xfrm>
-        </p:spPr>
-        <p:txBody>
-          <a:bodyPr xmlns:a="http://schemas.openxmlformats.org/drawingml/2006/main" lIns="0" tIns="0" rIns="0" bIns="0" anchor="ctr"/>
-          <a:lstStyle xmlns:a="http://schemas.openxmlformats.org/drawingml/2006/main"/>
+          <p:cNvPr id="7" name="judgment-title">
+            <a:extLst xmlns:a="http://schemas.openxmlformats.org/drawingml/2006/main">
+              <a:ext uri="{FF2B5EF4-FFF2-40B4-BE49-F238E27FC236}">
+                <a16:creationId xmlns:a16="http://schemas.microsoft.com/office/drawing/2014/main" id="{EFCB6525-4EB2-4E49-B70A-7E551D809670}"/>
+              </a:ext>
+            </a:extLst>
+          </p:cNvPr>
+          <p:cNvSpPr>
+            <a:spLocks xmlns:a="http://schemas.openxmlformats.org/drawingml/2006/main" noGrp="1"/>
+          </p:cNvSpPr>
+          <p:nvPr/>
+        </p:nvSpPr>
+        <p:spPr>
+          <a:xfrm xmlns:a="http://schemas.openxmlformats.org/drawingml/2006/main">
+            <a:off x="1028700" y="76200"/>
+            <a:ext cx="10687050" cy="514350"/>
+          </a:xfrm>
+          <a:prstGeom xmlns:a="http://schemas.openxmlformats.org/drawingml/2006/main" prst="rect">
+            <a:avLst/>
+          </a:prstGeom>
+          <a:noFill xmlns:a="http://schemas.openxmlformats.org/drawingml/2006/main"/>
+          <a:ln xmlns:a="http://schemas.openxmlformats.org/drawingml/2006/main" w="0">
+            <a:noFill/>
+          </a:ln>
+        </p:spPr>
+        <p:txBody>
+          <a:bodyPr xmlns:a="http://schemas.openxmlformats.org/drawingml/2006/main" lIns="0" tIns="0" rIns="0" bIns="0" anchor="t"/>
+          <a:lstStyle xmlns:a="http://schemas.openxmlformats.org/drawingml/2006/main">
+            <a:defPPr algn="l">
+              <a:defRPr sz="3000" b="1">
+                <a:solidFill>
+                  <a:srgbClr val="FFFFFF"/>
+                </a:solidFill>
+                <a:latin typeface="微软雅黑"/>
+                <a:ea typeface="微软雅黑"/>
+                <a:cs typeface="微软雅黑"/>
+              </a:defRPr>
+            </a:defPPr>
+          </a:lstStyle>
           <a:p xmlns:a="http://schemas.openxmlformats.org/drawingml/2006/main">
             <a:pPr algn="l">
-              <a:lnSpc>
-                <a:spcPct val="118000"/>
-              </a:lnSpc>
-              <a:buNone/>
+              <a:defRPr sz="3000" b="1">
+                <a:solidFill>
+                  <a:srgbClr val="FFFFFF"/>
+                </a:solidFill>
+                <a:latin typeface="微软雅黑"/>
+                <a:ea typeface="微软雅黑"/>
+                <a:cs typeface="微软雅黑"/>
+              </a:defRPr>
             </a:pPr>
             <a:r>
               <a:rPr sz="3000" b="1">
@@ -9298,700 +8055,337 @@
                 <a:ea typeface="微软雅黑"/>
                 <a:cs typeface="微软雅黑"/>
               </a:rPr>
-              <a:t>带齐展示与抽查材料</a:t>
-            </a:r>
-            <a:endParaRPr/>
-          </a:p>
-        </p:txBody>
-      </p:sp>
-      <p:sp>
-        <p:nvSpPr>
-          <p:cNvPr id="5" name="Slide Number Placeholder 4">
-            <a:extLst xmlns:a="http://schemas.openxmlformats.org/drawingml/2006/main">
-              <a:ext uri="{FF2B5EF4-FFF2-40B4-BE49-F238E27FC236}">
-                <a16:creationId xmlns:a16="http://schemas.microsoft.com/office/drawing/2014/main" id="{EBA5909F-738E-F60C-BE8C-B3F1D94548E5}"/>
-              </a:ext>
-            </a:extLst>
-          </p:cNvPr>
-          <p:cNvSpPr>
-            <a:spLocks xmlns:a="http://schemas.openxmlformats.org/drawingml/2006/main" noGrp="1"/>
-          </p:cNvSpPr>
-          <p:nvPr>
-            <p:ph type="sldNum" idx="10"/>
-          </p:nvPr>
-        </p:nvSpPr>
-        <p:spPr/>
-        <p:txBody>
-          <a:bodyPr xmlns:a="http://schemas.openxmlformats.org/drawingml/2006/main"/>
-          <a:lstStyle xmlns:a="http://schemas.openxmlformats.org/drawingml/2006/main"/>
-          <a:p xmlns:a="http://schemas.openxmlformats.org/drawingml/2006/main">
-            <a:fld id="{EA83FA91-883A-0168-8075-96CEB9DCA3C2}" type="slidenum">
+              <a:t>保留本课决定，准备下一课输入</a:t>
+            </a:r>
+          </a:p>
+        </p:txBody>
+      </p:sp>
+      <p:sp>
+        <p:nvSpPr>
+          <p:cNvPr id="2" name="judgment-body-0">
+            <a:extLst xmlns:a="http://schemas.openxmlformats.org/drawingml/2006/main">
+              <a:ext uri="{FF2B5EF4-FFF2-40B4-BE49-F238E27FC236}">
+                <a16:creationId xmlns:a16="http://schemas.microsoft.com/office/drawing/2014/main" id="{AB5B977B-7F7A-4A1A-B93B-B6B490217DC7}"/>
+              </a:ext>
+            </a:extLst>
+          </p:cNvPr>
+          <p:cNvSpPr>
+            <a:spLocks xmlns:a="http://schemas.openxmlformats.org/drawingml/2006/main" noGrp="1"/>
+          </p:cNvSpPr>
+          <p:nvPr/>
+        </p:nvSpPr>
+        <p:spPr>
+          <a:xfrm xmlns:a="http://schemas.openxmlformats.org/drawingml/2006/main">
+            <a:off x="666750" y="1066800"/>
+            <a:ext cx="10858500" cy="1009650"/>
+          </a:xfrm>
+          <a:prstGeom xmlns:a="http://schemas.openxmlformats.org/drawingml/2006/main" prst="rect">
+            <a:avLst/>
+          </a:prstGeom>
+          <a:noFill xmlns:a="http://schemas.openxmlformats.org/drawingml/2006/main"/>
+          <a:ln xmlns:a="http://schemas.openxmlformats.org/drawingml/2006/main" w="0">
+            <a:noFill/>
+          </a:ln>
+        </p:spPr>
+        <p:txBody>
+          <a:bodyPr xmlns:a="http://schemas.openxmlformats.org/drawingml/2006/main" lIns="0" tIns="0" rIns="0" bIns="0" anchor="t"/>
+          <a:lstStyle xmlns:a="http://schemas.openxmlformats.org/drawingml/2006/main">
+            <a:defPPr algn="l">
+              <a:defRPr sz="2400" b="0">
+                <a:solidFill>
+                  <a:srgbClr val="263746"/>
+                </a:solidFill>
+                <a:latin typeface="微软雅黑"/>
+                <a:ea typeface="微软雅黑"/>
+                <a:cs typeface="微软雅黑"/>
+              </a:defRPr>
+            </a:defPPr>
+          </a:lstStyle>
+          <a:p xmlns:a="http://schemas.openxmlformats.org/drawingml/2006/main">
+            <a:pPr algn="l">
+              <a:defRPr sz="2400" b="0">
+                <a:solidFill>
+                  <a:srgbClr val="263746"/>
+                </a:solidFill>
+                <a:latin typeface="微软雅黑"/>
+                <a:ea typeface="微软雅黑"/>
+                <a:cs typeface="微软雅黑"/>
+              </a:defRPr>
+            </a:pPr>
+            <a:r>
+              <a:rPr sz="2400" b="0">
+                <a:solidFill>
+                  <a:srgbClr val="263746"/>
+                </a:solidFill>
+                <a:latin typeface="微软雅黑"/>
+                <a:ea typeface="微软雅黑"/>
+                <a:cs typeface="微软雅黑"/>
+              </a:rPr>
+              <a:t>L16 展示现有结论与工件，不另起展示项目。</a:t>
+            </a:r>
+          </a:p>
+        </p:txBody>
+      </p:sp>
+      <p:sp>
+        <p:nvSpPr>
+          <p:cNvPr id="3" name="judgment-body-1">
+            <a:extLst xmlns:a="http://schemas.openxmlformats.org/drawingml/2006/main">
+              <a:ext uri="{FF2B5EF4-FFF2-40B4-BE49-F238E27FC236}">
+                <a16:creationId xmlns:a16="http://schemas.microsoft.com/office/drawing/2014/main" id="{950BF108-FDB8-436D-8B91-1BFDEBBA0569}"/>
+              </a:ext>
+            </a:extLst>
+          </p:cNvPr>
+          <p:cNvSpPr>
+            <a:spLocks xmlns:a="http://schemas.openxmlformats.org/drawingml/2006/main" noGrp="1"/>
+          </p:cNvSpPr>
+          <p:nvPr/>
+        </p:nvSpPr>
+        <p:spPr>
+          <a:xfrm xmlns:a="http://schemas.openxmlformats.org/drawingml/2006/main">
+            <a:off x="666750" y="2238375"/>
+            <a:ext cx="10858500" cy="2076450"/>
+          </a:xfrm>
+          <a:prstGeom xmlns:a="http://schemas.openxmlformats.org/drawingml/2006/main" prst="rect">
+            <a:avLst/>
+          </a:prstGeom>
+          <a:noFill xmlns:a="http://schemas.openxmlformats.org/drawingml/2006/main"/>
+          <a:ln xmlns:a="http://schemas.openxmlformats.org/drawingml/2006/main" w="0">
+            <a:noFill/>
+          </a:ln>
+        </p:spPr>
+        <p:txBody>
+          <a:bodyPr xmlns:a="http://schemas.openxmlformats.org/drawingml/2006/main" lIns="0" tIns="0" rIns="0" bIns="0" anchor="t"/>
+          <a:lstStyle xmlns:a="http://schemas.openxmlformats.org/drawingml/2006/main">
+            <a:defPPr algn="l">
+              <a:defRPr sz="2400" b="0">
+                <a:solidFill>
+                  <a:srgbClr val="263746"/>
+                </a:solidFill>
+                <a:latin typeface="微软雅黑"/>
+                <a:ea typeface="微软雅黑"/>
+                <a:cs typeface="微软雅黑"/>
+              </a:defRPr>
+            </a:defPPr>
+          </a:lstStyle>
+          <a:p xmlns:a="http://schemas.openxmlformats.org/drawingml/2006/main">
+            <a:pPr algn="l">
+              <a:defRPr sz="2400" b="0">
+                <a:solidFill>
+                  <a:srgbClr val="263746"/>
+                </a:solidFill>
+                <a:latin typeface="微软雅黑"/>
+                <a:ea typeface="微软雅黑"/>
+                <a:cs typeface="微软雅黑"/>
+              </a:defRPr>
+            </a:pPr>
+            <a:r>
+              <a:rPr sz="2400" b="0">
+                <a:solidFill>
+                  <a:srgbClr val="263746"/>
+                </a:solidFill>
+                <a:latin typeface="微软雅黑"/>
+                <a:ea typeface="微软雅黑"/>
+                <a:cs typeface="微软雅黑"/>
+              </a:rPr>
+              <a:t>回写已有项目：真实评审意见、处理理由、实际 diff 与论证门预检</a:t>
+            </a:r>
+          </a:p>
+        </p:txBody>
+      </p:sp>
+      <p:sp>
+        <p:nvSpPr>
+          <p:cNvPr id="4" name="judgment-body-2">
+            <a:extLst xmlns:a="http://schemas.openxmlformats.org/drawingml/2006/main">
+              <a:ext uri="{FF2B5EF4-FFF2-40B4-BE49-F238E27FC236}">
+                <a16:creationId xmlns:a16="http://schemas.microsoft.com/office/drawing/2014/main" id="{AC92A75D-E89C-429F-B0D5-ADA5F317D095}"/>
+              </a:ext>
+            </a:extLst>
+          </p:cNvPr>
+          <p:cNvSpPr>
+            <a:spLocks xmlns:a="http://schemas.openxmlformats.org/drawingml/2006/main" noGrp="1"/>
+          </p:cNvSpPr>
+          <p:nvPr/>
+        </p:nvSpPr>
+        <p:spPr>
+          <a:xfrm xmlns:a="http://schemas.openxmlformats.org/drawingml/2006/main">
+            <a:off x="666750" y="4495800"/>
+            <a:ext cx="10858500" cy="1409700"/>
+          </a:xfrm>
+          <a:prstGeom xmlns:a="http://schemas.openxmlformats.org/drawingml/2006/main" prst="rect">
+            <a:avLst/>
+          </a:prstGeom>
+          <a:noFill xmlns:a="http://schemas.openxmlformats.org/drawingml/2006/main"/>
+          <a:ln xmlns:a="http://schemas.openxmlformats.org/drawingml/2006/main" w="0">
+            <a:noFill/>
+          </a:ln>
+        </p:spPr>
+        <p:txBody>
+          <a:bodyPr xmlns:a="http://schemas.openxmlformats.org/drawingml/2006/main" lIns="0" tIns="0" rIns="0" bIns="0" anchor="t"/>
+          <a:lstStyle xmlns:a="http://schemas.openxmlformats.org/drawingml/2006/main">
+            <a:defPPr algn="l">
+              <a:defRPr sz="2200" b="0">
+                <a:solidFill>
+                  <a:srgbClr val="1F4D78"/>
+                </a:solidFill>
+                <a:latin typeface="微软雅黑"/>
+                <a:ea typeface="微软雅黑"/>
+                <a:cs typeface="微软雅黑"/>
+              </a:defRPr>
+            </a:defPPr>
+          </a:lstStyle>
+          <a:p xmlns:a="http://schemas.openxmlformats.org/drawingml/2006/main">
+            <a:pPr algn="l">
+              <a:defRPr sz="2200" b="0">
+                <a:solidFill>
+                  <a:srgbClr val="1F4D78"/>
+                </a:solidFill>
+                <a:latin typeface="微软雅黑"/>
+                <a:ea typeface="微软雅黑"/>
+                <a:cs typeface="微软雅黑"/>
+              </a:defRPr>
+            </a:pPr>
+            <a:r>
+              <a:rPr sz="2200" b="0">
+                <a:solidFill>
+                  <a:srgbClr val="1F4D78"/>
+                </a:solidFill>
+                <a:latin typeface="微软雅黑"/>
+                <a:ea typeface="微软雅黑"/>
+                <a:cs typeface="微软雅黑"/>
+              </a:rPr>
+              <a:t>只读指定段落，补课堂留下的真实缺口。安装与排障计入课外总预算。</a:t>
+            </a:r>
+          </a:p>
+        </p:txBody>
+      </p:sp>
+      <p:sp>
+        <p:nvSpPr>
+          <p:cNvPr id="5" name="judgment-source">
+            <a:extLst xmlns:a="http://schemas.openxmlformats.org/drawingml/2006/main">
+              <a:ext uri="{FF2B5EF4-FFF2-40B4-BE49-F238E27FC236}">
+                <a16:creationId xmlns:a16="http://schemas.microsoft.com/office/drawing/2014/main" id="{6E4DC6F3-ACF5-4D2E-BBE8-7463F490100C}"/>
+              </a:ext>
+            </a:extLst>
+          </p:cNvPr>
+          <p:cNvSpPr>
+            <a:spLocks xmlns:a="http://schemas.openxmlformats.org/drawingml/2006/main" noGrp="1"/>
+          </p:cNvSpPr>
+          <p:nvPr/>
+        </p:nvSpPr>
+        <p:spPr>
+          <a:xfrm xmlns:a="http://schemas.openxmlformats.org/drawingml/2006/main">
+            <a:off x="666750" y="6276975"/>
+            <a:ext cx="10572750" cy="209550"/>
+          </a:xfrm>
+          <a:prstGeom xmlns:a="http://schemas.openxmlformats.org/drawingml/2006/main" prst="rect">
+            <a:avLst/>
+          </a:prstGeom>
+          <a:noFill xmlns:a="http://schemas.openxmlformats.org/drawingml/2006/main"/>
+          <a:ln xmlns:a="http://schemas.openxmlformats.org/drawingml/2006/main" w="0">
+            <a:noFill/>
+          </a:ln>
+        </p:spPr>
+        <p:txBody>
+          <a:bodyPr xmlns:a="http://schemas.openxmlformats.org/drawingml/2006/main" lIns="0" tIns="0" rIns="0" bIns="0" anchor="t"/>
+          <a:lstStyle xmlns:a="http://schemas.openxmlformats.org/drawingml/2006/main">
+            <a:defPPr algn="l">
+              <a:defRPr sz="1100" b="0">
+                <a:solidFill>
+                  <a:srgbClr val="667684"/>
+                </a:solidFill>
+                <a:latin typeface="微软雅黑"/>
+                <a:ea typeface="微软雅黑"/>
+                <a:cs typeface="微软雅黑"/>
+              </a:defRPr>
+            </a:defPPr>
+          </a:lstStyle>
+          <a:p xmlns:a="http://schemas.openxmlformats.org/drawingml/2006/main">
+            <a:pPr algn="l">
+              <a:defRPr sz="1100" b="0">
+                <a:solidFill>
+                  <a:srgbClr val="667684"/>
+                </a:solidFill>
+                <a:latin typeface="微软雅黑"/>
+                <a:ea typeface="微软雅黑"/>
+                <a:cs typeface="微软雅黑"/>
+              </a:defRPr>
+            </a:pPr>
+            <a:r>
+              <a:rPr sz="1100" b="0">
+                <a:solidFill>
+                  <a:srgbClr val="667684"/>
+                </a:solidFill>
+                <a:latin typeface="微软雅黑"/>
+                <a:ea typeface="微软雅黑"/>
+                <a:cs typeface="微软雅黑"/>
+              </a:rPr>
+              <a:t>来源：本课判断任务与讲义；构造材料及真实来源按材料包标识</a:t>
+            </a:r>
+          </a:p>
+        </p:txBody>
+      </p:sp>
+      <p:sp>
+        <p:nvSpPr>
+          <p:cNvPr id="6" name="judgment-page">
+            <a:extLst xmlns:a="http://schemas.openxmlformats.org/drawingml/2006/main">
+              <a:ext uri="{FF2B5EF4-FFF2-40B4-BE49-F238E27FC236}">
+                <a16:creationId xmlns:a16="http://schemas.microsoft.com/office/drawing/2014/main" id="{B2245186-B031-4DE3-AA89-AC86C6090485}"/>
+              </a:ext>
+            </a:extLst>
+          </p:cNvPr>
+          <p:cNvSpPr>
+            <a:spLocks xmlns:a="http://schemas.openxmlformats.org/drawingml/2006/main" noGrp="1"/>
+          </p:cNvSpPr>
+          <p:nvPr/>
+        </p:nvSpPr>
+        <p:spPr>
+          <a:xfrm xmlns:a="http://schemas.openxmlformats.org/drawingml/2006/main">
+            <a:off x="11715750" y="6562725"/>
+            <a:ext cx="238125" cy="171450"/>
+          </a:xfrm>
+          <a:prstGeom xmlns:a="http://schemas.openxmlformats.org/drawingml/2006/main" prst="rect">
+            <a:avLst/>
+          </a:prstGeom>
+          <a:noFill xmlns:a="http://schemas.openxmlformats.org/drawingml/2006/main"/>
+          <a:ln xmlns:a="http://schemas.openxmlformats.org/drawingml/2006/main" w="0">
+            <a:noFill/>
+          </a:ln>
+        </p:spPr>
+        <p:txBody>
+          <a:bodyPr xmlns:a="http://schemas.openxmlformats.org/drawingml/2006/main" lIns="0" tIns="0" rIns="0" bIns="0" anchor="t"/>
+          <a:lstStyle xmlns:a="http://schemas.openxmlformats.org/drawingml/2006/main">
+            <a:defPPr algn="l">
+              <a:defRPr sz="900" b="0">
+                <a:solidFill>
+                  <a:srgbClr val="A5A5A5"/>
+                </a:solidFill>
+                <a:latin typeface="微软雅黑"/>
+                <a:ea typeface="微软雅黑"/>
+                <a:cs typeface="微软雅黑"/>
+              </a:defRPr>
+            </a:defPPr>
+          </a:lstStyle>
+          <a:p xmlns:a="http://schemas.openxmlformats.org/drawingml/2006/main">
+            <a:pPr algn="l">
+              <a:defRPr sz="900" b="0">
+                <a:solidFill>
+                  <a:srgbClr val="A5A5A5"/>
+                </a:solidFill>
+                <a:latin typeface="微软雅黑"/>
+                <a:ea typeface="微软雅黑"/>
+                <a:cs typeface="微软雅黑"/>
+              </a:defRPr>
+            </a:pPr>
+            <a:r>
+              <a:rPr sz="900" b="0">
+                <a:solidFill>
+                  <a:srgbClr val="A5A5A5"/>
+                </a:solidFill>
+                <a:latin typeface="微软雅黑"/>
+                <a:ea typeface="微软雅黑"/>
+                <a:cs typeface="微软雅黑"/>
+              </a:rPr>
               <a:t>15</a:t>
-            </a:fld>
-            <a:endParaRPr/>
-          </a:p>
-        </p:txBody>
-      </p:sp>
-      <p:sp>
-        <p:nvSpPr>
-          <p:cNvPr id="6" name="lightning-label">
-            <a:extLst xmlns:a="http://schemas.openxmlformats.org/drawingml/2006/main">
-              <a:ext uri="{FF2B5EF4-FFF2-40B4-BE49-F238E27FC236}">
-                <a16:creationId xmlns:a16="http://schemas.microsoft.com/office/drawing/2014/main" id="{A95A015C-F509-4DF1-9234-9C490129997C}"/>
-              </a:ext>
-            </a:extLst>
-          </p:cNvPr>
-          <p:cNvSpPr>
-            <a:spLocks xmlns:a="http://schemas.openxmlformats.org/drawingml/2006/main" noGrp="1"/>
-          </p:cNvSpPr>
-          <p:nvPr/>
-        </p:nvSpPr>
-        <p:spPr>
-          <a:xfrm xmlns:a="http://schemas.openxmlformats.org/drawingml/2006/main">
-            <a:off x="609600" y="1419225"/>
-            <a:ext cx="4695825" cy="381000"/>
-          </a:xfrm>
-          <a:prstGeom xmlns:a="http://schemas.openxmlformats.org/drawingml/2006/main" prst="rect">
-            <a:avLst/>
-          </a:prstGeom>
-          <a:noFill xmlns:a="http://schemas.openxmlformats.org/drawingml/2006/main"/>
-          <a:ln xmlns:a="http://schemas.openxmlformats.org/drawingml/2006/main" w="0">
-            <a:noFill/>
-          </a:ln>
-        </p:spPr>
-        <p:txBody>
-          <a:bodyPr xmlns:a="http://schemas.openxmlformats.org/drawingml/2006/main" lIns="0" tIns="0" rIns="0" bIns="0" anchor="t"/>
-          <a:lstStyle xmlns:a="http://schemas.openxmlformats.org/drawingml/2006/main"/>
-          <a:p xmlns:a="http://schemas.openxmlformats.org/drawingml/2006/main">
-            <a:pPr algn="l">
-              <a:lnSpc>
-                <a:spcPct val="118000"/>
-              </a:lnSpc>
-              <a:buNone/>
-              <a:defRPr sz="2000" b="1">
-                <a:solidFill>
-                  <a:srgbClr val="1F4D78"/>
-                </a:solidFill>
-                <a:latin typeface="微软雅黑"/>
-                <a:ea typeface="微软雅黑"/>
-                <a:cs typeface="微软雅黑"/>
-              </a:defRPr>
-            </a:pPr>
-            <a:r>
-              <a:rPr sz="2000" b="1">
-                <a:solidFill>
-                  <a:srgbClr val="1F4D78"/>
-                </a:solidFill>
-                <a:latin typeface="微软雅黑"/>
-                <a:ea typeface="微软雅黑"/>
-                <a:cs typeface="微软雅黑"/>
-              </a:rPr>
-              <a:t>全员闪电报告</a:t>
-            </a:r>
-          </a:p>
-        </p:txBody>
-      </p:sp>
-      <p:sp>
-        <p:nvSpPr>
-          <p:cNvPr id="7" name="lightning-body">
-            <a:extLst xmlns:a="http://schemas.openxmlformats.org/drawingml/2006/main">
-              <a:ext uri="{FF2B5EF4-FFF2-40B4-BE49-F238E27FC236}">
-                <a16:creationId xmlns:a16="http://schemas.microsoft.com/office/drawing/2014/main" id="{59D0B415-55D4-4B3A-A44D-59C4D8120766}"/>
-              </a:ext>
-            </a:extLst>
-          </p:cNvPr>
-          <p:cNvSpPr>
-            <a:spLocks xmlns:a="http://schemas.openxmlformats.org/drawingml/2006/main" noGrp="1"/>
-          </p:cNvSpPr>
-          <p:nvPr/>
-        </p:nvSpPr>
-        <p:spPr>
-          <a:xfrm xmlns:a="http://schemas.openxmlformats.org/drawingml/2006/main">
-            <a:off x="609600" y="1924050"/>
-            <a:ext cx="4695825" cy="1381125"/>
-          </a:xfrm>
-          <a:prstGeom xmlns:a="http://schemas.openxmlformats.org/drawingml/2006/main" prst="rect">
-            <a:avLst/>
-          </a:prstGeom>
-          <a:noFill xmlns:a="http://schemas.openxmlformats.org/drawingml/2006/main"/>
-          <a:ln xmlns:a="http://schemas.openxmlformats.org/drawingml/2006/main" w="0">
-            <a:noFill/>
-          </a:ln>
-        </p:spPr>
-        <p:txBody>
-          <a:bodyPr xmlns:a="http://schemas.openxmlformats.org/drawingml/2006/main" lIns="0" tIns="0" rIns="0" bIns="0" anchor="t"/>
-          <a:lstStyle xmlns:a="http://schemas.openxmlformats.org/drawingml/2006/main"/>
-          <a:p xmlns:a="http://schemas.openxmlformats.org/drawingml/2006/main">
-            <a:pPr algn="l">
-              <a:lnSpc>
-                <a:spcPct val="118000"/>
-              </a:lnSpc>
-              <a:buNone/>
-              <a:defRPr sz="2400" b="0">
-                <a:solidFill>
-                  <a:srgbClr val="27333D"/>
-                </a:solidFill>
-                <a:latin typeface="微软雅黑"/>
-                <a:ea typeface="微软雅黑"/>
-                <a:cs typeface="微软雅黑"/>
-              </a:defRPr>
-            </a:pPr>
-            <a:r>
-              <a:rPr sz="2400" b="0">
-                <a:solidFill>
-                  <a:srgbClr val="27333D"/>
-                </a:solidFill>
-                <a:latin typeface="微软雅黑"/>
-                <a:ea typeface="微软雅黑"/>
-                <a:cs typeface="微软雅黑"/>
-              </a:rPr>
-              <a:t>研究问题</a:t>
-            </a:r>
-          </a:p>
-          <a:p xmlns:a="http://schemas.openxmlformats.org/drawingml/2006/main">
-            <a:pPr algn="l">
-              <a:lnSpc>
-                <a:spcPct val="118000"/>
-              </a:lnSpc>
-              <a:buNone/>
-              <a:defRPr sz="2400" b="0">
-                <a:solidFill>
-                  <a:srgbClr val="27333D"/>
-                </a:solidFill>
-                <a:latin typeface="微软雅黑"/>
-                <a:ea typeface="微软雅黑"/>
-                <a:cs typeface="微软雅黑"/>
-              </a:defRPr>
-            </a:pPr>
-            <a:r>
-              <a:rPr sz="2400" b="0">
-                <a:solidFill>
-                  <a:srgbClr val="27333D"/>
-                </a:solidFill>
-                <a:latin typeface="微软雅黑"/>
-                <a:ea typeface="微软雅黑"/>
-                <a:cs typeface="微软雅黑"/>
-              </a:rPr>
-              <a:t>关键结果</a:t>
-            </a:r>
-          </a:p>
-          <a:p xmlns:a="http://schemas.openxmlformats.org/drawingml/2006/main">
-            <a:pPr algn="l">
-              <a:lnSpc>
-                <a:spcPct val="118000"/>
-              </a:lnSpc>
-              <a:buNone/>
-              <a:defRPr sz="2400" b="0">
-                <a:solidFill>
-                  <a:srgbClr val="27333D"/>
-                </a:solidFill>
-                <a:latin typeface="微软雅黑"/>
-                <a:ea typeface="微软雅黑"/>
-                <a:cs typeface="微软雅黑"/>
-              </a:defRPr>
-            </a:pPr>
-            <a:r>
-              <a:rPr sz="2400" b="0">
-                <a:solidFill>
-                  <a:srgbClr val="27333D"/>
-                </a:solidFill>
-                <a:latin typeface="微软雅黑"/>
-                <a:ea typeface="微软雅黑"/>
-                <a:cs typeface="微软雅黑"/>
-              </a:rPr>
-              <a:t>结论边界</a:t>
-            </a:r>
-          </a:p>
-        </p:txBody>
-      </p:sp>
-      <p:sp>
-        <p:nvSpPr>
-          <p:cNvPr id="8" name="demo-label">
-            <a:extLst xmlns:a="http://schemas.openxmlformats.org/drawingml/2006/main">
-              <a:ext uri="{FF2B5EF4-FFF2-40B4-BE49-F238E27FC236}">
-                <a16:creationId xmlns:a16="http://schemas.microsoft.com/office/drawing/2014/main" id="{D0F99C0F-06D2-48FD-BC10-8F8E8B0AF405}"/>
-              </a:ext>
-            </a:extLst>
-          </p:cNvPr>
-          <p:cNvSpPr>
-            <a:spLocks xmlns:a="http://schemas.openxmlformats.org/drawingml/2006/main" noGrp="1"/>
-          </p:cNvSpPr>
-          <p:nvPr/>
-        </p:nvSpPr>
-        <p:spPr>
-          <a:xfrm xmlns:a="http://schemas.openxmlformats.org/drawingml/2006/main">
-            <a:off x="609600" y="3733800"/>
-            <a:ext cx="5381625" cy="381000"/>
-          </a:xfrm>
-          <a:prstGeom xmlns:a="http://schemas.openxmlformats.org/drawingml/2006/main" prst="rect">
-            <a:avLst/>
-          </a:prstGeom>
-          <a:noFill xmlns:a="http://schemas.openxmlformats.org/drawingml/2006/main"/>
-          <a:ln xmlns:a="http://schemas.openxmlformats.org/drawingml/2006/main" w="0">
-            <a:noFill/>
-          </a:ln>
-        </p:spPr>
-        <p:txBody>
-          <a:bodyPr xmlns:a="http://schemas.openxmlformats.org/drawingml/2006/main" lIns="0" tIns="0" rIns="0" bIns="0" anchor="t"/>
-          <a:lstStyle xmlns:a="http://schemas.openxmlformats.org/drawingml/2006/main"/>
-          <a:p xmlns:a="http://schemas.openxmlformats.org/drawingml/2006/main">
-            <a:pPr algn="l">
-              <a:lnSpc>
-                <a:spcPct val="118000"/>
-              </a:lnSpc>
-              <a:buNone/>
-              <a:defRPr sz="2000" b="1">
-                <a:solidFill>
-                  <a:srgbClr val="1F4D78"/>
-                </a:solidFill>
-                <a:latin typeface="微软雅黑"/>
-                <a:ea typeface="微软雅黑"/>
-                <a:cs typeface="微软雅黑"/>
-              </a:defRPr>
-            </a:pPr>
-            <a:r>
-              <a:rPr sz="2000" b="1">
-                <a:solidFill>
-                  <a:srgbClr val="1F4D78"/>
-                </a:solidFill>
-                <a:latin typeface="微软雅黑"/>
-                <a:ea typeface="微软雅黑"/>
-                <a:cs typeface="微软雅黑"/>
-              </a:rPr>
-              <a:t>分组证据／工作流演示</a:t>
-            </a:r>
-          </a:p>
-        </p:txBody>
-      </p:sp>
-      <p:sp>
-        <p:nvSpPr>
-          <p:cNvPr id="9" name="demo-body">
-            <a:extLst xmlns:a="http://schemas.openxmlformats.org/drawingml/2006/main">
-              <a:ext uri="{FF2B5EF4-FFF2-40B4-BE49-F238E27FC236}">
-                <a16:creationId xmlns:a16="http://schemas.microsoft.com/office/drawing/2014/main" id="{2E1233FA-D2D6-4C9D-A454-9CC0B94D302E}"/>
-              </a:ext>
-            </a:extLst>
-          </p:cNvPr>
-          <p:cNvSpPr>
-            <a:spLocks xmlns:a="http://schemas.openxmlformats.org/drawingml/2006/main" noGrp="1"/>
-          </p:cNvSpPr>
-          <p:nvPr/>
-        </p:nvSpPr>
-        <p:spPr>
-          <a:xfrm xmlns:a="http://schemas.openxmlformats.org/drawingml/2006/main">
-            <a:off x="609600" y="4238625"/>
-            <a:ext cx="5381625" cy="1381125"/>
-          </a:xfrm>
-          <a:prstGeom xmlns:a="http://schemas.openxmlformats.org/drawingml/2006/main" prst="rect">
-            <a:avLst/>
-          </a:prstGeom>
-          <a:noFill xmlns:a="http://schemas.openxmlformats.org/drawingml/2006/main"/>
-          <a:ln xmlns:a="http://schemas.openxmlformats.org/drawingml/2006/main" w="0">
-            <a:noFill/>
-          </a:ln>
-        </p:spPr>
-        <p:txBody>
-          <a:bodyPr xmlns:a="http://schemas.openxmlformats.org/drawingml/2006/main" lIns="0" tIns="0" rIns="0" bIns="0" anchor="t"/>
-          <a:lstStyle xmlns:a="http://schemas.openxmlformats.org/drawingml/2006/main"/>
-          <a:p xmlns:a="http://schemas.openxmlformats.org/drawingml/2006/main">
-            <a:pPr algn="l">
-              <a:lnSpc>
-                <a:spcPct val="118000"/>
-              </a:lnSpc>
-              <a:buNone/>
-              <a:defRPr sz="2400" b="0">
-                <a:solidFill>
-                  <a:srgbClr val="27333D"/>
-                </a:solidFill>
-                <a:latin typeface="微软雅黑"/>
-                <a:ea typeface="微软雅黑"/>
-                <a:cs typeface="微软雅黑"/>
-              </a:defRPr>
-            </a:pPr>
-            <a:r>
-              <a:rPr sz="2400" b="0">
-                <a:solidFill>
-                  <a:srgbClr val="27333D"/>
-                </a:solidFill>
-                <a:latin typeface="微软雅黑"/>
-                <a:ea typeface="微软雅黑"/>
-                <a:cs typeface="微软雅黑"/>
-              </a:rPr>
-              <a:t>证据定位与真实作用</a:t>
-            </a:r>
-          </a:p>
-          <a:p xmlns:a="http://schemas.openxmlformats.org/drawingml/2006/main">
-            <a:pPr algn="l">
-              <a:lnSpc>
-                <a:spcPct val="118000"/>
-              </a:lnSpc>
-              <a:buNone/>
-              <a:defRPr sz="2400" b="0">
-                <a:solidFill>
-                  <a:srgbClr val="27333D"/>
-                </a:solidFill>
-                <a:latin typeface="微软雅黑"/>
-                <a:ea typeface="微软雅黑"/>
-                <a:cs typeface="微软雅黑"/>
-              </a:defRPr>
-            </a:pPr>
-            <a:r>
-              <a:rPr sz="2400" b="0">
-                <a:solidFill>
-                  <a:srgbClr val="27333D"/>
-                </a:solidFill>
-                <a:latin typeface="微软雅黑"/>
-                <a:ea typeface="微软雅黑"/>
-                <a:cs typeface="微软雅黑"/>
-              </a:rPr>
-              <a:t>失败与人工判断</a:t>
-            </a:r>
-          </a:p>
-        </p:txBody>
-      </p:sp>
-      <p:sp>
-        <p:nvSpPr>
-          <p:cNvPr id="10" name="divider">
-            <a:extLst xmlns:a="http://schemas.openxmlformats.org/drawingml/2006/main">
-              <a:ext uri="{FF2B5EF4-FFF2-40B4-BE49-F238E27FC236}">
-                <a16:creationId xmlns:a16="http://schemas.microsoft.com/office/drawing/2014/main" id="{E3F14289-8116-465C-A31F-C39EE5773A7C}"/>
-              </a:ext>
-            </a:extLst>
-          </p:cNvPr>
-          <p:cNvSpPr>
-            <a:spLocks xmlns:a="http://schemas.openxmlformats.org/drawingml/2006/main" noGrp="1"/>
-          </p:cNvSpPr>
-          <p:nvPr/>
-        </p:nvSpPr>
-        <p:spPr>
-          <a:xfrm xmlns:a="http://schemas.openxmlformats.org/drawingml/2006/main">
-            <a:off x="6486525" y="1390650"/>
-            <a:ext cx="9525" cy="14288"/>
-          </a:xfrm>
-          <a:prstGeom xmlns:a="http://schemas.openxmlformats.org/drawingml/2006/main" prst="rect">
-            <a:avLst/>
-          </a:prstGeom>
-          <a:solidFill xmlns:a="http://schemas.openxmlformats.org/drawingml/2006/main">
-            <a:srgbClr val="CDD5DB"/>
-          </a:solidFill>
-          <a:ln xmlns:a="http://schemas.openxmlformats.org/drawingml/2006/main" w="0">
-            <a:noFill/>
-          </a:ln>
-        </p:spPr>
-      </p:sp>
-      <p:sp>
-        <p:nvSpPr>
-          <p:cNvPr id="11" name="audit">
-            <a:extLst xmlns:a="http://schemas.openxmlformats.org/drawingml/2006/main">
-              <a:ext uri="{FF2B5EF4-FFF2-40B4-BE49-F238E27FC236}">
-                <a16:creationId xmlns:a16="http://schemas.microsoft.com/office/drawing/2014/main" id="{137A22D1-AE57-4863-952D-D530B9DAA122}"/>
-              </a:ext>
-            </a:extLst>
-          </p:cNvPr>
-          <p:cNvSpPr>
-            <a:spLocks xmlns:a="http://schemas.openxmlformats.org/drawingml/2006/main" noGrp="1"/>
-          </p:cNvSpPr>
-          <p:nvPr/>
-        </p:nvSpPr>
-        <p:spPr>
-          <a:xfrm xmlns:a="http://schemas.openxmlformats.org/drawingml/2006/main">
-            <a:off x="7400925" y="1600200"/>
-            <a:ext cx="4095750" cy="542925"/>
-          </a:xfrm>
-          <a:prstGeom xmlns:a="http://schemas.openxmlformats.org/drawingml/2006/main" prst="rect">
-            <a:avLst/>
-          </a:prstGeom>
-          <a:noFill xmlns:a="http://schemas.openxmlformats.org/drawingml/2006/main"/>
-          <a:ln xmlns:a="http://schemas.openxmlformats.org/drawingml/2006/main" w="0">
-            <a:noFill/>
-          </a:ln>
-        </p:spPr>
-        <p:txBody>
-          <a:bodyPr xmlns:a="http://schemas.openxmlformats.org/drawingml/2006/main" lIns="0" tIns="0" rIns="0" bIns="0" anchor="t"/>
-          <a:lstStyle xmlns:a="http://schemas.openxmlformats.org/drawingml/2006/main"/>
-          <a:p xmlns:a="http://schemas.openxmlformats.org/drawingml/2006/main">
-            <a:pPr algn="l">
-              <a:lnSpc>
-                <a:spcPct val="118000"/>
-              </a:lnSpc>
-              <a:buNone/>
-              <a:defRPr sz="2800" b="1">
-                <a:solidFill>
-                  <a:srgbClr val="1F4D78"/>
-                </a:solidFill>
-                <a:latin typeface="微软雅黑"/>
-                <a:ea typeface="微软雅黑"/>
-                <a:cs typeface="微软雅黑"/>
-              </a:defRPr>
-            </a:pPr>
-            <a:r>
-              <a:rPr sz="2800" b="1">
-                <a:solidFill>
-                  <a:srgbClr val="1F4D78"/>
-                </a:solidFill>
-                <a:latin typeface="微软雅黑"/>
-                <a:ea typeface="微软雅黑"/>
-                <a:cs typeface="微软雅黑"/>
-              </a:rPr>
-              <a:t>教师抽查</a:t>
-            </a:r>
-          </a:p>
-        </p:txBody>
-      </p:sp>
-      <p:sp>
-        <p:nvSpPr>
-          <p:cNvPr id="12" name="audit-data">
-            <a:extLst xmlns:a="http://schemas.openxmlformats.org/drawingml/2006/main">
-              <a:ext uri="{FF2B5EF4-FFF2-40B4-BE49-F238E27FC236}">
-                <a16:creationId xmlns:a16="http://schemas.microsoft.com/office/drawing/2014/main" id="{E376DB76-8551-473A-ACD8-8A7D6D8A5089}"/>
-              </a:ext>
-            </a:extLst>
-          </p:cNvPr>
-          <p:cNvSpPr>
-            <a:spLocks xmlns:a="http://schemas.openxmlformats.org/drawingml/2006/main" noGrp="1"/>
-          </p:cNvSpPr>
-          <p:nvPr/>
-        </p:nvSpPr>
-        <p:spPr>
-          <a:xfrm xmlns:a="http://schemas.openxmlformats.org/drawingml/2006/main">
-            <a:off x="7400925" y="2628900"/>
-            <a:ext cx="4095750" cy="1781175"/>
-          </a:xfrm>
-          <a:prstGeom xmlns:a="http://schemas.openxmlformats.org/drawingml/2006/main" prst="rect">
-            <a:avLst/>
-          </a:prstGeom>
-          <a:noFill xmlns:a="http://schemas.openxmlformats.org/drawingml/2006/main"/>
-          <a:ln xmlns:a="http://schemas.openxmlformats.org/drawingml/2006/main" w="0">
-            <a:noFill/>
-          </a:ln>
-        </p:spPr>
-        <p:txBody>
-          <a:bodyPr xmlns:a="http://schemas.openxmlformats.org/drawingml/2006/main" lIns="0" tIns="0" rIns="0" bIns="0" anchor="t"/>
-          <a:lstStyle xmlns:a="http://schemas.openxmlformats.org/drawingml/2006/main"/>
-          <a:p xmlns:a="http://schemas.openxmlformats.org/drawingml/2006/main">
-            <a:pPr algn="l">
-              <a:lnSpc>
-                <a:spcPct val="118000"/>
-              </a:lnSpc>
-              <a:buNone/>
-              <a:defRPr sz="2600" b="0">
-                <a:solidFill>
-                  <a:srgbClr val="27333D"/>
-                </a:solidFill>
-                <a:latin typeface="微软雅黑"/>
-                <a:ea typeface="微软雅黑"/>
-                <a:cs typeface="微软雅黑"/>
-              </a:defRPr>
-            </a:pPr>
-            <a:r>
-              <a:rPr sz="2600" b="0">
-                <a:solidFill>
-                  <a:srgbClr val="27333D"/>
-                </a:solidFill>
-                <a:latin typeface="微软雅黑"/>
-                <a:ea typeface="微软雅黑"/>
-                <a:cs typeface="微软雅黑"/>
-              </a:rPr>
-              <a:t>实验 ID</a:t>
-            </a:r>
-          </a:p>
-          <a:p xmlns:a="http://schemas.openxmlformats.org/drawingml/2006/main">
-            <a:pPr algn="l">
-              <a:lnSpc>
-                <a:spcPct val="118000"/>
-              </a:lnSpc>
-              <a:buNone/>
-              <a:defRPr sz="2600" b="0">
-                <a:solidFill>
-                  <a:srgbClr val="27333D"/>
-                </a:solidFill>
-                <a:latin typeface="微软雅黑"/>
-                <a:ea typeface="微软雅黑"/>
-                <a:cs typeface="微软雅黑"/>
-              </a:defRPr>
-            </a:pPr>
-            <a:r>
-              <a:rPr sz="2600" b="0">
-                <a:solidFill>
-                  <a:srgbClr val="27333D"/>
-                </a:solidFill>
-                <a:latin typeface="微软雅黑"/>
-                <a:ea typeface="微软雅黑"/>
-                <a:cs typeface="微软雅黑"/>
-              </a:rPr>
-              <a:t>引用</a:t>
-            </a:r>
-          </a:p>
-          <a:p xmlns:a="http://schemas.openxmlformats.org/drawingml/2006/main">
-            <a:pPr algn="l">
-              <a:lnSpc>
-                <a:spcPct val="118000"/>
-              </a:lnSpc>
-              <a:buNone/>
-              <a:defRPr sz="2600" b="0">
-                <a:solidFill>
-                  <a:srgbClr val="27333D"/>
-                </a:solidFill>
-                <a:latin typeface="微软雅黑"/>
-                <a:ea typeface="微软雅黑"/>
-                <a:cs typeface="微软雅黑"/>
-              </a:defRPr>
-            </a:pPr>
-            <a:r>
-              <a:rPr sz="2600" b="0">
-                <a:solidFill>
-                  <a:srgbClr val="27333D"/>
-                </a:solidFill>
-                <a:latin typeface="微软雅黑"/>
-                <a:ea typeface="微软雅黑"/>
-                <a:cs typeface="微软雅黑"/>
-              </a:rPr>
-              <a:t>工作流 trace</a:t>
-            </a:r>
-          </a:p>
-        </p:txBody>
-      </p:sp>
-      <p:sp>
-        <p:nvSpPr>
-          <p:cNvPr id="13" name="existing">
-            <a:extLst xmlns:a="http://schemas.openxmlformats.org/drawingml/2006/main">
-              <a:ext uri="{FF2B5EF4-FFF2-40B4-BE49-F238E27FC236}">
-                <a16:creationId xmlns:a16="http://schemas.microsoft.com/office/drawing/2014/main" id="{FC2B6FE2-A4B4-41E5-918D-7567031E25F5}"/>
-              </a:ext>
-            </a:extLst>
-          </p:cNvPr>
-          <p:cNvSpPr>
-            <a:spLocks xmlns:a="http://schemas.openxmlformats.org/drawingml/2006/main" noGrp="1"/>
-          </p:cNvSpPr>
-          <p:nvPr/>
-        </p:nvSpPr>
-        <p:spPr>
-          <a:xfrm xmlns:a="http://schemas.openxmlformats.org/drawingml/2006/main">
-            <a:off x="7400925" y="5086350"/>
-            <a:ext cx="4095750" cy="914400"/>
-          </a:xfrm>
-          <a:prstGeom xmlns:a="http://schemas.openxmlformats.org/drawingml/2006/main" prst="rect">
-            <a:avLst/>
-          </a:prstGeom>
-          <a:noFill xmlns:a="http://schemas.openxmlformats.org/drawingml/2006/main"/>
-          <a:ln xmlns:a="http://schemas.openxmlformats.org/drawingml/2006/main" w="0">
-            <a:noFill/>
-          </a:ln>
-        </p:spPr>
-        <p:txBody>
-          <a:bodyPr xmlns:a="http://schemas.openxmlformats.org/drawingml/2006/main" lIns="0" tIns="0" rIns="0" bIns="0" anchor="t"/>
-          <a:lstStyle xmlns:a="http://schemas.openxmlformats.org/drawingml/2006/main"/>
-          <a:p xmlns:a="http://schemas.openxmlformats.org/drawingml/2006/main">
-            <a:pPr algn="l">
-              <a:lnSpc>
-                <a:spcPct val="118000"/>
-              </a:lnSpc>
-              <a:buNone/>
-              <a:defRPr sz="2200" b="0">
-                <a:solidFill>
-                  <a:srgbClr val="27333D"/>
-                </a:solidFill>
-                <a:latin typeface="微软雅黑"/>
-                <a:ea typeface="微软雅黑"/>
-                <a:cs typeface="微软雅黑"/>
-              </a:defRPr>
-            </a:pPr>
-            <a:r>
-              <a:rPr sz="2200" b="0">
-                <a:solidFill>
-                  <a:srgbClr val="27333D"/>
-                </a:solidFill>
-                <a:latin typeface="微软雅黑"/>
-                <a:ea typeface="微软雅黑"/>
-                <a:cs typeface="微软雅黑"/>
-              </a:rPr>
-              <a:t>使用现有项目材料，</a:t>
-            </a:r>
-          </a:p>
-          <a:p xmlns:a="http://schemas.openxmlformats.org/drawingml/2006/main">
-            <a:pPr algn="l">
-              <a:lnSpc>
-                <a:spcPct val="118000"/>
-              </a:lnSpc>
-              <a:buNone/>
-              <a:defRPr sz="2200" b="0">
-                <a:solidFill>
-                  <a:srgbClr val="27333D"/>
-                </a:solidFill>
-                <a:latin typeface="微软雅黑"/>
-                <a:ea typeface="微软雅黑"/>
-                <a:cs typeface="微软雅黑"/>
-              </a:defRPr>
-            </a:pPr>
-            <a:r>
-              <a:rPr sz="2200" b="0">
-                <a:solidFill>
-                  <a:srgbClr val="27333D"/>
-                </a:solidFill>
-                <a:latin typeface="微软雅黑"/>
-                <a:ea typeface="微软雅黑"/>
-                <a:cs typeface="微软雅黑"/>
-              </a:rPr>
-              <a:t>不新增独立汇报文档。</a:t>
-            </a:r>
-          </a:p>
-        </p:txBody>
-      </p:sp>
-      <p:sp>
-        <p:nvSpPr>
-          <p:cNvPr id="14" name="source">
-            <a:extLst xmlns:a="http://schemas.openxmlformats.org/drawingml/2006/main">
-              <a:ext uri="{FF2B5EF4-FFF2-40B4-BE49-F238E27FC236}">
-                <a16:creationId xmlns:a16="http://schemas.microsoft.com/office/drawing/2014/main" id="{78EFC8DF-E64D-45C8-B948-1AD86B0C70D6}"/>
-              </a:ext>
-            </a:extLst>
-          </p:cNvPr>
-          <p:cNvSpPr>
-            <a:spLocks xmlns:a="http://schemas.openxmlformats.org/drawingml/2006/main" noGrp="1"/>
-          </p:cNvSpPr>
-          <p:nvPr/>
-        </p:nvSpPr>
-        <p:spPr>
-          <a:xfrm xmlns:a="http://schemas.openxmlformats.org/drawingml/2006/main">
-            <a:off x="609600" y="6067425"/>
-            <a:ext cx="10763250" cy="209550"/>
-          </a:xfrm>
-          <a:prstGeom xmlns:a="http://schemas.openxmlformats.org/drawingml/2006/main" prst="rect">
-            <a:avLst/>
-          </a:prstGeom>
-          <a:noFill xmlns:a="http://schemas.openxmlformats.org/drawingml/2006/main"/>
-          <a:ln xmlns:a="http://schemas.openxmlformats.org/drawingml/2006/main" w="0">
-            <a:noFill/>
-          </a:ln>
-        </p:spPr>
-        <p:txBody>
-          <a:bodyPr xmlns:a="http://schemas.openxmlformats.org/drawingml/2006/main" lIns="0" tIns="0" rIns="0" bIns="0" anchor="t"/>
-          <a:lstStyle xmlns:a="http://schemas.openxmlformats.org/drawingml/2006/main"/>
-          <a:p xmlns:a="http://schemas.openxmlformats.org/drawingml/2006/main">
-            <a:pPr algn="l">
-              <a:lnSpc>
-                <a:spcPct val="118000"/>
-              </a:lnSpc>
-              <a:buNone/>
-              <a:defRPr sz="1100" b="0">
-                <a:solidFill>
-                  <a:srgbClr val="66727D"/>
-                </a:solidFill>
-                <a:latin typeface="微软雅黑"/>
-                <a:ea typeface="微软雅黑"/>
-                <a:cs typeface="微软雅黑"/>
-              </a:defRPr>
-            </a:pPr>
-            <a:r>
-              <a:rPr sz="1100" b="0">
-                <a:solidFill>
-                  <a:srgbClr val="66727D"/>
-                </a:solidFill>
-                <a:latin typeface="微软雅黑"/>
-                <a:ea typeface="微软雅黑"/>
-                <a:cs typeface="微软雅黑"/>
-              </a:rPr>
-              <a:t>来源：本课讲义与课程评审模板；课程研究门规范 · 教学构造样例不冒充学生记录</a:t>
             </a:r>
           </a:p>
         </p:txBody>
@@ -11248,35 +9642,55 @@
       </p:grpSpPr>
       <p:sp>
         <p:nvSpPr>
-          <p:cNvPr id="4" name="Text Placeholder 3">
-            <a:extLst xmlns:a="http://schemas.openxmlformats.org/drawingml/2006/main">
-              <a:ext uri="{FF2B5EF4-FFF2-40B4-BE49-F238E27FC236}">
-                <a16:creationId xmlns:a16="http://schemas.microsoft.com/office/drawing/2014/main" id="{4D941B40-7A0A-534E-3563-CA11753C8E3F}"/>
-              </a:ext>
-            </a:extLst>
-          </p:cNvPr>
-          <p:cNvSpPr>
-            <a:spLocks xmlns:a="http://schemas.openxmlformats.org/drawingml/2006/main" noGrp="1"/>
-          </p:cNvSpPr>
-          <p:nvPr>
-            <p:ph type="body" idx="14"/>
-          </p:nvPr>
-        </p:nvSpPr>
-        <p:spPr>
-          <a:xfrm xmlns:a="http://schemas.openxmlformats.org/drawingml/2006/main">
-            <a:off x="1028700" y="57150"/>
-            <a:ext cx="10668000" cy="571500"/>
-          </a:xfrm>
-        </p:spPr>
-        <p:txBody>
-          <a:bodyPr xmlns:a="http://schemas.openxmlformats.org/drawingml/2006/main" lIns="0" tIns="0" rIns="0" bIns="0" anchor="ctr"/>
-          <a:lstStyle xmlns:a="http://schemas.openxmlformats.org/drawingml/2006/main"/>
+          <p:cNvPr id="7" name="judgment-title">
+            <a:extLst xmlns:a="http://schemas.openxmlformats.org/drawingml/2006/main">
+              <a:ext uri="{FF2B5EF4-FFF2-40B4-BE49-F238E27FC236}">
+                <a16:creationId xmlns:a16="http://schemas.microsoft.com/office/drawing/2014/main" id="{D538EC21-1892-4E71-B421-04FD7178BF64}"/>
+              </a:ext>
+            </a:extLst>
+          </p:cNvPr>
+          <p:cNvSpPr>
+            <a:spLocks xmlns:a="http://schemas.openxmlformats.org/drawingml/2006/main" noGrp="1"/>
+          </p:cNvSpPr>
+          <p:nvPr/>
+        </p:nvSpPr>
+        <p:spPr>
+          <a:xfrm xmlns:a="http://schemas.openxmlformats.org/drawingml/2006/main">
+            <a:off x="1028700" y="76200"/>
+            <a:ext cx="10687050" cy="514350"/>
+          </a:xfrm>
+          <a:prstGeom xmlns:a="http://schemas.openxmlformats.org/drawingml/2006/main" prst="rect">
+            <a:avLst/>
+          </a:prstGeom>
+          <a:noFill xmlns:a="http://schemas.openxmlformats.org/drawingml/2006/main"/>
+          <a:ln xmlns:a="http://schemas.openxmlformats.org/drawingml/2006/main" w="0">
+            <a:noFill/>
+          </a:ln>
+        </p:spPr>
+        <p:txBody>
+          <a:bodyPr xmlns:a="http://schemas.openxmlformats.org/drawingml/2006/main" lIns="0" tIns="0" rIns="0" bIns="0" anchor="t"/>
+          <a:lstStyle xmlns:a="http://schemas.openxmlformats.org/drawingml/2006/main">
+            <a:defPPr algn="l">
+              <a:defRPr sz="3000" b="1">
+                <a:solidFill>
+                  <a:srgbClr val="FFFFFF"/>
+                </a:solidFill>
+                <a:latin typeface="微软雅黑"/>
+                <a:ea typeface="微软雅黑"/>
+                <a:cs typeface="微软雅黑"/>
+              </a:defRPr>
+            </a:defPPr>
+          </a:lstStyle>
           <a:p xmlns:a="http://schemas.openxmlformats.org/drawingml/2006/main">
             <a:pPr algn="l">
-              <a:lnSpc>
-                <a:spcPct val="118000"/>
-              </a:lnSpc>
-              <a:buNone/>
+              <a:defRPr sz="3000" b="1">
+                <a:solidFill>
+                  <a:srgbClr val="FFFFFF"/>
+                </a:solidFill>
+                <a:latin typeface="微软雅黑"/>
+                <a:ea typeface="微软雅黑"/>
+                <a:cs typeface="微软雅黑"/>
+              </a:defRPr>
             </a:pPr>
             <a:r>
               <a:rPr sz="3000" b="1">
@@ -11287,272 +9701,406 @@
                 <a:ea typeface="微软雅黑"/>
                 <a:cs typeface="微软雅黑"/>
               </a:rPr>
-              <a:t>给三处错误排优先级</a:t>
-            </a:r>
-            <a:endParaRPr/>
-          </a:p>
-        </p:txBody>
-      </p:sp>
-      <p:sp>
-        <p:nvSpPr>
-          <p:cNvPr id="5" name="Slide Number Placeholder 4">
-            <a:extLst xmlns:a="http://schemas.openxmlformats.org/drawingml/2006/main">
-              <a:ext uri="{FF2B5EF4-FFF2-40B4-BE49-F238E27FC236}">
-                <a16:creationId xmlns:a16="http://schemas.microsoft.com/office/drawing/2014/main" id="{EBA5909F-738E-F60C-BE8C-B3F1D94548E5}"/>
-              </a:ext>
-            </a:extLst>
-          </p:cNvPr>
-          <p:cNvSpPr>
-            <a:spLocks xmlns:a="http://schemas.openxmlformats.org/drawingml/2006/main" noGrp="1"/>
-          </p:cNvSpPr>
-          <p:nvPr>
-            <p:ph type="sldNum" idx="10"/>
-          </p:nvPr>
-        </p:nvSpPr>
-        <p:spPr/>
-        <p:txBody>
-          <a:bodyPr xmlns:a="http://schemas.openxmlformats.org/drawingml/2006/main"/>
-          <a:lstStyle xmlns:a="http://schemas.openxmlformats.org/drawingml/2006/main"/>
-          <a:p xmlns:a="http://schemas.openxmlformats.org/drawingml/2006/main">
-            <a:fld id="{EFD6AB9A-5F9E-5F59-51AB-3C8734130965}" type="slidenum">
+              <a:t>哪条评审应先处理</a:t>
+            </a:r>
+          </a:p>
+        </p:txBody>
+      </p:sp>
+      <p:sp>
+        <p:nvSpPr>
+          <p:cNvPr id="2" name="judgment-body-0">
+            <a:extLst xmlns:a="http://schemas.openxmlformats.org/drawingml/2006/main">
+              <a:ext uri="{FF2B5EF4-FFF2-40B4-BE49-F238E27FC236}">
+                <a16:creationId xmlns:a16="http://schemas.microsoft.com/office/drawing/2014/main" id="{694124DB-5EAE-4CF7-A816-C3DF7C6FEBC4}"/>
+              </a:ext>
+            </a:extLst>
+          </p:cNvPr>
+          <p:cNvSpPr>
+            <a:spLocks xmlns:a="http://schemas.openxmlformats.org/drawingml/2006/main" noGrp="1"/>
+          </p:cNvSpPr>
+          <p:nvPr/>
+        </p:nvSpPr>
+        <p:spPr>
+          <a:xfrm xmlns:a="http://schemas.openxmlformats.org/drawingml/2006/main">
+            <a:off x="666750" y="1066800"/>
+            <a:ext cx="10858500" cy="1009650"/>
+          </a:xfrm>
+          <a:prstGeom xmlns:a="http://schemas.openxmlformats.org/drawingml/2006/main" prst="rect">
+            <a:avLst/>
+          </a:prstGeom>
+          <a:noFill xmlns:a="http://schemas.openxmlformats.org/drawingml/2006/main"/>
+          <a:ln xmlns:a="http://schemas.openxmlformats.org/drawingml/2006/main" w="0">
+            <a:noFill/>
+          </a:ln>
+        </p:spPr>
+        <p:txBody>
+          <a:bodyPr xmlns:a="http://schemas.openxmlformats.org/drawingml/2006/main" lIns="0" tIns="0" rIns="0" bIns="0" anchor="t"/>
+          <a:lstStyle xmlns:a="http://schemas.openxmlformats.org/drawingml/2006/main">
+            <a:defPPr algn="l">
+              <a:defRPr sz="2400" b="0">
+                <a:solidFill>
+                  <a:srgbClr val="263746"/>
+                </a:solidFill>
+                <a:latin typeface="微软雅黑"/>
+                <a:ea typeface="微软雅黑"/>
+                <a:cs typeface="微软雅黑"/>
+              </a:defRPr>
+            </a:defPPr>
+          </a:lstStyle>
+          <a:p xmlns:a="http://schemas.openxmlformats.org/drawingml/2006/main">
+            <a:pPr algn="l">
+              <a:defRPr sz="2400" b="0">
+                <a:solidFill>
+                  <a:srgbClr val="263746"/>
+                </a:solidFill>
+                <a:latin typeface="微软雅黑"/>
+                <a:ea typeface="微软雅黑"/>
+                <a:cs typeface="微软雅黑"/>
+              </a:defRPr>
+            </a:pPr>
+            <a:r>
+              <a:rPr sz="2400" b="0">
+                <a:solidFill>
+                  <a:srgbClr val="263746"/>
+                </a:solidFill>
+                <a:latin typeface="微软雅黑"/>
+                <a:ea typeface="微软雅黑"/>
+                <a:cs typeface="微软雅黑"/>
+              </a:rPr>
+              <a:t>正文：8 篇独立论文证明机制</a:t>
+            </a:r>
+          </a:p>
+          <a:p xmlns:a="http://schemas.openxmlformats.org/drawingml/2006/main">
+            <a:pPr algn="l">
+              <a:defRPr sz="2400" b="0">
+                <a:solidFill>
+                  <a:srgbClr val="263746"/>
+                </a:solidFill>
+                <a:latin typeface="微软雅黑"/>
+                <a:ea typeface="微软雅黑"/>
+                <a:cs typeface="微软雅黑"/>
+              </a:defRPr>
+            </a:pPr>
+            <a:r>
+              <a:rPr sz="2400" b="0">
+                <a:solidFill>
+                  <a:srgbClr val="263746"/>
+                </a:solidFill>
+                <a:latin typeface="微软雅黑"/>
+                <a:ea typeface="微软雅黑"/>
+                <a:cs typeface="微软雅黑"/>
+              </a:rPr>
+              <a:t>实际：3 个文本、8 条条件；确定性回放</a:t>
+            </a:r>
+          </a:p>
+        </p:txBody>
+      </p:sp>
+      <p:sp>
+        <p:nvSpPr>
+          <p:cNvPr id="3" name="judgment-body-1">
+            <a:extLst xmlns:a="http://schemas.openxmlformats.org/drawingml/2006/main">
+              <a:ext uri="{FF2B5EF4-FFF2-40B4-BE49-F238E27FC236}">
+                <a16:creationId xmlns:a16="http://schemas.microsoft.com/office/drawing/2014/main" id="{BC682C77-FB86-4B01-A788-46821A78F8B1}"/>
+              </a:ext>
+            </a:extLst>
+          </p:cNvPr>
+          <p:cNvSpPr>
+            <a:spLocks xmlns:a="http://schemas.openxmlformats.org/drawingml/2006/main" noGrp="1"/>
+          </p:cNvSpPr>
+          <p:nvPr/>
+        </p:nvSpPr>
+        <p:spPr>
+          <a:xfrm xmlns:a="http://schemas.openxmlformats.org/drawingml/2006/main">
+            <a:off x="666750" y="2238375"/>
+            <a:ext cx="10858500" cy="2076450"/>
+          </a:xfrm>
+          <a:prstGeom xmlns:a="http://schemas.openxmlformats.org/drawingml/2006/main" prst="rect">
+            <a:avLst/>
+          </a:prstGeom>
+          <a:noFill xmlns:a="http://schemas.openxmlformats.org/drawingml/2006/main"/>
+          <a:ln xmlns:a="http://schemas.openxmlformats.org/drawingml/2006/main" w="0">
+            <a:noFill/>
+          </a:ln>
+        </p:spPr>
+        <p:txBody>
+          <a:bodyPr xmlns:a="http://schemas.openxmlformats.org/drawingml/2006/main" lIns="0" tIns="0" rIns="0" bIns="0" anchor="t"/>
+          <a:lstStyle xmlns:a="http://schemas.openxmlformats.org/drawingml/2006/main">
+            <a:defPPr algn="l">
+              <a:defRPr sz="2400" b="0">
+                <a:solidFill>
+                  <a:srgbClr val="263746"/>
+                </a:solidFill>
+                <a:latin typeface="微软雅黑"/>
+                <a:ea typeface="微软雅黑"/>
+                <a:cs typeface="微软雅黑"/>
+              </a:defRPr>
+            </a:defPPr>
+          </a:lstStyle>
+          <a:p xmlns:a="http://schemas.openxmlformats.org/drawingml/2006/main">
+            <a:pPr algn="l">
+              <a:defRPr sz="2400" b="0">
+                <a:solidFill>
+                  <a:srgbClr val="263746"/>
+                </a:solidFill>
+                <a:latin typeface="微软雅黑"/>
+                <a:ea typeface="微软雅黑"/>
+                <a:cs typeface="微软雅黑"/>
+              </a:defRPr>
+            </a:pPr>
+            <a:r>
+              <a:rPr sz="2400" b="0">
+                <a:solidFill>
+                  <a:srgbClr val="263746"/>
+                </a:solidFill>
+                <a:latin typeface="微软雅黑"/>
+                <a:ea typeface="微软雅黑"/>
+                <a:cs typeface="微软雅黑"/>
+              </a:rPr>
+              <a:t>A｜修正单位与机制结论</a:t>
+            </a:r>
+          </a:p>
+          <a:p xmlns:a="http://schemas.openxmlformats.org/drawingml/2006/main">
+            <a:pPr algn="l">
+              <a:defRPr sz="2400" b="0">
+                <a:solidFill>
+                  <a:srgbClr val="263746"/>
+                </a:solidFill>
+                <a:latin typeface="微软雅黑"/>
+                <a:ea typeface="微软雅黑"/>
+                <a:cs typeface="微软雅黑"/>
+              </a:defRPr>
+            </a:pPr>
+            <a:r>
+              <a:rPr sz="2400" b="0">
+                <a:solidFill>
+                  <a:srgbClr val="263746"/>
+                </a:solidFill>
+                <a:latin typeface="微软雅黑"/>
+                <a:ea typeface="微软雅黑"/>
+                <a:cs typeface="微软雅黑"/>
+              </a:rPr>
+              <a:t>B｜重画配色</a:t>
+            </a:r>
+          </a:p>
+          <a:p xmlns:a="http://schemas.openxmlformats.org/drawingml/2006/main">
+            <a:pPr algn="l">
+              <a:defRPr sz="2400" b="0">
+                <a:solidFill>
+                  <a:srgbClr val="263746"/>
+                </a:solidFill>
+                <a:latin typeface="微软雅黑"/>
+                <a:ea typeface="微软雅黑"/>
+                <a:cs typeface="微软雅黑"/>
+              </a:defRPr>
+            </a:pPr>
+            <a:r>
+              <a:rPr sz="2400" b="0">
+                <a:solidFill>
+                  <a:srgbClr val="263746"/>
+                </a:solidFill>
+                <a:latin typeface="微软雅黑"/>
+                <a:ea typeface="微软雅黑"/>
+                <a:cs typeface="微软雅黑"/>
+              </a:rPr>
+              <a:t>C｜无随机种子，因此不可复现</a:t>
+            </a:r>
+          </a:p>
+        </p:txBody>
+      </p:sp>
+      <p:sp>
+        <p:nvSpPr>
+          <p:cNvPr id="4" name="judgment-body-2">
+            <a:extLst xmlns:a="http://schemas.openxmlformats.org/drawingml/2006/main">
+              <a:ext uri="{FF2B5EF4-FFF2-40B4-BE49-F238E27FC236}">
+                <a16:creationId xmlns:a16="http://schemas.microsoft.com/office/drawing/2014/main" id="{07B98DA1-20CD-4731-AC5A-A5D0A9971450}"/>
+              </a:ext>
+            </a:extLst>
+          </p:cNvPr>
+          <p:cNvSpPr>
+            <a:spLocks xmlns:a="http://schemas.openxmlformats.org/drawingml/2006/main" noGrp="1"/>
+          </p:cNvSpPr>
+          <p:nvPr/>
+        </p:nvSpPr>
+        <p:spPr>
+          <a:xfrm xmlns:a="http://schemas.openxmlformats.org/drawingml/2006/main">
+            <a:off x="666750" y="4495800"/>
+            <a:ext cx="10858500" cy="1409700"/>
+          </a:xfrm>
+          <a:prstGeom xmlns:a="http://schemas.openxmlformats.org/drawingml/2006/main" prst="rect">
+            <a:avLst/>
+          </a:prstGeom>
+          <a:noFill xmlns:a="http://schemas.openxmlformats.org/drawingml/2006/main"/>
+          <a:ln xmlns:a="http://schemas.openxmlformats.org/drawingml/2006/main" w="0">
+            <a:noFill/>
+          </a:ln>
+        </p:spPr>
+        <p:txBody>
+          <a:bodyPr xmlns:a="http://schemas.openxmlformats.org/drawingml/2006/main" lIns="0" tIns="0" rIns="0" bIns="0" anchor="t"/>
+          <a:lstStyle xmlns:a="http://schemas.openxmlformats.org/drawingml/2006/main">
+            <a:defPPr algn="l">
+              <a:defRPr sz="2200" b="0">
+                <a:solidFill>
+                  <a:srgbClr val="1F4D78"/>
+                </a:solidFill>
+                <a:latin typeface="微软雅黑"/>
+                <a:ea typeface="微软雅黑"/>
+                <a:cs typeface="微软雅黑"/>
+              </a:defRPr>
+            </a:defPPr>
+          </a:lstStyle>
+          <a:p xmlns:a="http://schemas.openxmlformats.org/drawingml/2006/main">
+            <a:pPr algn="l">
+              <a:defRPr sz="2200" b="0">
+                <a:solidFill>
+                  <a:srgbClr val="1F4D78"/>
+                </a:solidFill>
+                <a:latin typeface="微软雅黑"/>
+                <a:ea typeface="微软雅黑"/>
+                <a:cs typeface="微软雅黑"/>
+              </a:defRPr>
+            </a:pPr>
+            <a:r>
+              <a:rPr sz="2200" b="0">
+                <a:solidFill>
+                  <a:srgbClr val="1F4D78"/>
+                </a:solidFill>
+                <a:latin typeface="微软雅黑"/>
+                <a:ea typeface="微软雅黑"/>
+                <a:cs typeface="微软雅黑"/>
+              </a:rPr>
+              <a:t>逐项定位事实、影响与最小修订；可澄清或保留异议，但须有证据。</a:t>
+            </a:r>
+          </a:p>
+        </p:txBody>
+      </p:sp>
+      <p:sp>
+        <p:nvSpPr>
+          <p:cNvPr id="5" name="judgment-source">
+            <a:extLst xmlns:a="http://schemas.openxmlformats.org/drawingml/2006/main">
+              <a:ext uri="{FF2B5EF4-FFF2-40B4-BE49-F238E27FC236}">
+                <a16:creationId xmlns:a16="http://schemas.microsoft.com/office/drawing/2014/main" id="{8E551F6F-B802-415C-84E7-24B36B13EFEC}"/>
+              </a:ext>
+            </a:extLst>
+          </p:cNvPr>
+          <p:cNvSpPr>
+            <a:spLocks xmlns:a="http://schemas.openxmlformats.org/drawingml/2006/main" noGrp="1"/>
+          </p:cNvSpPr>
+          <p:nvPr/>
+        </p:nvSpPr>
+        <p:spPr>
+          <a:xfrm xmlns:a="http://schemas.openxmlformats.org/drawingml/2006/main">
+            <a:off x="666750" y="6276975"/>
+            <a:ext cx="10572750" cy="209550"/>
+          </a:xfrm>
+          <a:prstGeom xmlns:a="http://schemas.openxmlformats.org/drawingml/2006/main" prst="rect">
+            <a:avLst/>
+          </a:prstGeom>
+          <a:noFill xmlns:a="http://schemas.openxmlformats.org/drawingml/2006/main"/>
+          <a:ln xmlns:a="http://schemas.openxmlformats.org/drawingml/2006/main" w="0">
+            <a:noFill/>
+          </a:ln>
+        </p:spPr>
+        <p:txBody>
+          <a:bodyPr xmlns:a="http://schemas.openxmlformats.org/drawingml/2006/main" lIns="0" tIns="0" rIns="0" bIns="0" anchor="t"/>
+          <a:lstStyle xmlns:a="http://schemas.openxmlformats.org/drawingml/2006/main">
+            <a:defPPr algn="l">
+              <a:defRPr sz="1100" b="0">
+                <a:solidFill>
+                  <a:srgbClr val="667684"/>
+                </a:solidFill>
+                <a:latin typeface="微软雅黑"/>
+                <a:ea typeface="微软雅黑"/>
+                <a:cs typeface="微软雅黑"/>
+              </a:defRPr>
+            </a:defPPr>
+          </a:lstStyle>
+          <a:p xmlns:a="http://schemas.openxmlformats.org/drawingml/2006/main">
+            <a:pPr algn="l">
+              <a:defRPr sz="1100" b="0">
+                <a:solidFill>
+                  <a:srgbClr val="667684"/>
+                </a:solidFill>
+                <a:latin typeface="微软雅黑"/>
+                <a:ea typeface="微软雅黑"/>
+                <a:cs typeface="微软雅黑"/>
+              </a:defRPr>
+            </a:pPr>
+            <a:r>
+              <a:rPr sz="1100" b="0">
+                <a:solidFill>
+                  <a:srgbClr val="667684"/>
+                </a:solidFill>
+                <a:latin typeface="微软雅黑"/>
+                <a:ea typeface="微软雅黑"/>
+                <a:cs typeface="微软雅黑"/>
+              </a:rPr>
+              <a:t>来源：本课判断任务与讲义；构造材料及真实来源按材料包标识</a:t>
+            </a:r>
+          </a:p>
+        </p:txBody>
+      </p:sp>
+      <p:sp>
+        <p:nvSpPr>
+          <p:cNvPr id="6" name="judgment-page">
+            <a:extLst xmlns:a="http://schemas.openxmlformats.org/drawingml/2006/main">
+              <a:ext uri="{FF2B5EF4-FFF2-40B4-BE49-F238E27FC236}">
+                <a16:creationId xmlns:a16="http://schemas.microsoft.com/office/drawing/2014/main" id="{7467979A-7285-4C6C-81CD-B5970E507B1C}"/>
+              </a:ext>
+            </a:extLst>
+          </p:cNvPr>
+          <p:cNvSpPr>
+            <a:spLocks xmlns:a="http://schemas.openxmlformats.org/drawingml/2006/main" noGrp="1"/>
+          </p:cNvSpPr>
+          <p:nvPr/>
+        </p:nvSpPr>
+        <p:spPr>
+          <a:xfrm xmlns:a="http://schemas.openxmlformats.org/drawingml/2006/main">
+            <a:off x="11715750" y="6562725"/>
+            <a:ext cx="238125" cy="171450"/>
+          </a:xfrm>
+          <a:prstGeom xmlns:a="http://schemas.openxmlformats.org/drawingml/2006/main" prst="rect">
+            <a:avLst/>
+          </a:prstGeom>
+          <a:noFill xmlns:a="http://schemas.openxmlformats.org/drawingml/2006/main"/>
+          <a:ln xmlns:a="http://schemas.openxmlformats.org/drawingml/2006/main" w="0">
+            <a:noFill/>
+          </a:ln>
+        </p:spPr>
+        <p:txBody>
+          <a:bodyPr xmlns:a="http://schemas.openxmlformats.org/drawingml/2006/main" lIns="0" tIns="0" rIns="0" bIns="0" anchor="t"/>
+          <a:lstStyle xmlns:a="http://schemas.openxmlformats.org/drawingml/2006/main">
+            <a:defPPr algn="l">
+              <a:defRPr sz="900" b="0">
+                <a:solidFill>
+                  <a:srgbClr val="A5A5A5"/>
+                </a:solidFill>
+                <a:latin typeface="微软雅黑"/>
+                <a:ea typeface="微软雅黑"/>
+                <a:cs typeface="微软雅黑"/>
+              </a:defRPr>
+            </a:defPPr>
+          </a:lstStyle>
+          <a:p xmlns:a="http://schemas.openxmlformats.org/drawingml/2006/main">
+            <a:pPr algn="l">
+              <a:defRPr sz="900" b="0">
+                <a:solidFill>
+                  <a:srgbClr val="A5A5A5"/>
+                </a:solidFill>
+                <a:latin typeface="微软雅黑"/>
+                <a:ea typeface="微软雅黑"/>
+                <a:cs typeface="微软雅黑"/>
+              </a:defRPr>
+            </a:pPr>
+            <a:r>
+              <a:rPr sz="900" b="0">
+                <a:solidFill>
+                  <a:srgbClr val="A5A5A5"/>
+                </a:solidFill>
+                <a:latin typeface="微软雅黑"/>
+                <a:ea typeface="微软雅黑"/>
+                <a:cs typeface="微软雅黑"/>
+              </a:rPr>
               <a:t>4</a:t>
-            </a:fld>
-            <a:endParaRPr/>
-          </a:p>
-        </p:txBody>
-      </p:sp>
-      <p:sp>
-        <p:nvSpPr>
-          <p:cNvPr id="6" name="content-201">
-            <a:extLst xmlns:a="http://schemas.openxmlformats.org/drawingml/2006/main">
-              <a:ext uri="{FF2B5EF4-FFF2-40B4-BE49-F238E27FC236}">
-                <a16:creationId xmlns:a16="http://schemas.microsoft.com/office/drawing/2014/main" id="{297CD03F-BB99-4F45-8989-ECA0FA81D8FC}"/>
-              </a:ext>
-            </a:extLst>
-          </p:cNvPr>
-          <p:cNvSpPr>
-            <a:spLocks xmlns:a="http://schemas.openxmlformats.org/drawingml/2006/main" noGrp="1"/>
-          </p:cNvSpPr>
-          <p:nvPr/>
-        </p:nvSpPr>
-        <p:spPr>
-          <a:xfrm xmlns:a="http://schemas.openxmlformats.org/drawingml/2006/main">
-            <a:off x="609600" y="1571625"/>
-            <a:ext cx="10972800" cy="432435"/>
-          </a:xfrm>
-          <a:prstGeom xmlns:a="http://schemas.openxmlformats.org/drawingml/2006/main" prst="rect">
-            <a:avLst/>
-          </a:prstGeom>
-          <a:noFill xmlns:a="http://schemas.openxmlformats.org/drawingml/2006/main"/>
-          <a:ln xmlns:a="http://schemas.openxmlformats.org/drawingml/2006/main" w="0">
-            <a:noFill/>
-          </a:ln>
-        </p:spPr>
-        <p:txBody>
-          <a:bodyPr xmlns:a="http://schemas.openxmlformats.org/drawingml/2006/main" lIns="0" tIns="0" rIns="0" bIns="0" anchor="t"/>
-          <a:lstStyle xmlns:a="http://schemas.openxmlformats.org/drawingml/2006/main"/>
-          <a:p xmlns:a="http://schemas.openxmlformats.org/drawingml/2006/main">
-            <a:pPr algn="l">
-              <a:lnSpc>
-                <a:spcPct val="118000"/>
-              </a:lnSpc>
-              <a:buNone/>
-              <a:defRPr sz="2400" b="0">
-                <a:solidFill>
-                  <a:srgbClr val="27333D"/>
-                </a:solidFill>
-                <a:latin typeface="微软雅黑"/>
-                <a:ea typeface="微软雅黑"/>
-                <a:cs typeface="微软雅黑"/>
-              </a:defRPr>
-            </a:pPr>
-            <a:r>
-              <a:rPr sz="2400" b="0">
-                <a:solidFill>
-                  <a:srgbClr val="27333D"/>
-                </a:solidFill>
-                <a:latin typeface="微软雅黑"/>
-                <a:ea typeface="微软雅黑"/>
-                <a:cs typeface="微软雅黑"/>
-              </a:rPr>
-              <a:t>D1：“证明机制，对所有文本有效，stable。”</a:t>
-            </a:r>
-          </a:p>
-        </p:txBody>
-      </p:sp>
-      <p:sp>
-        <p:nvSpPr>
-          <p:cNvPr id="7" name="content-202">
-            <a:extLst xmlns:a="http://schemas.openxmlformats.org/drawingml/2006/main">
-              <a:ext uri="{FF2B5EF4-FFF2-40B4-BE49-F238E27FC236}">
-                <a16:creationId xmlns:a16="http://schemas.microsoft.com/office/drawing/2014/main" id="{12B97342-63B0-4BDE-ACE2-5B9B1A029476}"/>
-              </a:ext>
-            </a:extLst>
-          </p:cNvPr>
-          <p:cNvSpPr>
-            <a:spLocks xmlns:a="http://schemas.openxmlformats.org/drawingml/2006/main" noGrp="1"/>
-          </p:cNvSpPr>
-          <p:nvPr/>
-        </p:nvSpPr>
-        <p:spPr>
-          <a:xfrm xmlns:a="http://schemas.openxmlformats.org/drawingml/2006/main">
-            <a:off x="609600" y="2261235"/>
-            <a:ext cx="10972800" cy="432435"/>
-          </a:xfrm>
-          <a:prstGeom xmlns:a="http://schemas.openxmlformats.org/drawingml/2006/main" prst="rect">
-            <a:avLst/>
-          </a:prstGeom>
-          <a:noFill xmlns:a="http://schemas.openxmlformats.org/drawingml/2006/main"/>
-          <a:ln xmlns:a="http://schemas.openxmlformats.org/drawingml/2006/main" w="0">
-            <a:noFill/>
-          </a:ln>
-        </p:spPr>
-        <p:txBody>
-          <a:bodyPr xmlns:a="http://schemas.openxmlformats.org/drawingml/2006/main" lIns="0" tIns="0" rIns="0" bIns="0" anchor="t"/>
-          <a:lstStyle xmlns:a="http://schemas.openxmlformats.org/drawingml/2006/main"/>
-          <a:p xmlns:a="http://schemas.openxmlformats.org/drawingml/2006/main">
-            <a:pPr algn="l">
-              <a:lnSpc>
-                <a:spcPct val="118000"/>
-              </a:lnSpc>
-              <a:buNone/>
-              <a:defRPr sz="2400" b="0">
-                <a:solidFill>
-                  <a:srgbClr val="27333D"/>
-                </a:solidFill>
-                <a:latin typeface="微软雅黑"/>
-                <a:ea typeface="微软雅黑"/>
-                <a:cs typeface="微软雅黑"/>
-              </a:defRPr>
-            </a:pPr>
-            <a:r>
-              <a:rPr sz="2400" b="0">
-                <a:solidFill>
-                  <a:srgbClr val="27333D"/>
-                </a:solidFill>
-                <a:latin typeface="微软雅黑"/>
-                <a:ea typeface="微软雅黑"/>
-                <a:cs typeface="微软雅黑"/>
-              </a:rPr>
-              <a:t>D2：只给百分比，没有分母和原始记录位置。</a:t>
-            </a:r>
-          </a:p>
-        </p:txBody>
-      </p:sp>
-      <p:sp>
-        <p:nvSpPr>
-          <p:cNvPr id="8" name="content-203">
-            <a:extLst xmlns:a="http://schemas.openxmlformats.org/drawingml/2006/main">
-              <a:ext uri="{FF2B5EF4-FFF2-40B4-BE49-F238E27FC236}">
-                <a16:creationId xmlns:a16="http://schemas.microsoft.com/office/drawing/2014/main" id="{50DA49D8-EEC1-4F97-AA82-F5A1E621CF66}"/>
-              </a:ext>
-            </a:extLst>
-          </p:cNvPr>
-          <p:cNvSpPr>
-            <a:spLocks xmlns:a="http://schemas.openxmlformats.org/drawingml/2006/main" noGrp="1"/>
-          </p:cNvSpPr>
-          <p:nvPr/>
-        </p:nvSpPr>
-        <p:spPr>
-          <a:xfrm xmlns:a="http://schemas.openxmlformats.org/drawingml/2006/main">
-            <a:off x="609600" y="2950845"/>
-            <a:ext cx="10972800" cy="432435"/>
-          </a:xfrm>
-          <a:prstGeom xmlns:a="http://schemas.openxmlformats.org/drawingml/2006/main" prst="rect">
-            <a:avLst/>
-          </a:prstGeom>
-          <a:noFill xmlns:a="http://schemas.openxmlformats.org/drawingml/2006/main"/>
-          <a:ln xmlns:a="http://schemas.openxmlformats.org/drawingml/2006/main" w="0">
-            <a:noFill/>
-          </a:ln>
-        </p:spPr>
-        <p:txBody>
-          <a:bodyPr xmlns:a="http://schemas.openxmlformats.org/drawingml/2006/main" lIns="0" tIns="0" rIns="0" bIns="0" anchor="t"/>
-          <a:lstStyle xmlns:a="http://schemas.openxmlformats.org/drawingml/2006/main"/>
-          <a:p xmlns:a="http://schemas.openxmlformats.org/drawingml/2006/main">
-            <a:pPr algn="l">
-              <a:lnSpc>
-                <a:spcPct val="118000"/>
-              </a:lnSpc>
-              <a:buNone/>
-              <a:defRPr sz="2400" b="0">
-                <a:solidFill>
-                  <a:srgbClr val="27333D"/>
-                </a:solidFill>
-                <a:latin typeface="微软雅黑"/>
-                <a:ea typeface="微软雅黑"/>
-                <a:cs typeface="微软雅黑"/>
-              </a:defRPr>
-            </a:pPr>
-            <a:r>
-              <a:rPr sz="2400" b="0">
-                <a:solidFill>
-                  <a:srgbClr val="27333D"/>
-                </a:solidFill>
-                <a:latin typeface="微软雅黑"/>
-                <a:ea typeface="微软雅黑"/>
-                <a:cs typeface="微软雅黑"/>
-              </a:rPr>
-              <a:t>图1：“组一/组二”，指标和范围不明。</a:t>
-            </a:r>
-          </a:p>
-        </p:txBody>
-      </p:sp>
-      <p:sp>
-        <p:nvSpPr>
-          <p:cNvPr id="9" name="content-204">
-            <a:extLst xmlns:a="http://schemas.openxmlformats.org/drawingml/2006/main">
-              <a:ext uri="{FF2B5EF4-FFF2-40B4-BE49-F238E27FC236}">
-                <a16:creationId xmlns:a16="http://schemas.microsoft.com/office/drawing/2014/main" id="{B1419711-54CD-4FFA-A60C-4C9AADC7B885}"/>
-              </a:ext>
-            </a:extLst>
-          </p:cNvPr>
-          <p:cNvSpPr>
-            <a:spLocks xmlns:a="http://schemas.openxmlformats.org/drawingml/2006/main" noGrp="1"/>
-          </p:cNvSpPr>
-          <p:nvPr/>
-        </p:nvSpPr>
-        <p:spPr>
-          <a:xfrm xmlns:a="http://schemas.openxmlformats.org/drawingml/2006/main">
-            <a:off x="609600" y="3640455"/>
-            <a:ext cx="10972800" cy="432435"/>
-          </a:xfrm>
-          <a:prstGeom xmlns:a="http://schemas.openxmlformats.org/drawingml/2006/main" prst="rect">
-            <a:avLst/>
-          </a:prstGeom>
-          <a:noFill xmlns:a="http://schemas.openxmlformats.org/drawingml/2006/main"/>
-          <a:ln xmlns:a="http://schemas.openxmlformats.org/drawingml/2006/main" w="0">
-            <a:noFill/>
-          </a:ln>
-        </p:spPr>
-        <p:txBody>
-          <a:bodyPr xmlns:a="http://schemas.openxmlformats.org/drawingml/2006/main" lIns="0" tIns="0" rIns="0" bIns="0" anchor="t"/>
-          <a:lstStyle xmlns:a="http://schemas.openxmlformats.org/drawingml/2006/main"/>
-          <a:p xmlns:a="http://schemas.openxmlformats.org/drawingml/2006/main">
-            <a:pPr algn="l">
-              <a:lnSpc>
-                <a:spcPct val="118000"/>
-              </a:lnSpc>
-              <a:buNone/>
-              <a:defRPr sz="2400" b="0">
-                <a:solidFill>
-                  <a:srgbClr val="1F4D78"/>
-                </a:solidFill>
-                <a:latin typeface="微软雅黑"/>
-                <a:ea typeface="微软雅黑"/>
-                <a:cs typeface="微软雅黑"/>
-              </a:defRPr>
-            </a:pPr>
-            <a:r>
-              <a:rPr sz="2400" b="0">
-                <a:solidFill>
-                  <a:srgbClr val="1F4D78"/>
-                </a:solidFill>
-                <a:latin typeface="微软雅黑"/>
-                <a:ea typeface="微软雅黑"/>
-                <a:cs typeface="微软雅黑"/>
-              </a:rPr>
-              <a:t>先处理结论越界，再补追踪与图表说明。</a:t>
             </a:r>
           </a:p>
         </p:txBody>

</xml_diff>